<commit_message>
add part 1 gitlab
</commit_message>
<xml_diff>
--- a/Part 1 Git/Git-art of source control.pptx
+++ b/Part 1 Git/Git-art of source control.pptx
@@ -5,7 +5,7 @@
     <p:sldMasterId id="2147483660" r:id="rId1"/>
   </p:sldMasterIdLst>
   <p:notesMasterIdLst>
-    <p:notesMasterId r:id="rId38"/>
+    <p:notesMasterId r:id="rId53"/>
   </p:notesMasterIdLst>
   <p:sldIdLst>
     <p:sldId id="256" r:id="rId2"/>
@@ -44,6 +44,21 @@
     <p:sldId id="288" r:id="rId35"/>
     <p:sldId id="290" r:id="rId36"/>
     <p:sldId id="291" r:id="rId37"/>
+    <p:sldId id="292" r:id="rId38"/>
+    <p:sldId id="293" r:id="rId39"/>
+    <p:sldId id="294" r:id="rId40"/>
+    <p:sldId id="295" r:id="rId41"/>
+    <p:sldId id="296" r:id="rId42"/>
+    <p:sldId id="297" r:id="rId43"/>
+    <p:sldId id="298" r:id="rId44"/>
+    <p:sldId id="299" r:id="rId45"/>
+    <p:sldId id="300" r:id="rId46"/>
+    <p:sldId id="301" r:id="rId47"/>
+    <p:sldId id="305" r:id="rId48"/>
+    <p:sldId id="302" r:id="rId49"/>
+    <p:sldId id="303" r:id="rId50"/>
+    <p:sldId id="304" r:id="rId51"/>
+    <p:sldId id="306" r:id="rId52"/>
   </p:sldIdLst>
   <p:sldSz cx="12192000" cy="6858000"/>
   <p:notesSz cx="6858000" cy="9144000"/>
@@ -193,6 +208,29 @@
             <p14:sldId id="291"/>
           </p14:sldIdLst>
         </p14:section>
+        <p14:section name="Gitlab" id="{39944DDF-D3FC-42A6-BC6A-C9F89F4AE70E}">
+          <p14:sldIdLst>
+            <p14:sldId id="292"/>
+            <p14:sldId id="293"/>
+            <p14:sldId id="294"/>
+            <p14:sldId id="295"/>
+            <p14:sldId id="296"/>
+            <p14:sldId id="297"/>
+            <p14:sldId id="298"/>
+            <p14:sldId id="299"/>
+            <p14:sldId id="300"/>
+            <p14:sldId id="301"/>
+            <p14:sldId id="305"/>
+            <p14:sldId id="302"/>
+            <p14:sldId id="303"/>
+            <p14:sldId id="304"/>
+          </p14:sldIdLst>
+        </p14:section>
+        <p14:section name="Hosting" id="{1C028AB8-67AB-4DA3-B6ED-EB3F2B4BAB6A}">
+          <p14:sldIdLst>
+            <p14:sldId id="306"/>
+          </p14:sldIdLst>
+        </p14:section>
       </p14:sectionLst>
     </p:ext>
     <p:ext uri="{EFAFB233-063F-42B5-8137-9DF3F51BA10A}">
@@ -284,7 +322,7 @@
           <a:p>
             <a:fld id="{3004ABFC-3074-413D-B7F9-A3C08E187088}" type="datetimeFigureOut">
               <a:rPr lang="en-ID" smtClean="0"/>
-              <a:t>25/02/2026</a:t>
+              <a:t>26/02/2026</a:t>
             </a:fld>
             <a:endParaRPr lang="en-ID"/>
           </a:p>
@@ -13060,6 +13098,631 @@
 </p:sld>
 </file>
 
+<file path=ppt/slides/slide37.xml><?xml version="1.0" encoding="utf-8"?>
+<p:sld xmlns:a="http://schemas.openxmlformats.org/drawingml/2006/main" xmlns:r="http://schemas.openxmlformats.org/officeDocument/2006/relationships" xmlns:p="http://schemas.openxmlformats.org/presentationml/2006/main">
+  <p:cSld>
+    <p:spTree>
+      <p:nvGrpSpPr>
+        <p:cNvPr id="1" name="">
+          <a:extLst>
+            <a:ext uri="{FF2B5EF4-FFF2-40B4-BE49-F238E27FC236}">
+              <a16:creationId xmlns:a16="http://schemas.microsoft.com/office/drawing/2014/main" id="{477D8A47-0D73-5273-3516-0C765BF0E1EA}"/>
+            </a:ext>
+          </a:extLst>
+        </p:cNvPr>
+        <p:cNvGrpSpPr/>
+        <p:nvPr/>
+      </p:nvGrpSpPr>
+      <p:grpSpPr>
+        <a:xfrm>
+          <a:off x="0" y="0"/>
+          <a:ext cx="0" cy="0"/>
+          <a:chOff x="0" y="0"/>
+          <a:chExt cx="0" cy="0"/>
+        </a:xfrm>
+      </p:grpSpPr>
+      <p:sp>
+        <p:nvSpPr>
+          <p:cNvPr id="2" name="Title 1">
+            <a:extLst>
+              <a:ext uri="{FF2B5EF4-FFF2-40B4-BE49-F238E27FC236}">
+                <a16:creationId xmlns:a16="http://schemas.microsoft.com/office/drawing/2014/main" id="{283C6800-77FC-315A-6CA3-721C2A7A1F75}"/>
+              </a:ext>
+            </a:extLst>
+          </p:cNvPr>
+          <p:cNvSpPr>
+            <a:spLocks noGrp="1"/>
+          </p:cNvSpPr>
+          <p:nvPr>
+            <p:ph type="title"/>
+          </p:nvPr>
+        </p:nvSpPr>
+        <p:spPr/>
+        <p:txBody>
+          <a:bodyPr/>
+          <a:lstStyle/>
+          <a:p>
+            <a:r>
+              <a:rPr lang="en-US" dirty="0"/>
+              <a:t>Gitlab: the online git</a:t>
+            </a:r>
+            <a:endParaRPr lang="en-ID" dirty="0"/>
+          </a:p>
+        </p:txBody>
+      </p:sp>
+      <p:sp>
+        <p:nvSpPr>
+          <p:cNvPr id="3" name="Text Placeholder 2">
+            <a:extLst>
+              <a:ext uri="{FF2B5EF4-FFF2-40B4-BE49-F238E27FC236}">
+                <a16:creationId xmlns:a16="http://schemas.microsoft.com/office/drawing/2014/main" id="{5A6D7F81-D4C6-C8A8-96A5-098B68E137D2}"/>
+              </a:ext>
+            </a:extLst>
+          </p:cNvPr>
+          <p:cNvSpPr>
+            <a:spLocks noGrp="1"/>
+          </p:cNvSpPr>
+          <p:nvPr>
+            <p:ph type="body" idx="1"/>
+          </p:nvPr>
+        </p:nvSpPr>
+        <p:spPr/>
+        <p:txBody>
+          <a:bodyPr/>
+          <a:lstStyle/>
+          <a:p>
+            <a:endParaRPr lang="en-ID" dirty="0"/>
+          </a:p>
+        </p:txBody>
+      </p:sp>
+      <p:sp>
+        <p:nvSpPr>
+          <p:cNvPr id="4" name="Date Placeholder 3">
+            <a:extLst>
+              <a:ext uri="{FF2B5EF4-FFF2-40B4-BE49-F238E27FC236}">
+                <a16:creationId xmlns:a16="http://schemas.microsoft.com/office/drawing/2014/main" id="{2509686A-8672-5401-A4B3-FF34CDBA29C6}"/>
+              </a:ext>
+            </a:extLst>
+          </p:cNvPr>
+          <p:cNvSpPr>
+            <a:spLocks noGrp="1"/>
+          </p:cNvSpPr>
+          <p:nvPr>
+            <p:ph type="dt" sz="half" idx="10"/>
+          </p:nvPr>
+        </p:nvSpPr>
+        <p:spPr/>
+        <p:txBody>
+          <a:bodyPr/>
+          <a:lstStyle/>
+          <a:p>
+            <a:r>
+              <a:rPr lang="en-ID"/>
+              <a:t>27/02/2026</a:t>
+            </a:r>
+          </a:p>
+        </p:txBody>
+      </p:sp>
+      <p:sp>
+        <p:nvSpPr>
+          <p:cNvPr id="5" name="Footer Placeholder 4">
+            <a:extLst>
+              <a:ext uri="{FF2B5EF4-FFF2-40B4-BE49-F238E27FC236}">
+                <a16:creationId xmlns:a16="http://schemas.microsoft.com/office/drawing/2014/main" id="{D7BBB76B-CED0-40E2-C641-2D090E0DC049}"/>
+              </a:ext>
+            </a:extLst>
+          </p:cNvPr>
+          <p:cNvSpPr>
+            <a:spLocks noGrp="1"/>
+          </p:cNvSpPr>
+          <p:nvPr>
+            <p:ph type="ftr" sz="quarter" idx="11"/>
+          </p:nvPr>
+        </p:nvSpPr>
+        <p:spPr/>
+        <p:txBody>
+          <a:bodyPr/>
+          <a:lstStyle/>
+          <a:p>
+            <a:r>
+              <a:rPr lang="en-ID"/>
+              <a:t>Git</a:t>
+            </a:r>
+          </a:p>
+        </p:txBody>
+      </p:sp>
+    </p:spTree>
+    <p:extLst>
+      <p:ext uri="{BB962C8B-B14F-4D97-AF65-F5344CB8AC3E}">
+        <p14:creationId xmlns:p14="http://schemas.microsoft.com/office/powerpoint/2010/main" val="1145819383"/>
+      </p:ext>
+    </p:extLst>
+  </p:cSld>
+  <p:clrMapOvr>
+    <a:masterClrMapping/>
+  </p:clrMapOvr>
+</p:sld>
+</file>
+
+<file path=ppt/slides/slide38.xml><?xml version="1.0" encoding="utf-8"?>
+<p:sld xmlns:a="http://schemas.openxmlformats.org/drawingml/2006/main" xmlns:r="http://schemas.openxmlformats.org/officeDocument/2006/relationships" xmlns:p="http://schemas.openxmlformats.org/presentationml/2006/main">
+  <p:cSld>
+    <p:spTree>
+      <p:nvGrpSpPr>
+        <p:cNvPr id="1" name="">
+          <a:extLst>
+            <a:ext uri="{FF2B5EF4-FFF2-40B4-BE49-F238E27FC236}">
+              <a16:creationId xmlns:a16="http://schemas.microsoft.com/office/drawing/2014/main" id="{9222C84E-BA9C-8FC7-F58D-30BBC3AC72D9}"/>
+            </a:ext>
+          </a:extLst>
+        </p:cNvPr>
+        <p:cNvGrpSpPr/>
+        <p:nvPr/>
+      </p:nvGrpSpPr>
+      <p:grpSpPr>
+        <a:xfrm>
+          <a:off x="0" y="0"/>
+          <a:ext cx="0" cy="0"/>
+          <a:chOff x="0" y="0"/>
+          <a:chExt cx="0" cy="0"/>
+        </a:xfrm>
+      </p:grpSpPr>
+      <p:sp>
+        <p:nvSpPr>
+          <p:cNvPr id="2" name="Title 1">
+            <a:extLst>
+              <a:ext uri="{FF2B5EF4-FFF2-40B4-BE49-F238E27FC236}">
+                <a16:creationId xmlns:a16="http://schemas.microsoft.com/office/drawing/2014/main" id="{B2622DC7-165A-18BE-CD30-249682B91907}"/>
+              </a:ext>
+            </a:extLst>
+          </p:cNvPr>
+          <p:cNvSpPr>
+            <a:spLocks noGrp="1"/>
+          </p:cNvSpPr>
+          <p:nvPr>
+            <p:ph type="title"/>
+          </p:nvPr>
+        </p:nvSpPr>
+        <p:spPr/>
+        <p:txBody>
+          <a:bodyPr/>
+          <a:lstStyle/>
+          <a:p>
+            <a:r>
+              <a:rPr lang="en-US" dirty="0"/>
+              <a:t>Gitlab</a:t>
+            </a:r>
+            <a:endParaRPr lang="en-ID" dirty="0"/>
+          </a:p>
+        </p:txBody>
+      </p:sp>
+      <p:sp>
+        <p:nvSpPr>
+          <p:cNvPr id="3" name="Content Placeholder 2">
+            <a:extLst>
+              <a:ext uri="{FF2B5EF4-FFF2-40B4-BE49-F238E27FC236}">
+                <a16:creationId xmlns:a16="http://schemas.microsoft.com/office/drawing/2014/main" id="{027D423C-A0D8-0184-51D0-70ECBC85D102}"/>
+              </a:ext>
+            </a:extLst>
+          </p:cNvPr>
+          <p:cNvSpPr>
+            <a:spLocks noGrp="1"/>
+          </p:cNvSpPr>
+          <p:nvPr>
+            <p:ph idx="1"/>
+          </p:nvPr>
+        </p:nvSpPr>
+        <p:spPr>
+          <a:xfrm>
+            <a:off x="838200" y="1825625"/>
+            <a:ext cx="5031658" cy="4351338"/>
+          </a:xfrm>
+        </p:spPr>
+        <p:txBody>
+          <a:bodyPr/>
+          <a:lstStyle/>
+          <a:p>
+            <a:r>
+              <a:rPr lang="en-US" dirty="0"/>
+              <a:t>Kayak google drive </a:t>
+            </a:r>
+            <a:r>
+              <a:rPr lang="en-US" dirty="0" err="1"/>
+              <a:t>nya</a:t>
+            </a:r>
+            <a:r>
+              <a:rPr lang="en-US" dirty="0"/>
+              <a:t> for coding</a:t>
+            </a:r>
+          </a:p>
+          <a:p>
+            <a:r>
+              <a:rPr lang="en-US" dirty="0" err="1"/>
+              <a:t>Serupa</a:t>
+            </a:r>
+            <a:r>
+              <a:rPr lang="en-US" dirty="0"/>
+              <a:t> </a:t>
+            </a:r>
+            <a:r>
+              <a:rPr lang="en-US" dirty="0" err="1"/>
+              <a:t>tapi</a:t>
+            </a:r>
+            <a:r>
+              <a:rPr lang="en-US" dirty="0"/>
+              <a:t> </a:t>
+            </a:r>
+            <a:r>
+              <a:rPr lang="en-US" dirty="0" err="1"/>
+              <a:t>tak</a:t>
+            </a:r>
+            <a:r>
+              <a:rPr lang="en-US" dirty="0"/>
+              <a:t> </a:t>
+            </a:r>
+            <a:r>
+              <a:rPr lang="en-US" dirty="0" err="1"/>
+              <a:t>sama</a:t>
+            </a:r>
+            <a:endParaRPr lang="en-US" dirty="0"/>
+          </a:p>
+          <a:p>
+            <a:r>
+              <a:rPr lang="en-ID" dirty="0" err="1"/>
+              <a:t>Nggak</a:t>
+            </a:r>
+            <a:r>
+              <a:rPr lang="en-ID" dirty="0"/>
+              <a:t> </a:t>
+            </a:r>
+            <a:r>
+              <a:rPr lang="en-ID" dirty="0" err="1"/>
+              <a:t>bisa</a:t>
+            </a:r>
+            <a:r>
+              <a:rPr lang="en-ID" dirty="0"/>
+              <a:t> </a:t>
+            </a:r>
+            <a:r>
+              <a:rPr lang="en-ID" dirty="0" err="1"/>
+              <a:t>langusng</a:t>
+            </a:r>
+            <a:r>
+              <a:rPr lang="en-ID" dirty="0"/>
+              <a:t> upload file </a:t>
+            </a:r>
+            <a:r>
+              <a:rPr lang="en-ID" dirty="0" err="1"/>
+              <a:t>gitu</a:t>
+            </a:r>
+            <a:r>
+              <a:rPr lang="en-ID" dirty="0"/>
+              <a:t> </a:t>
+            </a:r>
+            <a:r>
+              <a:rPr lang="en-ID" dirty="0" err="1"/>
+              <a:t>aja</a:t>
+            </a:r>
+            <a:r>
+              <a:rPr lang="en-ID" dirty="0"/>
+              <a:t> (well you can, but don’t)</a:t>
+            </a:r>
+          </a:p>
+          <a:p>
+            <a:r>
+              <a:rPr lang="en-ID" dirty="0" err="1"/>
+              <a:t>Alternatif</a:t>
+            </a:r>
+            <a:r>
+              <a:rPr lang="en-ID" dirty="0"/>
+              <a:t> lain:</a:t>
+            </a:r>
+          </a:p>
+          <a:p>
+            <a:pPr lvl="1"/>
+            <a:r>
+              <a:rPr lang="en-ID" dirty="0" err="1"/>
+              <a:t>Github</a:t>
+            </a:r>
+            <a:r>
+              <a:rPr lang="en-ID" dirty="0"/>
+              <a:t>, </a:t>
+            </a:r>
+            <a:r>
+              <a:rPr lang="en-ID" dirty="0" err="1"/>
+              <a:t>gittea</a:t>
+            </a:r>
+            <a:r>
+              <a:rPr lang="en-ID" dirty="0"/>
+              <a:t>, </a:t>
+            </a:r>
+            <a:r>
+              <a:rPr lang="en-ID" dirty="0" err="1"/>
+              <a:t>atlassian</a:t>
+            </a:r>
+            <a:endParaRPr lang="en-US" dirty="0"/>
+          </a:p>
+        </p:txBody>
+      </p:sp>
+      <p:sp>
+        <p:nvSpPr>
+          <p:cNvPr id="4" name="Date Placeholder 3">
+            <a:extLst>
+              <a:ext uri="{FF2B5EF4-FFF2-40B4-BE49-F238E27FC236}">
+                <a16:creationId xmlns:a16="http://schemas.microsoft.com/office/drawing/2014/main" id="{9CF90CB1-6793-DD86-4A1D-3929EAD30658}"/>
+              </a:ext>
+            </a:extLst>
+          </p:cNvPr>
+          <p:cNvSpPr>
+            <a:spLocks noGrp="1"/>
+          </p:cNvSpPr>
+          <p:nvPr>
+            <p:ph type="dt" sz="half" idx="10"/>
+          </p:nvPr>
+        </p:nvSpPr>
+        <p:spPr/>
+        <p:txBody>
+          <a:bodyPr/>
+          <a:lstStyle/>
+          <a:p>
+            <a:r>
+              <a:rPr lang="en-ID"/>
+              <a:t>27/02/2026</a:t>
+            </a:r>
+            <a:endParaRPr lang="en-ID" dirty="0"/>
+          </a:p>
+        </p:txBody>
+      </p:sp>
+      <p:sp>
+        <p:nvSpPr>
+          <p:cNvPr id="5" name="Footer Placeholder 4">
+            <a:extLst>
+              <a:ext uri="{FF2B5EF4-FFF2-40B4-BE49-F238E27FC236}">
+                <a16:creationId xmlns:a16="http://schemas.microsoft.com/office/drawing/2014/main" id="{3D73F212-37E6-EC5F-818B-DD6EFB1A86F1}"/>
+              </a:ext>
+            </a:extLst>
+          </p:cNvPr>
+          <p:cNvSpPr>
+            <a:spLocks noGrp="1"/>
+          </p:cNvSpPr>
+          <p:nvPr>
+            <p:ph type="ftr" sz="quarter" idx="11"/>
+          </p:nvPr>
+        </p:nvSpPr>
+        <p:spPr/>
+        <p:txBody>
+          <a:bodyPr/>
+          <a:lstStyle/>
+          <a:p>
+            <a:r>
+              <a:rPr lang="en-ID"/>
+              <a:t>Git</a:t>
+            </a:r>
+            <a:endParaRPr lang="en-ID" dirty="0"/>
+          </a:p>
+        </p:txBody>
+      </p:sp>
+      <p:pic>
+        <p:nvPicPr>
+          <p:cNvPr id="1026" name="Picture 2" descr="gitlab - Gitlab works great actually! - devRant">
+            <a:extLst>
+              <a:ext uri="{FF2B5EF4-FFF2-40B4-BE49-F238E27FC236}">
+                <a16:creationId xmlns:a16="http://schemas.microsoft.com/office/drawing/2014/main" id="{C0DEF424-16ED-F1D6-B8E4-51A033FB8E95}"/>
+              </a:ext>
+            </a:extLst>
+          </p:cNvPr>
+          <p:cNvPicPr>
+            <a:picLocks noChangeAspect="1" noChangeArrowheads="1"/>
+          </p:cNvPicPr>
+          <p:nvPr/>
+        </p:nvPicPr>
+        <p:blipFill>
+          <a:blip r:embed="rId2">
+            <a:extLst>
+              <a:ext uri="{28A0092B-C50C-407E-A947-70E740481C1C}">
+                <a14:useLocalDpi xmlns:a14="http://schemas.microsoft.com/office/drawing/2010/main" val="0"/>
+              </a:ext>
+            </a:extLst>
+          </a:blip>
+          <a:srcRect/>
+          <a:stretch>
+            <a:fillRect/>
+          </a:stretch>
+        </p:blipFill>
+        <p:spPr bwMode="auto">
+          <a:xfrm>
+            <a:off x="6322144" y="1005860"/>
+            <a:ext cx="4594961" cy="4554417"/>
+          </a:xfrm>
+          <a:prstGeom prst="rect">
+            <a:avLst/>
+          </a:prstGeom>
+          <a:noFill/>
+          <a:extLst>
+            <a:ext uri="{909E8E84-426E-40DD-AFC4-6F175D3DCCD1}">
+              <a14:hiddenFill xmlns:a14="http://schemas.microsoft.com/office/drawing/2010/main">
+                <a:solidFill>
+                  <a:srgbClr val="FFFFFF"/>
+                </a:solidFill>
+              </a14:hiddenFill>
+            </a:ext>
+          </a:extLst>
+        </p:spPr>
+      </p:pic>
+    </p:spTree>
+    <p:extLst>
+      <p:ext uri="{BB962C8B-B14F-4D97-AF65-F5344CB8AC3E}">
+        <p14:creationId xmlns:p14="http://schemas.microsoft.com/office/powerpoint/2010/main" val="1086257265"/>
+      </p:ext>
+    </p:extLst>
+  </p:cSld>
+  <p:clrMapOvr>
+    <a:masterClrMapping/>
+  </p:clrMapOvr>
+</p:sld>
+</file>
+
+<file path=ppt/slides/slide39.xml><?xml version="1.0" encoding="utf-8"?>
+<p:sld xmlns:a="http://schemas.openxmlformats.org/drawingml/2006/main" xmlns:r="http://schemas.openxmlformats.org/officeDocument/2006/relationships" xmlns:p="http://schemas.openxmlformats.org/presentationml/2006/main">
+  <p:cSld>
+    <p:spTree>
+      <p:nvGrpSpPr>
+        <p:cNvPr id="1" name="">
+          <a:extLst>
+            <a:ext uri="{FF2B5EF4-FFF2-40B4-BE49-F238E27FC236}">
+              <a16:creationId xmlns:a16="http://schemas.microsoft.com/office/drawing/2014/main" id="{D096FB24-469A-E112-EBB0-9CA49ABA5C3F}"/>
+            </a:ext>
+          </a:extLst>
+        </p:cNvPr>
+        <p:cNvGrpSpPr/>
+        <p:nvPr/>
+      </p:nvGrpSpPr>
+      <p:grpSpPr>
+        <a:xfrm>
+          <a:off x="0" y="0"/>
+          <a:ext cx="0" cy="0"/>
+          <a:chOff x="0" y="0"/>
+          <a:chExt cx="0" cy="0"/>
+        </a:xfrm>
+      </p:grpSpPr>
+      <p:sp>
+        <p:nvSpPr>
+          <p:cNvPr id="2" name="Title 1">
+            <a:extLst>
+              <a:ext uri="{FF2B5EF4-FFF2-40B4-BE49-F238E27FC236}">
+                <a16:creationId xmlns:a16="http://schemas.microsoft.com/office/drawing/2014/main" id="{4B614563-7550-A37B-101A-08DD1D26BCDA}"/>
+              </a:ext>
+            </a:extLst>
+          </p:cNvPr>
+          <p:cNvSpPr>
+            <a:spLocks noGrp="1"/>
+          </p:cNvSpPr>
+          <p:nvPr>
+            <p:ph type="title"/>
+          </p:nvPr>
+        </p:nvSpPr>
+        <p:spPr/>
+        <p:txBody>
+          <a:bodyPr/>
+          <a:lstStyle/>
+          <a:p>
+            <a:r>
+              <a:rPr lang="en-US" dirty="0" err="1"/>
+              <a:t>Tampilan</a:t>
+            </a:r>
+            <a:r>
+              <a:rPr lang="en-US" dirty="0"/>
+              <a:t> </a:t>
+            </a:r>
+            <a:r>
+              <a:rPr lang="en-US" dirty="0" err="1"/>
+              <a:t>gitlab</a:t>
+            </a:r>
+            <a:endParaRPr lang="en-ID" dirty="0"/>
+          </a:p>
+        </p:txBody>
+      </p:sp>
+      <p:sp>
+        <p:nvSpPr>
+          <p:cNvPr id="4" name="Date Placeholder 3">
+            <a:extLst>
+              <a:ext uri="{FF2B5EF4-FFF2-40B4-BE49-F238E27FC236}">
+                <a16:creationId xmlns:a16="http://schemas.microsoft.com/office/drawing/2014/main" id="{BD738262-D0B4-5B67-8366-01F675CE3F64}"/>
+              </a:ext>
+            </a:extLst>
+          </p:cNvPr>
+          <p:cNvSpPr>
+            <a:spLocks noGrp="1"/>
+          </p:cNvSpPr>
+          <p:nvPr>
+            <p:ph type="dt" sz="half" idx="10"/>
+          </p:nvPr>
+        </p:nvSpPr>
+        <p:spPr/>
+        <p:txBody>
+          <a:bodyPr/>
+          <a:lstStyle/>
+          <a:p>
+            <a:r>
+              <a:rPr lang="en-ID"/>
+              <a:t>27/02/2026</a:t>
+            </a:r>
+            <a:endParaRPr lang="en-ID" dirty="0"/>
+          </a:p>
+        </p:txBody>
+      </p:sp>
+      <p:sp>
+        <p:nvSpPr>
+          <p:cNvPr id="5" name="Footer Placeholder 4">
+            <a:extLst>
+              <a:ext uri="{FF2B5EF4-FFF2-40B4-BE49-F238E27FC236}">
+                <a16:creationId xmlns:a16="http://schemas.microsoft.com/office/drawing/2014/main" id="{835A8725-D749-CB4F-B917-61B534957974}"/>
+              </a:ext>
+            </a:extLst>
+          </p:cNvPr>
+          <p:cNvSpPr>
+            <a:spLocks noGrp="1"/>
+          </p:cNvSpPr>
+          <p:nvPr>
+            <p:ph type="ftr" sz="quarter" idx="11"/>
+          </p:nvPr>
+        </p:nvSpPr>
+        <p:spPr/>
+        <p:txBody>
+          <a:bodyPr/>
+          <a:lstStyle/>
+          <a:p>
+            <a:r>
+              <a:rPr lang="en-ID"/>
+              <a:t>Git</a:t>
+            </a:r>
+            <a:endParaRPr lang="en-ID" dirty="0"/>
+          </a:p>
+        </p:txBody>
+      </p:sp>
+      <p:pic>
+        <p:nvPicPr>
+          <p:cNvPr id="10" name="Picture 9">
+            <a:extLst>
+              <a:ext uri="{FF2B5EF4-FFF2-40B4-BE49-F238E27FC236}">
+                <a16:creationId xmlns:a16="http://schemas.microsoft.com/office/drawing/2014/main" id="{7F3424AD-1E87-8D2C-951F-799FE792CE36}"/>
+              </a:ext>
+            </a:extLst>
+          </p:cNvPr>
+          <p:cNvPicPr>
+            <a:picLocks noChangeAspect="1"/>
+          </p:cNvPicPr>
+          <p:nvPr/>
+        </p:nvPicPr>
+        <p:blipFill>
+          <a:blip r:embed="rId2"/>
+          <a:stretch>
+            <a:fillRect/>
+          </a:stretch>
+        </p:blipFill>
+        <p:spPr>
+          <a:xfrm>
+            <a:off x="1676400" y="2010603"/>
+            <a:ext cx="8917858" cy="3360934"/>
+          </a:xfrm>
+          <a:prstGeom prst="rect">
+            <a:avLst/>
+          </a:prstGeom>
+        </p:spPr>
+      </p:pic>
+    </p:spTree>
+    <p:extLst>
+      <p:ext uri="{BB962C8B-B14F-4D97-AF65-F5344CB8AC3E}">
+        <p14:creationId xmlns:p14="http://schemas.microsoft.com/office/powerpoint/2010/main" val="3291461362"/>
+      </p:ext>
+    </p:extLst>
+  </p:cSld>
+  <p:clrMapOvr>
+    <a:masterClrMapping/>
+  </p:clrMapOvr>
+</p:sld>
+</file>
+
 <file path=ppt/slides/slide4.xml><?xml version="1.0" encoding="utf-8"?>
 <p:sld xmlns:a="http://schemas.openxmlformats.org/drawingml/2006/main" xmlns:r="http://schemas.openxmlformats.org/officeDocument/2006/relationships" xmlns:p="http://schemas.openxmlformats.org/presentationml/2006/main">
   <p:cSld>
@@ -13211,6 +13874,2400 @@
     <p:extLst>
       <p:ext uri="{BB962C8B-B14F-4D97-AF65-F5344CB8AC3E}">
         <p14:creationId xmlns:p14="http://schemas.microsoft.com/office/powerpoint/2010/main" val="3073127292"/>
+      </p:ext>
+    </p:extLst>
+  </p:cSld>
+  <p:clrMapOvr>
+    <a:masterClrMapping/>
+  </p:clrMapOvr>
+</p:sld>
+</file>
+
+<file path=ppt/slides/slide40.xml><?xml version="1.0" encoding="utf-8"?>
+<p:sld xmlns:a="http://schemas.openxmlformats.org/drawingml/2006/main" xmlns:r="http://schemas.openxmlformats.org/officeDocument/2006/relationships" xmlns:p="http://schemas.openxmlformats.org/presentationml/2006/main">
+  <p:cSld>
+    <p:spTree>
+      <p:nvGrpSpPr>
+        <p:cNvPr id="1" name="">
+          <a:extLst>
+            <a:ext uri="{FF2B5EF4-FFF2-40B4-BE49-F238E27FC236}">
+              <a16:creationId xmlns:a16="http://schemas.microsoft.com/office/drawing/2014/main" id="{1E31F3A2-655B-B310-C34E-DE5DFEC44A04}"/>
+            </a:ext>
+          </a:extLst>
+        </p:cNvPr>
+        <p:cNvGrpSpPr/>
+        <p:nvPr/>
+      </p:nvGrpSpPr>
+      <p:grpSpPr>
+        <a:xfrm>
+          <a:off x="0" y="0"/>
+          <a:ext cx="0" cy="0"/>
+          <a:chOff x="0" y="0"/>
+          <a:chExt cx="0" cy="0"/>
+        </a:xfrm>
+      </p:grpSpPr>
+      <p:sp>
+        <p:nvSpPr>
+          <p:cNvPr id="2" name="Title 1">
+            <a:extLst>
+              <a:ext uri="{FF2B5EF4-FFF2-40B4-BE49-F238E27FC236}">
+                <a16:creationId xmlns:a16="http://schemas.microsoft.com/office/drawing/2014/main" id="{99D5D119-E525-9C4A-FFF1-327C89C6F71F}"/>
+              </a:ext>
+            </a:extLst>
+          </p:cNvPr>
+          <p:cNvSpPr>
+            <a:spLocks noGrp="1"/>
+          </p:cNvSpPr>
+          <p:nvPr>
+            <p:ph type="title"/>
+          </p:nvPr>
+        </p:nvSpPr>
+        <p:spPr/>
+        <p:txBody>
+          <a:bodyPr/>
+          <a:lstStyle/>
+          <a:p>
+            <a:r>
+              <a:rPr lang="en-US" dirty="0"/>
+              <a:t>Fitur </a:t>
+            </a:r>
+            <a:r>
+              <a:rPr lang="en-US" dirty="0" err="1"/>
+              <a:t>dasar</a:t>
+            </a:r>
+            <a:r>
+              <a:rPr lang="en-US" dirty="0"/>
+              <a:t> </a:t>
+            </a:r>
+            <a:r>
+              <a:rPr lang="en-US" dirty="0" err="1"/>
+              <a:t>gitlab</a:t>
+            </a:r>
+            <a:endParaRPr lang="en-ID" dirty="0"/>
+          </a:p>
+        </p:txBody>
+      </p:sp>
+      <p:sp>
+        <p:nvSpPr>
+          <p:cNvPr id="3" name="Content Placeholder 2">
+            <a:extLst>
+              <a:ext uri="{FF2B5EF4-FFF2-40B4-BE49-F238E27FC236}">
+                <a16:creationId xmlns:a16="http://schemas.microsoft.com/office/drawing/2014/main" id="{17FF47F4-4EF6-536B-A9EF-EC235585FF7F}"/>
+              </a:ext>
+            </a:extLst>
+          </p:cNvPr>
+          <p:cNvSpPr>
+            <a:spLocks noGrp="1"/>
+          </p:cNvSpPr>
+          <p:nvPr>
+            <p:ph idx="1"/>
+          </p:nvPr>
+        </p:nvSpPr>
+        <p:spPr/>
+        <p:txBody>
+          <a:bodyPr/>
+          <a:lstStyle/>
+          <a:p>
+            <a:r>
+              <a:rPr lang="en-US" dirty="0"/>
+              <a:t>Project management</a:t>
+            </a:r>
+          </a:p>
+          <a:p>
+            <a:r>
+              <a:rPr lang="en-US" dirty="0"/>
+              <a:t>Issues </a:t>
+            </a:r>
+            <a:r>
+              <a:rPr lang="en-US" dirty="0" err="1"/>
+              <a:t>untuk</a:t>
+            </a:r>
+            <a:r>
+              <a:rPr lang="en-US" dirty="0"/>
+              <a:t> </a:t>
+            </a:r>
+            <a:r>
+              <a:rPr lang="en-US" dirty="0" err="1"/>
+              <a:t>pencatatan</a:t>
+            </a:r>
+            <a:r>
+              <a:rPr lang="en-US" dirty="0"/>
+              <a:t> </a:t>
+            </a:r>
+            <a:r>
+              <a:rPr lang="en-US" dirty="0" err="1"/>
+              <a:t>tugas</a:t>
+            </a:r>
+            <a:r>
+              <a:rPr lang="en-US" dirty="0"/>
+              <a:t>/bug</a:t>
+            </a:r>
+          </a:p>
+          <a:p>
+            <a:r>
+              <a:rPr lang="en-US" dirty="0"/>
+              <a:t>Merge request (review </a:t>
+            </a:r>
+            <a:r>
+              <a:rPr lang="en-US" dirty="0" err="1"/>
+              <a:t>sebelum</a:t>
+            </a:r>
+            <a:r>
+              <a:rPr lang="en-US" dirty="0"/>
+              <a:t> </a:t>
+            </a:r>
+            <a:r>
+              <a:rPr lang="en-US" dirty="0" err="1"/>
+              <a:t>dimerge</a:t>
+            </a:r>
+            <a:r>
+              <a:rPr lang="en-US" dirty="0"/>
+              <a:t>)</a:t>
+            </a:r>
+          </a:p>
+          <a:p>
+            <a:r>
+              <a:rPr lang="en-US" dirty="0"/>
+              <a:t>Snippets</a:t>
+            </a:r>
+          </a:p>
+          <a:p>
+            <a:r>
+              <a:rPr lang="en-ID" dirty="0"/>
+              <a:t>Multi-person collaboration</a:t>
+            </a:r>
+          </a:p>
+          <a:p>
+            <a:endParaRPr lang="en-ID" dirty="0"/>
+          </a:p>
+        </p:txBody>
+      </p:sp>
+      <p:sp>
+        <p:nvSpPr>
+          <p:cNvPr id="4" name="Date Placeholder 3">
+            <a:extLst>
+              <a:ext uri="{FF2B5EF4-FFF2-40B4-BE49-F238E27FC236}">
+                <a16:creationId xmlns:a16="http://schemas.microsoft.com/office/drawing/2014/main" id="{7F71C33B-3005-54AA-1797-04B044B8D604}"/>
+              </a:ext>
+            </a:extLst>
+          </p:cNvPr>
+          <p:cNvSpPr>
+            <a:spLocks noGrp="1"/>
+          </p:cNvSpPr>
+          <p:nvPr>
+            <p:ph type="dt" sz="half" idx="10"/>
+          </p:nvPr>
+        </p:nvSpPr>
+        <p:spPr/>
+        <p:txBody>
+          <a:bodyPr/>
+          <a:lstStyle/>
+          <a:p>
+            <a:r>
+              <a:rPr lang="en-ID"/>
+              <a:t>27/02/2026</a:t>
+            </a:r>
+            <a:endParaRPr lang="en-ID" dirty="0"/>
+          </a:p>
+        </p:txBody>
+      </p:sp>
+      <p:sp>
+        <p:nvSpPr>
+          <p:cNvPr id="5" name="Footer Placeholder 4">
+            <a:extLst>
+              <a:ext uri="{FF2B5EF4-FFF2-40B4-BE49-F238E27FC236}">
+                <a16:creationId xmlns:a16="http://schemas.microsoft.com/office/drawing/2014/main" id="{16D9B12A-6C76-B658-8E95-278649F99282}"/>
+              </a:ext>
+            </a:extLst>
+          </p:cNvPr>
+          <p:cNvSpPr>
+            <a:spLocks noGrp="1"/>
+          </p:cNvSpPr>
+          <p:nvPr>
+            <p:ph type="ftr" sz="quarter" idx="11"/>
+          </p:nvPr>
+        </p:nvSpPr>
+        <p:spPr/>
+        <p:txBody>
+          <a:bodyPr/>
+          <a:lstStyle/>
+          <a:p>
+            <a:r>
+              <a:rPr lang="en-ID"/>
+              <a:t>Git</a:t>
+            </a:r>
+            <a:endParaRPr lang="en-ID" dirty="0"/>
+          </a:p>
+        </p:txBody>
+      </p:sp>
+    </p:spTree>
+    <p:extLst>
+      <p:ext uri="{BB962C8B-B14F-4D97-AF65-F5344CB8AC3E}">
+        <p14:creationId xmlns:p14="http://schemas.microsoft.com/office/powerpoint/2010/main" val="723600560"/>
+      </p:ext>
+    </p:extLst>
+  </p:cSld>
+  <p:clrMapOvr>
+    <a:masterClrMapping/>
+  </p:clrMapOvr>
+</p:sld>
+</file>
+
+<file path=ppt/slides/slide41.xml><?xml version="1.0" encoding="utf-8"?>
+<p:sld xmlns:a="http://schemas.openxmlformats.org/drawingml/2006/main" xmlns:r="http://schemas.openxmlformats.org/officeDocument/2006/relationships" xmlns:p="http://schemas.openxmlformats.org/presentationml/2006/main">
+  <p:cSld>
+    <p:spTree>
+      <p:nvGrpSpPr>
+        <p:cNvPr id="1" name="">
+          <a:extLst>
+            <a:ext uri="{FF2B5EF4-FFF2-40B4-BE49-F238E27FC236}">
+              <a16:creationId xmlns:a16="http://schemas.microsoft.com/office/drawing/2014/main" id="{50C18C0C-C36C-8AA5-4A2C-0B53B1635449}"/>
+            </a:ext>
+          </a:extLst>
+        </p:cNvPr>
+        <p:cNvGrpSpPr/>
+        <p:nvPr/>
+      </p:nvGrpSpPr>
+      <p:grpSpPr>
+        <a:xfrm>
+          <a:off x="0" y="0"/>
+          <a:ext cx="0" cy="0"/>
+          <a:chOff x="0" y="0"/>
+          <a:chExt cx="0" cy="0"/>
+        </a:xfrm>
+      </p:grpSpPr>
+      <p:sp>
+        <p:nvSpPr>
+          <p:cNvPr id="2" name="Title 1">
+            <a:extLst>
+              <a:ext uri="{FF2B5EF4-FFF2-40B4-BE49-F238E27FC236}">
+                <a16:creationId xmlns:a16="http://schemas.microsoft.com/office/drawing/2014/main" id="{BF6342C2-BA3D-DB89-5E1D-B719719C5875}"/>
+              </a:ext>
+            </a:extLst>
+          </p:cNvPr>
+          <p:cNvSpPr>
+            <a:spLocks noGrp="1"/>
+          </p:cNvSpPr>
+          <p:nvPr>
+            <p:ph type="title"/>
+          </p:nvPr>
+        </p:nvSpPr>
+        <p:spPr/>
+        <p:txBody>
+          <a:bodyPr/>
+          <a:lstStyle/>
+          <a:p>
+            <a:r>
+              <a:rPr lang="en-US" dirty="0"/>
+              <a:t>Alternative </a:t>
+            </a:r>
+            <a:r>
+              <a:rPr lang="en-US" dirty="0" err="1"/>
+              <a:t>selain</a:t>
+            </a:r>
+            <a:r>
+              <a:rPr lang="en-US" dirty="0"/>
+              <a:t> </a:t>
+            </a:r>
+            <a:r>
+              <a:rPr lang="en-US" dirty="0" err="1"/>
+              <a:t>gitlab</a:t>
+            </a:r>
+            <a:r>
+              <a:rPr lang="en-US" dirty="0"/>
+              <a:t>?</a:t>
+            </a:r>
+            <a:endParaRPr lang="en-ID" dirty="0"/>
+          </a:p>
+        </p:txBody>
+      </p:sp>
+      <p:sp>
+        <p:nvSpPr>
+          <p:cNvPr id="3" name="Content Placeholder 2">
+            <a:extLst>
+              <a:ext uri="{FF2B5EF4-FFF2-40B4-BE49-F238E27FC236}">
+                <a16:creationId xmlns:a16="http://schemas.microsoft.com/office/drawing/2014/main" id="{8A3B0699-04A0-72BF-0534-4A3CD7A84083}"/>
+              </a:ext>
+            </a:extLst>
+          </p:cNvPr>
+          <p:cNvSpPr>
+            <a:spLocks noGrp="1"/>
+          </p:cNvSpPr>
+          <p:nvPr>
+            <p:ph idx="1"/>
+          </p:nvPr>
+        </p:nvSpPr>
+        <p:spPr/>
+        <p:txBody>
+          <a:bodyPr/>
+          <a:lstStyle/>
+          <a:p>
+            <a:r>
+              <a:rPr lang="en-US" dirty="0"/>
+              <a:t>Gitlab</a:t>
+            </a:r>
+          </a:p>
+          <a:p>
+            <a:r>
+              <a:rPr lang="en-US" dirty="0" err="1"/>
+              <a:t>Gittea</a:t>
+            </a:r>
+            <a:endParaRPr lang="en-US" dirty="0"/>
+          </a:p>
+          <a:p>
+            <a:r>
+              <a:rPr lang="en-US" dirty="0"/>
+              <a:t>Atlassian</a:t>
+            </a:r>
+          </a:p>
+          <a:p>
+            <a:r>
+              <a:rPr lang="en-US" dirty="0" err="1"/>
+              <a:t>BitBucket</a:t>
+            </a:r>
+            <a:endParaRPr lang="en-US" dirty="0"/>
+          </a:p>
+          <a:p>
+            <a:r>
+              <a:rPr lang="en-US" dirty="0" err="1"/>
+              <a:t>AzureRepos</a:t>
+            </a:r>
+            <a:endParaRPr lang="en-ID" dirty="0"/>
+          </a:p>
+        </p:txBody>
+      </p:sp>
+      <p:sp>
+        <p:nvSpPr>
+          <p:cNvPr id="4" name="Date Placeholder 3">
+            <a:extLst>
+              <a:ext uri="{FF2B5EF4-FFF2-40B4-BE49-F238E27FC236}">
+                <a16:creationId xmlns:a16="http://schemas.microsoft.com/office/drawing/2014/main" id="{3831799D-58E6-6131-4F89-80C25BEF1E5D}"/>
+              </a:ext>
+            </a:extLst>
+          </p:cNvPr>
+          <p:cNvSpPr>
+            <a:spLocks noGrp="1"/>
+          </p:cNvSpPr>
+          <p:nvPr>
+            <p:ph type="dt" sz="half" idx="10"/>
+          </p:nvPr>
+        </p:nvSpPr>
+        <p:spPr/>
+        <p:txBody>
+          <a:bodyPr/>
+          <a:lstStyle/>
+          <a:p>
+            <a:r>
+              <a:rPr lang="en-ID"/>
+              <a:t>27/02/2026</a:t>
+            </a:r>
+            <a:endParaRPr lang="en-ID" dirty="0"/>
+          </a:p>
+        </p:txBody>
+      </p:sp>
+      <p:sp>
+        <p:nvSpPr>
+          <p:cNvPr id="5" name="Footer Placeholder 4">
+            <a:extLst>
+              <a:ext uri="{FF2B5EF4-FFF2-40B4-BE49-F238E27FC236}">
+                <a16:creationId xmlns:a16="http://schemas.microsoft.com/office/drawing/2014/main" id="{CB81DE0C-E846-2858-CA1B-11981387090D}"/>
+              </a:ext>
+            </a:extLst>
+          </p:cNvPr>
+          <p:cNvSpPr>
+            <a:spLocks noGrp="1"/>
+          </p:cNvSpPr>
+          <p:nvPr>
+            <p:ph type="ftr" sz="quarter" idx="11"/>
+          </p:nvPr>
+        </p:nvSpPr>
+        <p:spPr/>
+        <p:txBody>
+          <a:bodyPr/>
+          <a:lstStyle/>
+          <a:p>
+            <a:r>
+              <a:rPr lang="en-ID"/>
+              <a:t>Git</a:t>
+            </a:r>
+            <a:endParaRPr lang="en-ID" dirty="0"/>
+          </a:p>
+        </p:txBody>
+      </p:sp>
+    </p:spTree>
+    <p:extLst>
+      <p:ext uri="{BB962C8B-B14F-4D97-AF65-F5344CB8AC3E}">
+        <p14:creationId xmlns:p14="http://schemas.microsoft.com/office/powerpoint/2010/main" val="577973470"/>
+      </p:ext>
+    </p:extLst>
+  </p:cSld>
+  <p:clrMapOvr>
+    <a:masterClrMapping/>
+  </p:clrMapOvr>
+</p:sld>
+</file>
+
+<file path=ppt/slides/slide42.xml><?xml version="1.0" encoding="utf-8"?>
+<p:sld xmlns:a="http://schemas.openxmlformats.org/drawingml/2006/main" xmlns:r="http://schemas.openxmlformats.org/officeDocument/2006/relationships" xmlns:p="http://schemas.openxmlformats.org/presentationml/2006/main">
+  <p:cSld>
+    <p:spTree>
+      <p:nvGrpSpPr>
+        <p:cNvPr id="1" name="">
+          <a:extLst>
+            <a:ext uri="{FF2B5EF4-FFF2-40B4-BE49-F238E27FC236}">
+              <a16:creationId xmlns:a16="http://schemas.microsoft.com/office/drawing/2014/main" id="{18C8D145-12CD-2CF2-0EF9-5E7A2AD9A4DE}"/>
+            </a:ext>
+          </a:extLst>
+        </p:cNvPr>
+        <p:cNvGrpSpPr/>
+        <p:nvPr/>
+      </p:nvGrpSpPr>
+      <p:grpSpPr>
+        <a:xfrm>
+          <a:off x="0" y="0"/>
+          <a:ext cx="0" cy="0"/>
+          <a:chOff x="0" y="0"/>
+          <a:chExt cx="0" cy="0"/>
+        </a:xfrm>
+      </p:grpSpPr>
+      <p:sp>
+        <p:nvSpPr>
+          <p:cNvPr id="2" name="Title 1">
+            <a:extLst>
+              <a:ext uri="{FF2B5EF4-FFF2-40B4-BE49-F238E27FC236}">
+                <a16:creationId xmlns:a16="http://schemas.microsoft.com/office/drawing/2014/main" id="{4C0D925E-3711-C487-378F-BEF085BFCB1E}"/>
+              </a:ext>
+            </a:extLst>
+          </p:cNvPr>
+          <p:cNvSpPr>
+            <a:spLocks noGrp="1"/>
+          </p:cNvSpPr>
+          <p:nvPr>
+            <p:ph type="title"/>
+          </p:nvPr>
+        </p:nvSpPr>
+        <p:spPr/>
+        <p:txBody>
+          <a:bodyPr/>
+          <a:lstStyle/>
+          <a:p>
+            <a:r>
+              <a:rPr lang="en-US" dirty="0"/>
+              <a:t>Git vs Gitlab? </a:t>
+            </a:r>
+            <a:r>
+              <a:rPr lang="en-US" dirty="0" err="1"/>
+              <a:t>Sebenernya</a:t>
+            </a:r>
+            <a:r>
+              <a:rPr lang="en-US" dirty="0"/>
+              <a:t> </a:t>
+            </a:r>
+            <a:r>
+              <a:rPr lang="en-US" dirty="0" err="1"/>
+              <a:t>gimana</a:t>
+            </a:r>
+            <a:r>
+              <a:rPr lang="en-US" dirty="0"/>
+              <a:t>?</a:t>
+            </a:r>
+            <a:endParaRPr lang="en-ID" dirty="0"/>
+          </a:p>
+        </p:txBody>
+      </p:sp>
+      <p:sp>
+        <p:nvSpPr>
+          <p:cNvPr id="3" name="Content Placeholder 2">
+            <a:extLst>
+              <a:ext uri="{FF2B5EF4-FFF2-40B4-BE49-F238E27FC236}">
+                <a16:creationId xmlns:a16="http://schemas.microsoft.com/office/drawing/2014/main" id="{53990665-4F2D-F705-EF02-936D6A97919D}"/>
+              </a:ext>
+            </a:extLst>
+          </p:cNvPr>
+          <p:cNvSpPr>
+            <a:spLocks noGrp="1"/>
+          </p:cNvSpPr>
+          <p:nvPr>
+            <p:ph idx="1"/>
+          </p:nvPr>
+        </p:nvSpPr>
+        <p:spPr>
+          <a:xfrm>
+            <a:off x="838200" y="1825625"/>
+            <a:ext cx="5037596" cy="4351338"/>
+          </a:xfrm>
+        </p:spPr>
+        <p:txBody>
+          <a:bodyPr/>
+          <a:lstStyle/>
+          <a:p>
+            <a:r>
+              <a:rPr lang="en-US" dirty="0"/>
+              <a:t>Git -&gt; Air Mineral</a:t>
+            </a:r>
+          </a:p>
+          <a:p>
+            <a:r>
+              <a:rPr lang="en-US" dirty="0"/>
+              <a:t>Gitlab -&gt; Aqua</a:t>
+            </a:r>
+          </a:p>
+          <a:p>
+            <a:endParaRPr lang="en-US" dirty="0"/>
+          </a:p>
+          <a:p>
+            <a:r>
+              <a:rPr lang="en-US" dirty="0"/>
+              <a:t>Gitlab </a:t>
+            </a:r>
+            <a:r>
+              <a:rPr lang="en-US" dirty="0" err="1"/>
+              <a:t>memungkinkan</a:t>
+            </a:r>
+            <a:r>
+              <a:rPr lang="en-US" dirty="0"/>
+              <a:t> remote storage </a:t>
+            </a:r>
+            <a:r>
+              <a:rPr lang="en-US" dirty="0" err="1"/>
+              <a:t>untuk</a:t>
+            </a:r>
+            <a:r>
+              <a:rPr lang="en-US" dirty="0"/>
+              <a:t> repository</a:t>
+            </a:r>
+          </a:p>
+          <a:p>
+            <a:endParaRPr lang="en-US" dirty="0"/>
+          </a:p>
+          <a:p>
+            <a:r>
+              <a:rPr lang="en-US" dirty="0"/>
+              <a:t>Coba run:</a:t>
+            </a:r>
+          </a:p>
+          <a:p>
+            <a:pPr lvl="1"/>
+            <a:r>
+              <a:rPr lang="en-US" dirty="0"/>
+              <a:t>Git remote get-</a:t>
+            </a:r>
+            <a:r>
+              <a:rPr lang="en-US" dirty="0" err="1"/>
+              <a:t>url</a:t>
+            </a:r>
+            <a:r>
+              <a:rPr lang="en-US" dirty="0"/>
+              <a:t> origin</a:t>
+            </a:r>
+            <a:endParaRPr lang="en-ID" dirty="0"/>
+          </a:p>
+        </p:txBody>
+      </p:sp>
+      <p:sp>
+        <p:nvSpPr>
+          <p:cNvPr id="4" name="Date Placeholder 3">
+            <a:extLst>
+              <a:ext uri="{FF2B5EF4-FFF2-40B4-BE49-F238E27FC236}">
+                <a16:creationId xmlns:a16="http://schemas.microsoft.com/office/drawing/2014/main" id="{31A3C542-F367-CABF-D2E6-76D87DB054C1}"/>
+              </a:ext>
+            </a:extLst>
+          </p:cNvPr>
+          <p:cNvSpPr>
+            <a:spLocks noGrp="1"/>
+          </p:cNvSpPr>
+          <p:nvPr>
+            <p:ph type="dt" sz="half" idx="10"/>
+          </p:nvPr>
+        </p:nvSpPr>
+        <p:spPr/>
+        <p:txBody>
+          <a:bodyPr/>
+          <a:lstStyle/>
+          <a:p>
+            <a:r>
+              <a:rPr lang="en-ID"/>
+              <a:t>27/02/2026</a:t>
+            </a:r>
+            <a:endParaRPr lang="en-ID" dirty="0"/>
+          </a:p>
+        </p:txBody>
+      </p:sp>
+      <p:sp>
+        <p:nvSpPr>
+          <p:cNvPr id="5" name="Footer Placeholder 4">
+            <a:extLst>
+              <a:ext uri="{FF2B5EF4-FFF2-40B4-BE49-F238E27FC236}">
+                <a16:creationId xmlns:a16="http://schemas.microsoft.com/office/drawing/2014/main" id="{58941452-712A-E6B8-9455-ECA97F8FF6CD}"/>
+              </a:ext>
+            </a:extLst>
+          </p:cNvPr>
+          <p:cNvSpPr>
+            <a:spLocks noGrp="1"/>
+          </p:cNvSpPr>
+          <p:nvPr>
+            <p:ph type="ftr" sz="quarter" idx="11"/>
+          </p:nvPr>
+        </p:nvSpPr>
+        <p:spPr/>
+        <p:txBody>
+          <a:bodyPr/>
+          <a:lstStyle/>
+          <a:p>
+            <a:r>
+              <a:rPr lang="en-ID"/>
+              <a:t>Git</a:t>
+            </a:r>
+            <a:endParaRPr lang="en-ID" dirty="0"/>
+          </a:p>
+        </p:txBody>
+      </p:sp>
+      <p:pic>
+        <p:nvPicPr>
+          <p:cNvPr id="10242" name="Picture 2">
+            <a:extLst>
+              <a:ext uri="{FF2B5EF4-FFF2-40B4-BE49-F238E27FC236}">
+                <a16:creationId xmlns:a16="http://schemas.microsoft.com/office/drawing/2014/main" id="{33524611-3D13-6E54-FB81-471DC0FA90C9}"/>
+              </a:ext>
+            </a:extLst>
+          </p:cNvPr>
+          <p:cNvPicPr>
+            <a:picLocks noChangeAspect="1" noChangeArrowheads="1"/>
+          </p:cNvPicPr>
+          <p:nvPr/>
+        </p:nvPicPr>
+        <p:blipFill>
+          <a:blip r:embed="rId2">
+            <a:extLst>
+              <a:ext uri="{28A0092B-C50C-407E-A947-70E740481C1C}">
+                <a14:useLocalDpi xmlns:a14="http://schemas.microsoft.com/office/drawing/2010/main" val="0"/>
+              </a:ext>
+            </a:extLst>
+          </a:blip>
+          <a:srcRect/>
+          <a:stretch>
+            <a:fillRect/>
+          </a:stretch>
+        </p:blipFill>
+        <p:spPr bwMode="auto">
+          <a:xfrm>
+            <a:off x="6316205" y="1870075"/>
+            <a:ext cx="4261360" cy="3199219"/>
+          </a:xfrm>
+          <a:prstGeom prst="rect">
+            <a:avLst/>
+          </a:prstGeom>
+          <a:noFill/>
+          <a:extLst>
+            <a:ext uri="{909E8E84-426E-40DD-AFC4-6F175D3DCCD1}">
+              <a14:hiddenFill xmlns:a14="http://schemas.microsoft.com/office/drawing/2010/main">
+                <a:solidFill>
+                  <a:srgbClr val="FFFFFF"/>
+                </a:solidFill>
+              </a14:hiddenFill>
+            </a:ext>
+          </a:extLst>
+        </p:spPr>
+      </p:pic>
+    </p:spTree>
+    <p:extLst>
+      <p:ext uri="{BB962C8B-B14F-4D97-AF65-F5344CB8AC3E}">
+        <p14:creationId xmlns:p14="http://schemas.microsoft.com/office/powerpoint/2010/main" val="4197096522"/>
+      </p:ext>
+    </p:extLst>
+  </p:cSld>
+  <p:clrMapOvr>
+    <a:masterClrMapping/>
+  </p:clrMapOvr>
+</p:sld>
+</file>
+
+<file path=ppt/slides/slide43.xml><?xml version="1.0" encoding="utf-8"?>
+<p:sld xmlns:a="http://schemas.openxmlformats.org/drawingml/2006/main" xmlns:r="http://schemas.openxmlformats.org/officeDocument/2006/relationships" xmlns:p="http://schemas.openxmlformats.org/presentationml/2006/main">
+  <p:cSld>
+    <p:spTree>
+      <p:nvGrpSpPr>
+        <p:cNvPr id="1" name="">
+          <a:extLst>
+            <a:ext uri="{FF2B5EF4-FFF2-40B4-BE49-F238E27FC236}">
+              <a16:creationId xmlns:a16="http://schemas.microsoft.com/office/drawing/2014/main" id="{0F0096A2-08A4-42DC-7B91-83B9C5F814BC}"/>
+            </a:ext>
+          </a:extLst>
+        </p:cNvPr>
+        <p:cNvGrpSpPr/>
+        <p:nvPr/>
+      </p:nvGrpSpPr>
+      <p:grpSpPr>
+        <a:xfrm>
+          <a:off x="0" y="0"/>
+          <a:ext cx="0" cy="0"/>
+          <a:chOff x="0" y="0"/>
+          <a:chExt cx="0" cy="0"/>
+        </a:xfrm>
+      </p:grpSpPr>
+      <p:sp>
+        <p:nvSpPr>
+          <p:cNvPr id="2" name="Title 1">
+            <a:extLst>
+              <a:ext uri="{FF2B5EF4-FFF2-40B4-BE49-F238E27FC236}">
+                <a16:creationId xmlns:a16="http://schemas.microsoft.com/office/drawing/2014/main" id="{3D3D92CB-3E54-D4BE-0F50-21F6CA9375E3}"/>
+              </a:ext>
+            </a:extLst>
+          </p:cNvPr>
+          <p:cNvSpPr>
+            <a:spLocks noGrp="1"/>
+          </p:cNvSpPr>
+          <p:nvPr>
+            <p:ph type="title"/>
+          </p:nvPr>
+        </p:nvSpPr>
+        <p:spPr/>
+        <p:txBody>
+          <a:bodyPr/>
+          <a:lstStyle/>
+          <a:p>
+            <a:r>
+              <a:rPr lang="en-US" dirty="0"/>
+              <a:t>In Depth: </a:t>
+            </a:r>
+            <a:r>
+              <a:rPr lang="en-US" dirty="0" err="1"/>
+              <a:t>gitlab</a:t>
+            </a:r>
+            <a:r>
+              <a:rPr lang="en-US" dirty="0"/>
+              <a:t> projects</a:t>
+            </a:r>
+            <a:endParaRPr lang="en-ID" dirty="0"/>
+          </a:p>
+        </p:txBody>
+      </p:sp>
+      <p:sp>
+        <p:nvSpPr>
+          <p:cNvPr id="3" name="Content Placeholder 2">
+            <a:extLst>
+              <a:ext uri="{FF2B5EF4-FFF2-40B4-BE49-F238E27FC236}">
+                <a16:creationId xmlns:a16="http://schemas.microsoft.com/office/drawing/2014/main" id="{53005F1B-5C59-2DDB-352C-8FB6EA7A17BF}"/>
+              </a:ext>
+            </a:extLst>
+          </p:cNvPr>
+          <p:cNvSpPr>
+            <a:spLocks noGrp="1"/>
+          </p:cNvSpPr>
+          <p:nvPr>
+            <p:ph idx="1"/>
+          </p:nvPr>
+        </p:nvSpPr>
+        <p:spPr/>
+        <p:txBody>
+          <a:bodyPr/>
+          <a:lstStyle/>
+          <a:p>
+            <a:r>
+              <a:rPr lang="en-US" dirty="0" err="1"/>
+              <a:t>Seperti</a:t>
+            </a:r>
+            <a:r>
+              <a:rPr lang="en-US" dirty="0"/>
+              <a:t> folder drive</a:t>
+            </a:r>
+          </a:p>
+          <a:p>
+            <a:r>
+              <a:rPr lang="en-US" dirty="0" err="1"/>
+              <a:t>Pokok</a:t>
+            </a:r>
+            <a:r>
+              <a:rPr lang="en-US" dirty="0"/>
+              <a:t> </a:t>
+            </a:r>
+            <a:r>
+              <a:rPr lang="en-US" dirty="0" err="1"/>
+              <a:t>dari</a:t>
+            </a:r>
+            <a:r>
+              <a:rPr lang="en-US" dirty="0"/>
+              <a:t> </a:t>
+            </a:r>
+            <a:r>
+              <a:rPr lang="en-US" dirty="0" err="1"/>
+              <a:t>segala</a:t>
+            </a:r>
+            <a:r>
+              <a:rPr lang="en-US" dirty="0"/>
+              <a:t> </a:t>
+            </a:r>
+            <a:r>
+              <a:rPr lang="en-US" dirty="0" err="1"/>
+              <a:t>konsep</a:t>
+            </a:r>
+            <a:r>
+              <a:rPr lang="en-US" dirty="0"/>
+              <a:t> </a:t>
+            </a:r>
+            <a:r>
+              <a:rPr lang="en-US" dirty="0" err="1"/>
+              <a:t>github</a:t>
+            </a:r>
+            <a:endParaRPr lang="en-US" dirty="0"/>
+          </a:p>
+          <a:p>
+            <a:r>
+              <a:rPr lang="en-US" dirty="0" err="1"/>
+              <a:t>Tempat</a:t>
+            </a:r>
+            <a:r>
+              <a:rPr lang="en-US" dirty="0"/>
+              <a:t> </a:t>
+            </a:r>
+            <a:r>
+              <a:rPr lang="en-US" dirty="0" err="1"/>
+              <a:t>naruh</a:t>
+            </a:r>
+            <a:r>
+              <a:rPr lang="en-US" dirty="0"/>
+              <a:t> code</a:t>
+            </a:r>
+          </a:p>
+          <a:p>
+            <a:r>
+              <a:rPr lang="en-US" dirty="0"/>
+              <a:t>Coba </a:t>
+            </a:r>
+            <a:r>
+              <a:rPr lang="en-US" dirty="0" err="1"/>
+              <a:t>buat</a:t>
+            </a:r>
+            <a:r>
+              <a:rPr lang="en-US" dirty="0"/>
+              <a:t>: new Projects</a:t>
+            </a:r>
+            <a:endParaRPr lang="en-ID" dirty="0"/>
+          </a:p>
+        </p:txBody>
+      </p:sp>
+      <p:sp>
+        <p:nvSpPr>
+          <p:cNvPr id="4" name="Date Placeholder 3">
+            <a:extLst>
+              <a:ext uri="{FF2B5EF4-FFF2-40B4-BE49-F238E27FC236}">
+                <a16:creationId xmlns:a16="http://schemas.microsoft.com/office/drawing/2014/main" id="{ADB56D4A-A61F-1717-4DD4-177D003A59F2}"/>
+              </a:ext>
+            </a:extLst>
+          </p:cNvPr>
+          <p:cNvSpPr>
+            <a:spLocks noGrp="1"/>
+          </p:cNvSpPr>
+          <p:nvPr>
+            <p:ph type="dt" sz="half" idx="10"/>
+          </p:nvPr>
+        </p:nvSpPr>
+        <p:spPr/>
+        <p:txBody>
+          <a:bodyPr/>
+          <a:lstStyle/>
+          <a:p>
+            <a:r>
+              <a:rPr lang="en-ID"/>
+              <a:t>27/02/2026</a:t>
+            </a:r>
+            <a:endParaRPr lang="en-ID" dirty="0"/>
+          </a:p>
+        </p:txBody>
+      </p:sp>
+      <p:sp>
+        <p:nvSpPr>
+          <p:cNvPr id="5" name="Footer Placeholder 4">
+            <a:extLst>
+              <a:ext uri="{FF2B5EF4-FFF2-40B4-BE49-F238E27FC236}">
+                <a16:creationId xmlns:a16="http://schemas.microsoft.com/office/drawing/2014/main" id="{C6385C48-8E72-5FA4-3DA7-C69DAF726B48}"/>
+              </a:ext>
+            </a:extLst>
+          </p:cNvPr>
+          <p:cNvSpPr>
+            <a:spLocks noGrp="1"/>
+          </p:cNvSpPr>
+          <p:nvPr>
+            <p:ph type="ftr" sz="quarter" idx="11"/>
+          </p:nvPr>
+        </p:nvSpPr>
+        <p:spPr/>
+        <p:txBody>
+          <a:bodyPr/>
+          <a:lstStyle/>
+          <a:p>
+            <a:r>
+              <a:rPr lang="en-ID"/>
+              <a:t>Git</a:t>
+            </a:r>
+            <a:endParaRPr lang="en-ID" dirty="0"/>
+          </a:p>
+        </p:txBody>
+      </p:sp>
+      <p:pic>
+        <p:nvPicPr>
+          <p:cNvPr id="8" name="Picture 7">
+            <a:extLst>
+              <a:ext uri="{FF2B5EF4-FFF2-40B4-BE49-F238E27FC236}">
+                <a16:creationId xmlns:a16="http://schemas.microsoft.com/office/drawing/2014/main" id="{618BC8E5-5F87-90C9-E3E0-8507103348D5}"/>
+              </a:ext>
+            </a:extLst>
+          </p:cNvPr>
+          <p:cNvPicPr>
+            <a:picLocks noChangeAspect="1"/>
+          </p:cNvPicPr>
+          <p:nvPr/>
+        </p:nvPicPr>
+        <p:blipFill>
+          <a:blip r:embed="rId2"/>
+          <a:stretch>
+            <a:fillRect/>
+          </a:stretch>
+        </p:blipFill>
+        <p:spPr>
+          <a:xfrm>
+            <a:off x="5860025" y="1870075"/>
+            <a:ext cx="6007510" cy="3158588"/>
+          </a:xfrm>
+          <a:prstGeom prst="rect">
+            <a:avLst/>
+          </a:prstGeom>
+        </p:spPr>
+      </p:pic>
+    </p:spTree>
+    <p:extLst>
+      <p:ext uri="{BB962C8B-B14F-4D97-AF65-F5344CB8AC3E}">
+        <p14:creationId xmlns:p14="http://schemas.microsoft.com/office/powerpoint/2010/main" val="3793814676"/>
+      </p:ext>
+    </p:extLst>
+  </p:cSld>
+  <p:clrMapOvr>
+    <a:masterClrMapping/>
+  </p:clrMapOvr>
+</p:sld>
+</file>
+
+<file path=ppt/slides/slide44.xml><?xml version="1.0" encoding="utf-8"?>
+<p:sld xmlns:a="http://schemas.openxmlformats.org/drawingml/2006/main" xmlns:r="http://schemas.openxmlformats.org/officeDocument/2006/relationships" xmlns:p="http://schemas.openxmlformats.org/presentationml/2006/main">
+  <p:cSld>
+    <p:spTree>
+      <p:nvGrpSpPr>
+        <p:cNvPr id="1" name="">
+          <a:extLst>
+            <a:ext uri="{FF2B5EF4-FFF2-40B4-BE49-F238E27FC236}">
+              <a16:creationId xmlns:a16="http://schemas.microsoft.com/office/drawing/2014/main" id="{7A959400-E380-E1B7-1F20-C5F159180D3B}"/>
+            </a:ext>
+          </a:extLst>
+        </p:cNvPr>
+        <p:cNvGrpSpPr/>
+        <p:nvPr/>
+      </p:nvGrpSpPr>
+      <p:grpSpPr>
+        <a:xfrm>
+          <a:off x="0" y="0"/>
+          <a:ext cx="0" cy="0"/>
+          <a:chOff x="0" y="0"/>
+          <a:chExt cx="0" cy="0"/>
+        </a:xfrm>
+      </p:grpSpPr>
+      <p:sp>
+        <p:nvSpPr>
+          <p:cNvPr id="2" name="Title 1">
+            <a:extLst>
+              <a:ext uri="{FF2B5EF4-FFF2-40B4-BE49-F238E27FC236}">
+                <a16:creationId xmlns:a16="http://schemas.microsoft.com/office/drawing/2014/main" id="{C6D3A4EE-1E81-AF97-B93A-8A273A0479E5}"/>
+              </a:ext>
+            </a:extLst>
+          </p:cNvPr>
+          <p:cNvSpPr>
+            <a:spLocks noGrp="1"/>
+          </p:cNvSpPr>
+          <p:nvPr>
+            <p:ph type="title"/>
+          </p:nvPr>
+        </p:nvSpPr>
+        <p:spPr/>
+        <p:txBody>
+          <a:bodyPr/>
+          <a:lstStyle/>
+          <a:p>
+            <a:r>
+              <a:rPr lang="en-US" dirty="0"/>
+              <a:t>In Depth: </a:t>
+            </a:r>
+            <a:r>
+              <a:rPr lang="en-US" dirty="0" err="1"/>
+              <a:t>gitlab</a:t>
+            </a:r>
+            <a:r>
+              <a:rPr lang="en-US" dirty="0"/>
+              <a:t> issue</a:t>
+            </a:r>
+            <a:endParaRPr lang="en-ID" dirty="0"/>
+          </a:p>
+        </p:txBody>
+      </p:sp>
+      <p:sp>
+        <p:nvSpPr>
+          <p:cNvPr id="3" name="Content Placeholder 2">
+            <a:extLst>
+              <a:ext uri="{FF2B5EF4-FFF2-40B4-BE49-F238E27FC236}">
+                <a16:creationId xmlns:a16="http://schemas.microsoft.com/office/drawing/2014/main" id="{DB3D690B-7808-BD68-2CB6-D20BE8965521}"/>
+              </a:ext>
+            </a:extLst>
+          </p:cNvPr>
+          <p:cNvSpPr>
+            <a:spLocks noGrp="1"/>
+          </p:cNvSpPr>
+          <p:nvPr>
+            <p:ph idx="1"/>
+          </p:nvPr>
+        </p:nvSpPr>
+        <p:spPr>
+          <a:xfrm>
+            <a:off x="838200" y="1825625"/>
+            <a:ext cx="5749413" cy="4351338"/>
+          </a:xfrm>
+        </p:spPr>
+        <p:txBody>
+          <a:bodyPr/>
+          <a:lstStyle/>
+          <a:p>
+            <a:r>
+              <a:rPr lang="en-US" dirty="0" err="1"/>
+              <a:t>Tempat</a:t>
+            </a:r>
+            <a:r>
+              <a:rPr lang="en-US" dirty="0"/>
+              <a:t> </a:t>
+            </a:r>
+            <a:r>
+              <a:rPr lang="en-US" dirty="0" err="1"/>
+              <a:t>membuat</a:t>
+            </a:r>
+            <a:r>
+              <a:rPr lang="en-US" dirty="0"/>
+              <a:t> task</a:t>
+            </a:r>
+          </a:p>
+          <a:p>
+            <a:r>
+              <a:rPr lang="en-US" dirty="0" err="1"/>
+              <a:t>Tempat</a:t>
+            </a:r>
+            <a:r>
+              <a:rPr lang="en-US" dirty="0"/>
+              <a:t> </a:t>
+            </a:r>
+            <a:r>
+              <a:rPr lang="en-US" dirty="0" err="1"/>
+              <a:t>membuat</a:t>
+            </a:r>
+            <a:r>
+              <a:rPr lang="en-US" dirty="0"/>
+              <a:t> “ticket”</a:t>
+            </a:r>
+          </a:p>
+          <a:p>
+            <a:r>
+              <a:rPr lang="en-US" dirty="0" err="1"/>
+              <a:t>Tempat</a:t>
+            </a:r>
+            <a:r>
+              <a:rPr lang="en-US" dirty="0"/>
+              <a:t> </a:t>
+            </a:r>
+            <a:r>
+              <a:rPr lang="en-US" dirty="0" err="1"/>
+              <a:t>protes</a:t>
+            </a:r>
+            <a:r>
+              <a:rPr lang="en-US" dirty="0"/>
+              <a:t> (</a:t>
+            </a:r>
+            <a:r>
+              <a:rPr lang="en-US" dirty="0" err="1"/>
+              <a:t>ke</a:t>
+            </a:r>
+            <a:r>
+              <a:rPr lang="en-US" dirty="0"/>
+              <a:t> open source project)</a:t>
+            </a:r>
+          </a:p>
+          <a:p>
+            <a:r>
+              <a:rPr lang="en-US" dirty="0" err="1"/>
+              <a:t>Tempat</a:t>
+            </a:r>
+            <a:r>
+              <a:rPr lang="en-US" dirty="0"/>
+              <a:t> </a:t>
+            </a:r>
+            <a:r>
+              <a:rPr lang="en-US" dirty="0" err="1"/>
+              <a:t>bertanya</a:t>
+            </a:r>
+            <a:r>
+              <a:rPr lang="en-US" dirty="0"/>
+              <a:t> (</a:t>
+            </a:r>
+            <a:r>
+              <a:rPr lang="en-US" dirty="0" err="1"/>
+              <a:t>ke</a:t>
+            </a:r>
+            <a:r>
+              <a:rPr lang="en-US" dirty="0"/>
+              <a:t> OSS)</a:t>
+            </a:r>
+            <a:endParaRPr lang="en-ID" dirty="0"/>
+          </a:p>
+        </p:txBody>
+      </p:sp>
+      <p:sp>
+        <p:nvSpPr>
+          <p:cNvPr id="4" name="Date Placeholder 3">
+            <a:extLst>
+              <a:ext uri="{FF2B5EF4-FFF2-40B4-BE49-F238E27FC236}">
+                <a16:creationId xmlns:a16="http://schemas.microsoft.com/office/drawing/2014/main" id="{0A399ECD-CE92-FFD5-5858-452640DBC184}"/>
+              </a:ext>
+            </a:extLst>
+          </p:cNvPr>
+          <p:cNvSpPr>
+            <a:spLocks noGrp="1"/>
+          </p:cNvSpPr>
+          <p:nvPr>
+            <p:ph type="dt" sz="half" idx="10"/>
+          </p:nvPr>
+        </p:nvSpPr>
+        <p:spPr/>
+        <p:txBody>
+          <a:bodyPr/>
+          <a:lstStyle/>
+          <a:p>
+            <a:r>
+              <a:rPr lang="en-ID"/>
+              <a:t>27/02/2026</a:t>
+            </a:r>
+            <a:endParaRPr lang="en-ID" dirty="0"/>
+          </a:p>
+        </p:txBody>
+      </p:sp>
+      <p:sp>
+        <p:nvSpPr>
+          <p:cNvPr id="5" name="Footer Placeholder 4">
+            <a:extLst>
+              <a:ext uri="{FF2B5EF4-FFF2-40B4-BE49-F238E27FC236}">
+                <a16:creationId xmlns:a16="http://schemas.microsoft.com/office/drawing/2014/main" id="{C001ED61-F666-CFBC-AEDE-FC8BD278789C}"/>
+              </a:ext>
+            </a:extLst>
+          </p:cNvPr>
+          <p:cNvSpPr>
+            <a:spLocks noGrp="1"/>
+          </p:cNvSpPr>
+          <p:nvPr>
+            <p:ph type="ftr" sz="quarter" idx="11"/>
+          </p:nvPr>
+        </p:nvSpPr>
+        <p:spPr/>
+        <p:txBody>
+          <a:bodyPr/>
+          <a:lstStyle/>
+          <a:p>
+            <a:r>
+              <a:rPr lang="en-ID"/>
+              <a:t>Git</a:t>
+            </a:r>
+            <a:endParaRPr lang="en-ID" dirty="0"/>
+          </a:p>
+        </p:txBody>
+      </p:sp>
+      <p:pic>
+        <p:nvPicPr>
+          <p:cNvPr id="10" name="Picture 9">
+            <a:extLst>
+              <a:ext uri="{FF2B5EF4-FFF2-40B4-BE49-F238E27FC236}">
+                <a16:creationId xmlns:a16="http://schemas.microsoft.com/office/drawing/2014/main" id="{C51DEF34-D11B-25EA-690D-94D51BBF7762}"/>
+              </a:ext>
+            </a:extLst>
+          </p:cNvPr>
+          <p:cNvPicPr>
+            <a:picLocks noChangeAspect="1"/>
+          </p:cNvPicPr>
+          <p:nvPr/>
+        </p:nvPicPr>
+        <p:blipFill>
+          <a:blip r:embed="rId2"/>
+          <a:stretch>
+            <a:fillRect/>
+          </a:stretch>
+        </p:blipFill>
+        <p:spPr>
+          <a:xfrm>
+            <a:off x="5884357" y="1870075"/>
+            <a:ext cx="5884856" cy="2534843"/>
+          </a:xfrm>
+          <a:prstGeom prst="rect">
+            <a:avLst/>
+          </a:prstGeom>
+        </p:spPr>
+      </p:pic>
+    </p:spTree>
+    <p:extLst>
+      <p:ext uri="{BB962C8B-B14F-4D97-AF65-F5344CB8AC3E}">
+        <p14:creationId xmlns:p14="http://schemas.microsoft.com/office/powerpoint/2010/main" val="797282480"/>
+      </p:ext>
+    </p:extLst>
+  </p:cSld>
+  <p:clrMapOvr>
+    <a:masterClrMapping/>
+  </p:clrMapOvr>
+</p:sld>
+</file>
+
+<file path=ppt/slides/slide45.xml><?xml version="1.0" encoding="utf-8"?>
+<p:sld xmlns:a="http://schemas.openxmlformats.org/drawingml/2006/main" xmlns:r="http://schemas.openxmlformats.org/officeDocument/2006/relationships" xmlns:p="http://schemas.openxmlformats.org/presentationml/2006/main">
+  <p:cSld>
+    <p:spTree>
+      <p:nvGrpSpPr>
+        <p:cNvPr id="1" name="">
+          <a:extLst>
+            <a:ext uri="{FF2B5EF4-FFF2-40B4-BE49-F238E27FC236}">
+              <a16:creationId xmlns:a16="http://schemas.microsoft.com/office/drawing/2014/main" id="{BE29A7EF-1461-0C43-139E-FED67A753BE9}"/>
+            </a:ext>
+          </a:extLst>
+        </p:cNvPr>
+        <p:cNvGrpSpPr/>
+        <p:nvPr/>
+      </p:nvGrpSpPr>
+      <p:grpSpPr>
+        <a:xfrm>
+          <a:off x="0" y="0"/>
+          <a:ext cx="0" cy="0"/>
+          <a:chOff x="0" y="0"/>
+          <a:chExt cx="0" cy="0"/>
+        </a:xfrm>
+      </p:grpSpPr>
+      <p:sp>
+        <p:nvSpPr>
+          <p:cNvPr id="2" name="Title 1">
+            <a:extLst>
+              <a:ext uri="{FF2B5EF4-FFF2-40B4-BE49-F238E27FC236}">
+                <a16:creationId xmlns:a16="http://schemas.microsoft.com/office/drawing/2014/main" id="{9A7909FE-1519-3FA1-5FBF-9D97BAEB1D69}"/>
+              </a:ext>
+            </a:extLst>
+          </p:cNvPr>
+          <p:cNvSpPr>
+            <a:spLocks noGrp="1"/>
+          </p:cNvSpPr>
+          <p:nvPr>
+            <p:ph type="title"/>
+          </p:nvPr>
+        </p:nvSpPr>
+        <p:spPr/>
+        <p:txBody>
+          <a:bodyPr/>
+          <a:lstStyle/>
+          <a:p>
+            <a:r>
+              <a:rPr lang="en-US" dirty="0"/>
+              <a:t>In Depth: </a:t>
+            </a:r>
+            <a:r>
+              <a:rPr lang="en-US" dirty="0" err="1"/>
+              <a:t>gitlab</a:t>
+            </a:r>
+            <a:r>
+              <a:rPr lang="en-US" dirty="0"/>
+              <a:t> Merge request</a:t>
+            </a:r>
+            <a:endParaRPr lang="en-ID" dirty="0"/>
+          </a:p>
+        </p:txBody>
+      </p:sp>
+      <p:sp>
+        <p:nvSpPr>
+          <p:cNvPr id="3" name="Content Placeholder 2">
+            <a:extLst>
+              <a:ext uri="{FF2B5EF4-FFF2-40B4-BE49-F238E27FC236}">
+                <a16:creationId xmlns:a16="http://schemas.microsoft.com/office/drawing/2014/main" id="{13C60752-2BEA-2EE2-AF78-CD5AE14610DC}"/>
+              </a:ext>
+            </a:extLst>
+          </p:cNvPr>
+          <p:cNvSpPr>
+            <a:spLocks noGrp="1"/>
+          </p:cNvSpPr>
+          <p:nvPr>
+            <p:ph idx="1"/>
+          </p:nvPr>
+        </p:nvSpPr>
+        <p:spPr>
+          <a:xfrm>
+            <a:off x="838200" y="1825625"/>
+            <a:ext cx="5749413" cy="4351338"/>
+          </a:xfrm>
+        </p:spPr>
+        <p:txBody>
+          <a:bodyPr/>
+          <a:lstStyle/>
+          <a:p>
+            <a:r>
+              <a:rPr lang="en-US" dirty="0"/>
+              <a:t>Proses </a:t>
+            </a:r>
+            <a:r>
+              <a:rPr lang="en-US" dirty="0" err="1"/>
+              <a:t>sebelum</a:t>
+            </a:r>
+            <a:r>
+              <a:rPr lang="en-US" dirty="0"/>
+              <a:t> Merge</a:t>
+            </a:r>
+          </a:p>
+          <a:p>
+            <a:r>
+              <a:rPr lang="en-US" dirty="0"/>
+              <a:t>Kalau di local </a:t>
+            </a:r>
+            <a:r>
+              <a:rPr lang="en-US" dirty="0" err="1"/>
+              <a:t>ngga</a:t>
+            </a:r>
+            <a:r>
+              <a:rPr lang="en-US" dirty="0"/>
+              <a:t> </a:t>
+            </a:r>
+            <a:r>
+              <a:rPr lang="en-US" dirty="0" err="1"/>
+              <a:t>ada</a:t>
+            </a:r>
+            <a:r>
+              <a:rPr lang="en-US" dirty="0"/>
+              <a:t> </a:t>
+            </a:r>
+            <a:r>
+              <a:rPr lang="en-US" dirty="0" err="1"/>
+              <a:t>fitur</a:t>
+            </a:r>
+            <a:r>
+              <a:rPr lang="en-US" dirty="0"/>
+              <a:t> preview</a:t>
+            </a:r>
+          </a:p>
+          <a:p>
+            <a:r>
+              <a:rPr lang="en-US" dirty="0"/>
+              <a:t>Preview </a:t>
+            </a:r>
+            <a:r>
+              <a:rPr lang="en-US" dirty="0" err="1"/>
+              <a:t>sebelum</a:t>
+            </a:r>
+            <a:r>
+              <a:rPr lang="en-US" dirty="0"/>
+              <a:t> </a:t>
+            </a:r>
+            <a:r>
+              <a:rPr lang="en-US" dirty="0" err="1"/>
+              <a:t>melanjutkan</a:t>
+            </a:r>
+            <a:r>
+              <a:rPr lang="en-US" dirty="0"/>
+              <a:t> merge</a:t>
+            </a:r>
+          </a:p>
+          <a:p>
+            <a:pPr lvl="1"/>
+            <a:r>
+              <a:rPr lang="en-US" dirty="0"/>
+              <a:t>Apakah </a:t>
+            </a:r>
+            <a:r>
+              <a:rPr lang="en-US" dirty="0" err="1"/>
+              <a:t>bagus</a:t>
+            </a:r>
+            <a:r>
+              <a:rPr lang="en-US" dirty="0"/>
+              <a:t>? Apakah conflict?</a:t>
+            </a:r>
+            <a:endParaRPr lang="en-ID" dirty="0"/>
+          </a:p>
+        </p:txBody>
+      </p:sp>
+      <p:sp>
+        <p:nvSpPr>
+          <p:cNvPr id="4" name="Date Placeholder 3">
+            <a:extLst>
+              <a:ext uri="{FF2B5EF4-FFF2-40B4-BE49-F238E27FC236}">
+                <a16:creationId xmlns:a16="http://schemas.microsoft.com/office/drawing/2014/main" id="{D1B435AC-C785-97FF-9407-33CDFF962069}"/>
+              </a:ext>
+            </a:extLst>
+          </p:cNvPr>
+          <p:cNvSpPr>
+            <a:spLocks noGrp="1"/>
+          </p:cNvSpPr>
+          <p:nvPr>
+            <p:ph type="dt" sz="half" idx="10"/>
+          </p:nvPr>
+        </p:nvSpPr>
+        <p:spPr/>
+        <p:txBody>
+          <a:bodyPr/>
+          <a:lstStyle/>
+          <a:p>
+            <a:r>
+              <a:rPr lang="en-ID"/>
+              <a:t>27/02/2026</a:t>
+            </a:r>
+            <a:endParaRPr lang="en-ID" dirty="0"/>
+          </a:p>
+        </p:txBody>
+      </p:sp>
+      <p:sp>
+        <p:nvSpPr>
+          <p:cNvPr id="5" name="Footer Placeholder 4">
+            <a:extLst>
+              <a:ext uri="{FF2B5EF4-FFF2-40B4-BE49-F238E27FC236}">
+                <a16:creationId xmlns:a16="http://schemas.microsoft.com/office/drawing/2014/main" id="{18901E06-47A2-4180-CD9D-6067C1007CE3}"/>
+              </a:ext>
+            </a:extLst>
+          </p:cNvPr>
+          <p:cNvSpPr>
+            <a:spLocks noGrp="1"/>
+          </p:cNvSpPr>
+          <p:nvPr>
+            <p:ph type="ftr" sz="quarter" idx="11"/>
+          </p:nvPr>
+        </p:nvSpPr>
+        <p:spPr/>
+        <p:txBody>
+          <a:bodyPr/>
+          <a:lstStyle/>
+          <a:p>
+            <a:r>
+              <a:rPr lang="en-ID"/>
+              <a:t>Git</a:t>
+            </a:r>
+            <a:endParaRPr lang="en-ID" dirty="0"/>
+          </a:p>
+        </p:txBody>
+      </p:sp>
+    </p:spTree>
+    <p:extLst>
+      <p:ext uri="{BB962C8B-B14F-4D97-AF65-F5344CB8AC3E}">
+        <p14:creationId xmlns:p14="http://schemas.microsoft.com/office/powerpoint/2010/main" val="1231456344"/>
+      </p:ext>
+    </p:extLst>
+  </p:cSld>
+  <p:clrMapOvr>
+    <a:masterClrMapping/>
+  </p:clrMapOvr>
+</p:sld>
+</file>
+
+<file path=ppt/slides/slide46.xml><?xml version="1.0" encoding="utf-8"?>
+<p:sld xmlns:a="http://schemas.openxmlformats.org/drawingml/2006/main" xmlns:r="http://schemas.openxmlformats.org/officeDocument/2006/relationships" xmlns:p="http://schemas.openxmlformats.org/presentationml/2006/main">
+  <p:cSld>
+    <p:spTree>
+      <p:nvGrpSpPr>
+        <p:cNvPr id="1" name="">
+          <a:extLst>
+            <a:ext uri="{FF2B5EF4-FFF2-40B4-BE49-F238E27FC236}">
+              <a16:creationId xmlns:a16="http://schemas.microsoft.com/office/drawing/2014/main" id="{AFE6AA0A-B99F-755A-BD2E-BD2A03F50B85}"/>
+            </a:ext>
+          </a:extLst>
+        </p:cNvPr>
+        <p:cNvGrpSpPr/>
+        <p:nvPr/>
+      </p:nvGrpSpPr>
+      <p:grpSpPr>
+        <a:xfrm>
+          <a:off x="0" y="0"/>
+          <a:ext cx="0" cy="0"/>
+          <a:chOff x="0" y="0"/>
+          <a:chExt cx="0" cy="0"/>
+        </a:xfrm>
+      </p:grpSpPr>
+      <p:sp>
+        <p:nvSpPr>
+          <p:cNvPr id="2" name="Title 1">
+            <a:extLst>
+              <a:ext uri="{FF2B5EF4-FFF2-40B4-BE49-F238E27FC236}">
+                <a16:creationId xmlns:a16="http://schemas.microsoft.com/office/drawing/2014/main" id="{7700E079-A89B-8D95-8950-3DF87529C30E}"/>
+              </a:ext>
+            </a:extLst>
+          </p:cNvPr>
+          <p:cNvSpPr>
+            <a:spLocks noGrp="1"/>
+          </p:cNvSpPr>
+          <p:nvPr>
+            <p:ph type="title"/>
+          </p:nvPr>
+        </p:nvSpPr>
+        <p:spPr/>
+        <p:txBody>
+          <a:bodyPr/>
+          <a:lstStyle/>
+          <a:p>
+            <a:r>
+              <a:rPr lang="en-US" dirty="0"/>
+              <a:t>In Depth: </a:t>
+            </a:r>
+            <a:r>
+              <a:rPr lang="en-US" dirty="0" err="1"/>
+              <a:t>gitlab</a:t>
+            </a:r>
+            <a:r>
+              <a:rPr lang="en-US" dirty="0"/>
+              <a:t> Plan</a:t>
+            </a:r>
+            <a:endParaRPr lang="en-ID" dirty="0"/>
+          </a:p>
+        </p:txBody>
+      </p:sp>
+      <p:sp>
+        <p:nvSpPr>
+          <p:cNvPr id="3" name="Content Placeholder 2">
+            <a:extLst>
+              <a:ext uri="{FF2B5EF4-FFF2-40B4-BE49-F238E27FC236}">
+                <a16:creationId xmlns:a16="http://schemas.microsoft.com/office/drawing/2014/main" id="{64D6DD0A-51D5-E495-EE13-906702FA00C0}"/>
+              </a:ext>
+            </a:extLst>
+          </p:cNvPr>
+          <p:cNvSpPr>
+            <a:spLocks noGrp="1"/>
+          </p:cNvSpPr>
+          <p:nvPr>
+            <p:ph idx="1"/>
+          </p:nvPr>
+        </p:nvSpPr>
+        <p:spPr>
+          <a:xfrm>
+            <a:off x="838200" y="1825625"/>
+            <a:ext cx="5749413" cy="4351338"/>
+          </a:xfrm>
+        </p:spPr>
+        <p:txBody>
+          <a:bodyPr/>
+          <a:lstStyle/>
+          <a:p>
+            <a:r>
+              <a:rPr lang="en-US" dirty="0" err="1"/>
+              <a:t>Tempat</a:t>
+            </a:r>
+            <a:r>
+              <a:rPr lang="en-US" dirty="0"/>
+              <a:t> </a:t>
+            </a:r>
+            <a:r>
+              <a:rPr lang="en-US" dirty="0" err="1"/>
+              <a:t>mengatur</a:t>
+            </a:r>
+            <a:r>
+              <a:rPr lang="en-US" dirty="0"/>
+              <a:t> planning </a:t>
+            </a:r>
+            <a:r>
+              <a:rPr lang="en-US" dirty="0" err="1"/>
+              <a:t>kedepannya</a:t>
+            </a:r>
+            <a:endParaRPr lang="en-US" dirty="0"/>
+          </a:p>
+          <a:p>
+            <a:r>
+              <a:rPr lang="en-US" dirty="0" err="1"/>
+              <a:t>Untuk</a:t>
+            </a:r>
+            <a:r>
+              <a:rPr lang="en-US" dirty="0"/>
+              <a:t> </a:t>
+            </a:r>
+            <a:r>
+              <a:rPr lang="en-US" dirty="0" err="1"/>
+              <a:t>visualisasi</a:t>
+            </a:r>
+            <a:r>
+              <a:rPr lang="en-US" dirty="0"/>
+              <a:t> mana </a:t>
+            </a:r>
+            <a:r>
+              <a:rPr lang="en-US" dirty="0" err="1"/>
+              <a:t>fitur</a:t>
+            </a:r>
+            <a:r>
+              <a:rPr lang="en-US" dirty="0"/>
+              <a:t>/task yang </a:t>
+            </a:r>
+            <a:r>
+              <a:rPr lang="en-US" dirty="0" err="1"/>
+              <a:t>sedang</a:t>
+            </a:r>
+            <a:r>
+              <a:rPr lang="en-US" dirty="0"/>
+              <a:t>/</a:t>
+            </a:r>
+            <a:r>
+              <a:rPr lang="en-US" dirty="0" err="1"/>
+              <a:t>akan</a:t>
+            </a:r>
+            <a:r>
+              <a:rPr lang="en-US" dirty="0"/>
+              <a:t> </a:t>
+            </a:r>
+            <a:r>
+              <a:rPr lang="en-US" dirty="0" err="1"/>
+              <a:t>dikerjakan</a:t>
+            </a:r>
+            <a:endParaRPr lang="en-US" dirty="0"/>
+          </a:p>
+          <a:p>
+            <a:r>
+              <a:rPr lang="en-US" dirty="0" err="1"/>
+              <a:t>Mirip</a:t>
+            </a:r>
+            <a:r>
+              <a:rPr lang="en-US" dirty="0"/>
+              <a:t> Jira </a:t>
+            </a:r>
+            <a:r>
+              <a:rPr lang="en-US" dirty="0" err="1"/>
+              <a:t>tapi</a:t>
+            </a:r>
+            <a:r>
+              <a:rPr lang="en-US" dirty="0"/>
+              <a:t> integrated</a:t>
+            </a:r>
+          </a:p>
+          <a:p>
+            <a:r>
+              <a:rPr lang="en-US" dirty="0"/>
+              <a:t>Bisa </a:t>
+            </a:r>
+            <a:r>
+              <a:rPr lang="en-US" dirty="0" err="1"/>
+              <a:t>ada</a:t>
+            </a:r>
+            <a:r>
+              <a:rPr lang="en-US" dirty="0"/>
+              <a:t> chart </a:t>
+            </a:r>
+            <a:r>
+              <a:rPr lang="en-US" dirty="0" err="1"/>
+              <a:t>nya</a:t>
+            </a:r>
+            <a:r>
+              <a:rPr lang="en-US" dirty="0"/>
+              <a:t> juga</a:t>
+            </a:r>
+            <a:endParaRPr lang="en-ID" dirty="0"/>
+          </a:p>
+        </p:txBody>
+      </p:sp>
+      <p:sp>
+        <p:nvSpPr>
+          <p:cNvPr id="4" name="Date Placeholder 3">
+            <a:extLst>
+              <a:ext uri="{FF2B5EF4-FFF2-40B4-BE49-F238E27FC236}">
+                <a16:creationId xmlns:a16="http://schemas.microsoft.com/office/drawing/2014/main" id="{3228F1D4-7A41-CE5F-0A06-11D1EFFA8B9F}"/>
+              </a:ext>
+            </a:extLst>
+          </p:cNvPr>
+          <p:cNvSpPr>
+            <a:spLocks noGrp="1"/>
+          </p:cNvSpPr>
+          <p:nvPr>
+            <p:ph type="dt" sz="half" idx="10"/>
+          </p:nvPr>
+        </p:nvSpPr>
+        <p:spPr/>
+        <p:txBody>
+          <a:bodyPr/>
+          <a:lstStyle/>
+          <a:p>
+            <a:r>
+              <a:rPr lang="en-ID"/>
+              <a:t>27/02/2026</a:t>
+            </a:r>
+            <a:endParaRPr lang="en-ID" dirty="0"/>
+          </a:p>
+        </p:txBody>
+      </p:sp>
+      <p:sp>
+        <p:nvSpPr>
+          <p:cNvPr id="5" name="Footer Placeholder 4">
+            <a:extLst>
+              <a:ext uri="{FF2B5EF4-FFF2-40B4-BE49-F238E27FC236}">
+                <a16:creationId xmlns:a16="http://schemas.microsoft.com/office/drawing/2014/main" id="{998F6A18-7F8F-4948-B921-AFC27770583F}"/>
+              </a:ext>
+            </a:extLst>
+          </p:cNvPr>
+          <p:cNvSpPr>
+            <a:spLocks noGrp="1"/>
+          </p:cNvSpPr>
+          <p:nvPr>
+            <p:ph type="ftr" sz="quarter" idx="11"/>
+          </p:nvPr>
+        </p:nvSpPr>
+        <p:spPr/>
+        <p:txBody>
+          <a:bodyPr/>
+          <a:lstStyle/>
+          <a:p>
+            <a:r>
+              <a:rPr lang="en-ID"/>
+              <a:t>Git</a:t>
+            </a:r>
+            <a:endParaRPr lang="en-ID" dirty="0"/>
+          </a:p>
+        </p:txBody>
+      </p:sp>
+    </p:spTree>
+    <p:extLst>
+      <p:ext uri="{BB962C8B-B14F-4D97-AF65-F5344CB8AC3E}">
+        <p14:creationId xmlns:p14="http://schemas.microsoft.com/office/powerpoint/2010/main" val="111532372"/>
+      </p:ext>
+    </p:extLst>
+  </p:cSld>
+  <p:clrMapOvr>
+    <a:masterClrMapping/>
+  </p:clrMapOvr>
+</p:sld>
+</file>
+
+<file path=ppt/slides/slide47.xml><?xml version="1.0" encoding="utf-8"?>
+<p:sld xmlns:a="http://schemas.openxmlformats.org/drawingml/2006/main" xmlns:r="http://schemas.openxmlformats.org/officeDocument/2006/relationships" xmlns:p="http://schemas.openxmlformats.org/presentationml/2006/main">
+  <p:cSld>
+    <p:spTree>
+      <p:nvGrpSpPr>
+        <p:cNvPr id="1" name="">
+          <a:extLst>
+            <a:ext uri="{FF2B5EF4-FFF2-40B4-BE49-F238E27FC236}">
+              <a16:creationId xmlns:a16="http://schemas.microsoft.com/office/drawing/2014/main" id="{146D9B8B-11DD-A275-4D9F-1D6F10415A97}"/>
+            </a:ext>
+          </a:extLst>
+        </p:cNvPr>
+        <p:cNvGrpSpPr/>
+        <p:nvPr/>
+      </p:nvGrpSpPr>
+      <p:grpSpPr>
+        <a:xfrm>
+          <a:off x="0" y="0"/>
+          <a:ext cx="0" cy="0"/>
+          <a:chOff x="0" y="0"/>
+          <a:chExt cx="0" cy="0"/>
+        </a:xfrm>
+      </p:grpSpPr>
+      <p:sp>
+        <p:nvSpPr>
+          <p:cNvPr id="2" name="Title 1">
+            <a:extLst>
+              <a:ext uri="{FF2B5EF4-FFF2-40B4-BE49-F238E27FC236}">
+                <a16:creationId xmlns:a16="http://schemas.microsoft.com/office/drawing/2014/main" id="{BE469379-59C2-8539-1249-C3A60FCB7285}"/>
+              </a:ext>
+            </a:extLst>
+          </p:cNvPr>
+          <p:cNvSpPr>
+            <a:spLocks noGrp="1"/>
+          </p:cNvSpPr>
+          <p:nvPr>
+            <p:ph type="title"/>
+          </p:nvPr>
+        </p:nvSpPr>
+        <p:spPr/>
+        <p:txBody>
+          <a:bodyPr/>
+          <a:lstStyle/>
+          <a:p>
+            <a:r>
+              <a:rPr lang="en-US" dirty="0"/>
+              <a:t>In Depth: </a:t>
+            </a:r>
+            <a:r>
+              <a:rPr lang="en-US" dirty="0" err="1"/>
+              <a:t>gitlab</a:t>
+            </a:r>
+            <a:r>
+              <a:rPr lang="en-US" dirty="0"/>
+              <a:t> pages</a:t>
+            </a:r>
+            <a:endParaRPr lang="en-ID" dirty="0"/>
+          </a:p>
+        </p:txBody>
+      </p:sp>
+      <p:sp>
+        <p:nvSpPr>
+          <p:cNvPr id="3" name="Content Placeholder 2">
+            <a:extLst>
+              <a:ext uri="{FF2B5EF4-FFF2-40B4-BE49-F238E27FC236}">
+                <a16:creationId xmlns:a16="http://schemas.microsoft.com/office/drawing/2014/main" id="{471FD0BC-0C58-95D2-7E93-12DF33E73082}"/>
+              </a:ext>
+            </a:extLst>
+          </p:cNvPr>
+          <p:cNvSpPr>
+            <a:spLocks noGrp="1"/>
+          </p:cNvSpPr>
+          <p:nvPr>
+            <p:ph idx="1"/>
+          </p:nvPr>
+        </p:nvSpPr>
+        <p:spPr>
+          <a:xfrm>
+            <a:off x="838200" y="1825625"/>
+            <a:ext cx="5749413" cy="4351338"/>
+          </a:xfrm>
+        </p:spPr>
+        <p:txBody>
+          <a:bodyPr/>
+          <a:lstStyle/>
+          <a:p>
+            <a:r>
+              <a:rPr lang="en-US" dirty="0"/>
+              <a:t>Free hosting </a:t>
+            </a:r>
+            <a:r>
+              <a:rPr lang="en-US" dirty="0" err="1"/>
+              <a:t>untuk</a:t>
+            </a:r>
+            <a:r>
+              <a:rPr lang="en-US" dirty="0"/>
+              <a:t> static website</a:t>
+            </a:r>
+            <a:endParaRPr lang="en-ID" dirty="0"/>
+          </a:p>
+        </p:txBody>
+      </p:sp>
+      <p:sp>
+        <p:nvSpPr>
+          <p:cNvPr id="4" name="Date Placeholder 3">
+            <a:extLst>
+              <a:ext uri="{FF2B5EF4-FFF2-40B4-BE49-F238E27FC236}">
+                <a16:creationId xmlns:a16="http://schemas.microsoft.com/office/drawing/2014/main" id="{AE91A228-66EE-B611-48A2-E84CCCFFA53B}"/>
+              </a:ext>
+            </a:extLst>
+          </p:cNvPr>
+          <p:cNvSpPr>
+            <a:spLocks noGrp="1"/>
+          </p:cNvSpPr>
+          <p:nvPr>
+            <p:ph type="dt" sz="half" idx="10"/>
+          </p:nvPr>
+        </p:nvSpPr>
+        <p:spPr/>
+        <p:txBody>
+          <a:bodyPr/>
+          <a:lstStyle/>
+          <a:p>
+            <a:r>
+              <a:rPr lang="en-ID"/>
+              <a:t>27/02/2026</a:t>
+            </a:r>
+            <a:endParaRPr lang="en-ID" dirty="0"/>
+          </a:p>
+        </p:txBody>
+      </p:sp>
+      <p:sp>
+        <p:nvSpPr>
+          <p:cNvPr id="5" name="Footer Placeholder 4">
+            <a:extLst>
+              <a:ext uri="{FF2B5EF4-FFF2-40B4-BE49-F238E27FC236}">
+                <a16:creationId xmlns:a16="http://schemas.microsoft.com/office/drawing/2014/main" id="{30B70D7C-8809-2F68-9CFC-2A668D81CC28}"/>
+              </a:ext>
+            </a:extLst>
+          </p:cNvPr>
+          <p:cNvSpPr>
+            <a:spLocks noGrp="1"/>
+          </p:cNvSpPr>
+          <p:nvPr>
+            <p:ph type="ftr" sz="quarter" idx="11"/>
+          </p:nvPr>
+        </p:nvSpPr>
+        <p:spPr/>
+        <p:txBody>
+          <a:bodyPr/>
+          <a:lstStyle/>
+          <a:p>
+            <a:r>
+              <a:rPr lang="en-ID"/>
+              <a:t>Git</a:t>
+            </a:r>
+            <a:endParaRPr lang="en-ID" dirty="0"/>
+          </a:p>
+        </p:txBody>
+      </p:sp>
+    </p:spTree>
+    <p:extLst>
+      <p:ext uri="{BB962C8B-B14F-4D97-AF65-F5344CB8AC3E}">
+        <p14:creationId xmlns:p14="http://schemas.microsoft.com/office/powerpoint/2010/main" val="450528783"/>
+      </p:ext>
+    </p:extLst>
+  </p:cSld>
+  <p:clrMapOvr>
+    <a:masterClrMapping/>
+  </p:clrMapOvr>
+</p:sld>
+</file>
+
+<file path=ppt/slides/slide48.xml><?xml version="1.0" encoding="utf-8"?>
+<p:sld xmlns:a="http://schemas.openxmlformats.org/drawingml/2006/main" xmlns:r="http://schemas.openxmlformats.org/officeDocument/2006/relationships" xmlns:p="http://schemas.openxmlformats.org/presentationml/2006/main">
+  <p:cSld>
+    <p:spTree>
+      <p:nvGrpSpPr>
+        <p:cNvPr id="1" name="">
+          <a:extLst>
+            <a:ext uri="{FF2B5EF4-FFF2-40B4-BE49-F238E27FC236}">
+              <a16:creationId xmlns:a16="http://schemas.microsoft.com/office/drawing/2014/main" id="{327B288B-7C0A-1062-BCC8-4418BBC28F7F}"/>
+            </a:ext>
+          </a:extLst>
+        </p:cNvPr>
+        <p:cNvGrpSpPr/>
+        <p:nvPr/>
+      </p:nvGrpSpPr>
+      <p:grpSpPr>
+        <a:xfrm>
+          <a:off x="0" y="0"/>
+          <a:ext cx="0" cy="0"/>
+          <a:chOff x="0" y="0"/>
+          <a:chExt cx="0" cy="0"/>
+        </a:xfrm>
+      </p:grpSpPr>
+      <p:sp>
+        <p:nvSpPr>
+          <p:cNvPr id="2" name="Title 1">
+            <a:extLst>
+              <a:ext uri="{FF2B5EF4-FFF2-40B4-BE49-F238E27FC236}">
+                <a16:creationId xmlns:a16="http://schemas.microsoft.com/office/drawing/2014/main" id="{BC096B87-ACAC-7F63-01D7-B6E406E6B697}"/>
+              </a:ext>
+            </a:extLst>
+          </p:cNvPr>
+          <p:cNvSpPr>
+            <a:spLocks noGrp="1"/>
+          </p:cNvSpPr>
+          <p:nvPr>
+            <p:ph type="title"/>
+          </p:nvPr>
+        </p:nvSpPr>
+        <p:spPr/>
+        <p:txBody>
+          <a:bodyPr/>
+          <a:lstStyle/>
+          <a:p>
+            <a:r>
+              <a:rPr lang="en-US" dirty="0"/>
+              <a:t>In Depth: </a:t>
+            </a:r>
+            <a:r>
+              <a:rPr lang="en-US" dirty="0" err="1"/>
+              <a:t>gitlab</a:t>
+            </a:r>
+            <a:r>
+              <a:rPr lang="en-US" dirty="0"/>
+              <a:t> job and pipeline</a:t>
+            </a:r>
+            <a:endParaRPr lang="en-ID" dirty="0"/>
+          </a:p>
+        </p:txBody>
+      </p:sp>
+      <p:sp>
+        <p:nvSpPr>
+          <p:cNvPr id="3" name="Content Placeholder 2">
+            <a:extLst>
+              <a:ext uri="{FF2B5EF4-FFF2-40B4-BE49-F238E27FC236}">
+                <a16:creationId xmlns:a16="http://schemas.microsoft.com/office/drawing/2014/main" id="{BB7252E5-1221-D3BF-88BE-E31CD504B181}"/>
+              </a:ext>
+            </a:extLst>
+          </p:cNvPr>
+          <p:cNvSpPr>
+            <a:spLocks noGrp="1"/>
+          </p:cNvSpPr>
+          <p:nvPr>
+            <p:ph idx="1"/>
+          </p:nvPr>
+        </p:nvSpPr>
+        <p:spPr>
+          <a:xfrm>
+            <a:off x="838200" y="1825625"/>
+            <a:ext cx="5749413" cy="4351338"/>
+          </a:xfrm>
+        </p:spPr>
+        <p:txBody>
+          <a:bodyPr/>
+          <a:lstStyle/>
+          <a:p>
+            <a:r>
+              <a:rPr lang="en-US" dirty="0"/>
+              <a:t>Automatic job yang di run </a:t>
+            </a:r>
+            <a:r>
+              <a:rPr lang="en-US" dirty="0" err="1"/>
+              <a:t>ketika</a:t>
+            </a:r>
+            <a:r>
+              <a:rPr lang="en-US" dirty="0"/>
+              <a:t> </a:t>
+            </a:r>
+            <a:r>
+              <a:rPr lang="en-US" dirty="0" err="1"/>
+              <a:t>ada</a:t>
+            </a:r>
+            <a:r>
+              <a:rPr lang="en-US" dirty="0"/>
+              <a:t> trigger</a:t>
+            </a:r>
+          </a:p>
+          <a:p>
+            <a:r>
+              <a:rPr lang="en-US" dirty="0"/>
+              <a:t>Misal:</a:t>
+            </a:r>
+          </a:p>
+          <a:p>
+            <a:pPr lvl="1"/>
+            <a:r>
+              <a:rPr lang="en-US" dirty="0"/>
+              <a:t>Auto run test</a:t>
+            </a:r>
+          </a:p>
+          <a:p>
+            <a:pPr lvl="1"/>
+            <a:r>
+              <a:rPr lang="en-US" dirty="0"/>
+              <a:t>Auto build</a:t>
+            </a:r>
+          </a:p>
+          <a:p>
+            <a:pPr lvl="1"/>
+            <a:r>
+              <a:rPr lang="en-US" dirty="0"/>
+              <a:t>Auto deploy</a:t>
+            </a:r>
+          </a:p>
+          <a:p>
+            <a:pPr lvl="1"/>
+            <a:r>
+              <a:rPr lang="en-US" dirty="0" err="1"/>
+              <a:t>etc</a:t>
+            </a:r>
+            <a:endParaRPr lang="en-ID" dirty="0"/>
+          </a:p>
+        </p:txBody>
+      </p:sp>
+      <p:sp>
+        <p:nvSpPr>
+          <p:cNvPr id="4" name="Date Placeholder 3">
+            <a:extLst>
+              <a:ext uri="{FF2B5EF4-FFF2-40B4-BE49-F238E27FC236}">
+                <a16:creationId xmlns:a16="http://schemas.microsoft.com/office/drawing/2014/main" id="{97438C47-3671-6D97-E8D1-B0C1BFCC75C4}"/>
+              </a:ext>
+            </a:extLst>
+          </p:cNvPr>
+          <p:cNvSpPr>
+            <a:spLocks noGrp="1"/>
+          </p:cNvSpPr>
+          <p:nvPr>
+            <p:ph type="dt" sz="half" idx="10"/>
+          </p:nvPr>
+        </p:nvSpPr>
+        <p:spPr/>
+        <p:txBody>
+          <a:bodyPr/>
+          <a:lstStyle/>
+          <a:p>
+            <a:r>
+              <a:rPr lang="en-ID"/>
+              <a:t>27/02/2026</a:t>
+            </a:r>
+            <a:endParaRPr lang="en-ID" dirty="0"/>
+          </a:p>
+        </p:txBody>
+      </p:sp>
+      <p:sp>
+        <p:nvSpPr>
+          <p:cNvPr id="5" name="Footer Placeholder 4">
+            <a:extLst>
+              <a:ext uri="{FF2B5EF4-FFF2-40B4-BE49-F238E27FC236}">
+                <a16:creationId xmlns:a16="http://schemas.microsoft.com/office/drawing/2014/main" id="{CDA80289-C28E-4782-4480-78ECE6CA325A}"/>
+              </a:ext>
+            </a:extLst>
+          </p:cNvPr>
+          <p:cNvSpPr>
+            <a:spLocks noGrp="1"/>
+          </p:cNvSpPr>
+          <p:nvPr>
+            <p:ph type="ftr" sz="quarter" idx="11"/>
+          </p:nvPr>
+        </p:nvSpPr>
+        <p:spPr/>
+        <p:txBody>
+          <a:bodyPr/>
+          <a:lstStyle/>
+          <a:p>
+            <a:r>
+              <a:rPr lang="en-ID"/>
+              <a:t>Git</a:t>
+            </a:r>
+            <a:endParaRPr lang="en-ID" dirty="0"/>
+          </a:p>
+        </p:txBody>
+      </p:sp>
+    </p:spTree>
+    <p:extLst>
+      <p:ext uri="{BB962C8B-B14F-4D97-AF65-F5344CB8AC3E}">
+        <p14:creationId xmlns:p14="http://schemas.microsoft.com/office/powerpoint/2010/main" val="3225697656"/>
+      </p:ext>
+    </p:extLst>
+  </p:cSld>
+  <p:clrMapOvr>
+    <a:masterClrMapping/>
+  </p:clrMapOvr>
+</p:sld>
+</file>
+
+<file path=ppt/slides/slide49.xml><?xml version="1.0" encoding="utf-8"?>
+<p:sld xmlns:a="http://schemas.openxmlformats.org/drawingml/2006/main" xmlns:r="http://schemas.openxmlformats.org/officeDocument/2006/relationships" xmlns:p="http://schemas.openxmlformats.org/presentationml/2006/main">
+  <p:cSld>
+    <p:spTree>
+      <p:nvGrpSpPr>
+        <p:cNvPr id="1" name="">
+          <a:extLst>
+            <a:ext uri="{FF2B5EF4-FFF2-40B4-BE49-F238E27FC236}">
+              <a16:creationId xmlns:a16="http://schemas.microsoft.com/office/drawing/2014/main" id="{CA819686-7461-67A4-1B60-116286D7FF5B}"/>
+            </a:ext>
+          </a:extLst>
+        </p:cNvPr>
+        <p:cNvGrpSpPr/>
+        <p:nvPr/>
+      </p:nvGrpSpPr>
+      <p:grpSpPr>
+        <a:xfrm>
+          <a:off x="0" y="0"/>
+          <a:ext cx="0" cy="0"/>
+          <a:chOff x="0" y="0"/>
+          <a:chExt cx="0" cy="0"/>
+        </a:xfrm>
+      </p:grpSpPr>
+      <p:sp>
+        <p:nvSpPr>
+          <p:cNvPr id="2" name="Title 1">
+            <a:extLst>
+              <a:ext uri="{FF2B5EF4-FFF2-40B4-BE49-F238E27FC236}">
+                <a16:creationId xmlns:a16="http://schemas.microsoft.com/office/drawing/2014/main" id="{72F27890-29A8-312D-A05B-1CCCAC18D838}"/>
+              </a:ext>
+            </a:extLst>
+          </p:cNvPr>
+          <p:cNvSpPr>
+            <a:spLocks noGrp="1"/>
+          </p:cNvSpPr>
+          <p:nvPr>
+            <p:ph type="title"/>
+          </p:nvPr>
+        </p:nvSpPr>
+        <p:spPr/>
+        <p:txBody>
+          <a:bodyPr/>
+          <a:lstStyle/>
+          <a:p>
+            <a:r>
+              <a:rPr lang="en-US" dirty="0"/>
+              <a:t>Art of merging</a:t>
+            </a:r>
+            <a:endParaRPr lang="en-ID" dirty="0"/>
+          </a:p>
+        </p:txBody>
+      </p:sp>
+      <p:sp>
+        <p:nvSpPr>
+          <p:cNvPr id="3" name="Content Placeholder 2">
+            <a:extLst>
+              <a:ext uri="{FF2B5EF4-FFF2-40B4-BE49-F238E27FC236}">
+                <a16:creationId xmlns:a16="http://schemas.microsoft.com/office/drawing/2014/main" id="{0802DC98-C7B0-6A8E-302A-673CBDA7E684}"/>
+              </a:ext>
+            </a:extLst>
+          </p:cNvPr>
+          <p:cNvSpPr>
+            <a:spLocks noGrp="1"/>
+          </p:cNvSpPr>
+          <p:nvPr>
+            <p:ph idx="1"/>
+          </p:nvPr>
+        </p:nvSpPr>
+        <p:spPr>
+          <a:xfrm>
+            <a:off x="838200" y="1825625"/>
+            <a:ext cx="11147323" cy="1212543"/>
+          </a:xfrm>
+        </p:spPr>
+        <p:txBody>
+          <a:bodyPr/>
+          <a:lstStyle/>
+          <a:p>
+            <a:r>
+              <a:rPr lang="en-US" dirty="0"/>
+              <a:t>Saat </a:t>
+            </a:r>
+            <a:r>
+              <a:rPr lang="en-US" dirty="0" err="1"/>
+              <a:t>melakukan</a:t>
+            </a:r>
+            <a:r>
+              <a:rPr lang="en-US" dirty="0"/>
+              <a:t> </a:t>
+            </a:r>
+            <a:r>
+              <a:rPr lang="en-US" dirty="0" err="1"/>
+              <a:t>mergin</a:t>
+            </a:r>
+            <a:r>
+              <a:rPr lang="en-US" dirty="0"/>
+              <a:t> </a:t>
+            </a:r>
+            <a:r>
+              <a:rPr lang="en-US" dirty="0" err="1"/>
+              <a:t>setelah</a:t>
+            </a:r>
+            <a:r>
+              <a:rPr lang="en-US" dirty="0"/>
+              <a:t> approve PR, </a:t>
+            </a:r>
+            <a:r>
+              <a:rPr lang="en-US" dirty="0" err="1"/>
+              <a:t>ada</a:t>
+            </a:r>
+            <a:r>
+              <a:rPr lang="en-US" dirty="0"/>
+              <a:t> 3 </a:t>
+            </a:r>
+            <a:r>
+              <a:rPr lang="en-US" dirty="0" err="1"/>
+              <a:t>jenis</a:t>
+            </a:r>
+            <a:r>
+              <a:rPr lang="en-US" dirty="0"/>
+              <a:t> commit yang </a:t>
+            </a:r>
+            <a:r>
+              <a:rPr lang="en-US" dirty="0" err="1"/>
+              <a:t>bisa</a:t>
+            </a:r>
+            <a:r>
+              <a:rPr lang="en-US" dirty="0"/>
+              <a:t> </a:t>
+            </a:r>
+            <a:r>
+              <a:rPr lang="en-US" dirty="0" err="1"/>
+              <a:t>terjadi</a:t>
+            </a:r>
+            <a:endParaRPr lang="en-ID" dirty="0"/>
+          </a:p>
+        </p:txBody>
+      </p:sp>
+      <p:sp>
+        <p:nvSpPr>
+          <p:cNvPr id="4" name="Date Placeholder 3">
+            <a:extLst>
+              <a:ext uri="{FF2B5EF4-FFF2-40B4-BE49-F238E27FC236}">
+                <a16:creationId xmlns:a16="http://schemas.microsoft.com/office/drawing/2014/main" id="{1F36C3C4-752C-51BC-104F-1DDD536B6D34}"/>
+              </a:ext>
+            </a:extLst>
+          </p:cNvPr>
+          <p:cNvSpPr>
+            <a:spLocks noGrp="1"/>
+          </p:cNvSpPr>
+          <p:nvPr>
+            <p:ph type="dt" sz="half" idx="10"/>
+          </p:nvPr>
+        </p:nvSpPr>
+        <p:spPr/>
+        <p:txBody>
+          <a:bodyPr/>
+          <a:lstStyle/>
+          <a:p>
+            <a:r>
+              <a:rPr lang="en-ID"/>
+              <a:t>27/02/2026</a:t>
+            </a:r>
+            <a:endParaRPr lang="en-ID" dirty="0"/>
+          </a:p>
+        </p:txBody>
+      </p:sp>
+      <p:sp>
+        <p:nvSpPr>
+          <p:cNvPr id="5" name="Footer Placeholder 4">
+            <a:extLst>
+              <a:ext uri="{FF2B5EF4-FFF2-40B4-BE49-F238E27FC236}">
+                <a16:creationId xmlns:a16="http://schemas.microsoft.com/office/drawing/2014/main" id="{847ECA0B-48AA-EF14-0458-076DDF567841}"/>
+              </a:ext>
+            </a:extLst>
+          </p:cNvPr>
+          <p:cNvSpPr>
+            <a:spLocks noGrp="1"/>
+          </p:cNvSpPr>
+          <p:nvPr>
+            <p:ph type="ftr" sz="quarter" idx="11"/>
+          </p:nvPr>
+        </p:nvSpPr>
+        <p:spPr/>
+        <p:txBody>
+          <a:bodyPr/>
+          <a:lstStyle/>
+          <a:p>
+            <a:r>
+              <a:rPr lang="en-ID"/>
+              <a:t>Git</a:t>
+            </a:r>
+            <a:endParaRPr lang="en-ID" dirty="0"/>
+          </a:p>
+        </p:txBody>
+      </p:sp>
+      <p:pic>
+        <p:nvPicPr>
+          <p:cNvPr id="11266" name="Picture 2">
+            <a:extLst>
+              <a:ext uri="{FF2B5EF4-FFF2-40B4-BE49-F238E27FC236}">
+                <a16:creationId xmlns:a16="http://schemas.microsoft.com/office/drawing/2014/main" id="{C337C9A2-51D5-1150-3DA2-E67E0AD64AB8}"/>
+              </a:ext>
+            </a:extLst>
+          </p:cNvPr>
+          <p:cNvPicPr>
+            <a:picLocks noChangeAspect="1" noChangeArrowheads="1"/>
+          </p:cNvPicPr>
+          <p:nvPr/>
+        </p:nvPicPr>
+        <p:blipFill>
+          <a:blip r:embed="rId2">
+            <a:extLst>
+              <a:ext uri="{28A0092B-C50C-407E-A947-70E740481C1C}">
+                <a14:useLocalDpi xmlns:a14="http://schemas.microsoft.com/office/drawing/2010/main" val="0"/>
+              </a:ext>
+            </a:extLst>
+          </a:blip>
+          <a:srcRect/>
+          <a:stretch>
+            <a:fillRect/>
+          </a:stretch>
+        </p:blipFill>
+        <p:spPr bwMode="auto">
+          <a:xfrm>
+            <a:off x="3943350" y="2831690"/>
+            <a:ext cx="3598054" cy="2648257"/>
+          </a:xfrm>
+          <a:prstGeom prst="rect">
+            <a:avLst/>
+          </a:prstGeom>
+          <a:noFill/>
+          <a:extLst>
+            <a:ext uri="{909E8E84-426E-40DD-AFC4-6F175D3DCCD1}">
+              <a14:hiddenFill xmlns:a14="http://schemas.microsoft.com/office/drawing/2010/main">
+                <a:solidFill>
+                  <a:srgbClr val="FFFFFF"/>
+                </a:solidFill>
+              </a14:hiddenFill>
+            </a:ext>
+          </a:extLst>
+        </p:spPr>
+      </p:pic>
+    </p:spTree>
+    <p:extLst>
+      <p:ext uri="{BB962C8B-B14F-4D97-AF65-F5344CB8AC3E}">
+        <p14:creationId xmlns:p14="http://schemas.microsoft.com/office/powerpoint/2010/main" val="2879913276"/>
       </p:ext>
     </p:extLst>
   </p:cSld>
@@ -14261,6 +17318,422 @@
     <p:extLst>
       <p:ext uri="{BB962C8B-B14F-4D97-AF65-F5344CB8AC3E}">
         <p14:creationId xmlns:p14="http://schemas.microsoft.com/office/powerpoint/2010/main" val="2083251556"/>
+      </p:ext>
+    </p:extLst>
+  </p:cSld>
+  <p:clrMapOvr>
+    <a:masterClrMapping/>
+  </p:clrMapOvr>
+</p:sld>
+</file>
+
+<file path=ppt/slides/slide50.xml><?xml version="1.0" encoding="utf-8"?>
+<p:sld xmlns:a="http://schemas.openxmlformats.org/drawingml/2006/main" xmlns:r="http://schemas.openxmlformats.org/officeDocument/2006/relationships" xmlns:p="http://schemas.openxmlformats.org/presentationml/2006/main">
+  <p:cSld>
+    <p:spTree>
+      <p:nvGrpSpPr>
+        <p:cNvPr id="1" name="">
+          <a:extLst>
+            <a:ext uri="{FF2B5EF4-FFF2-40B4-BE49-F238E27FC236}">
+              <a16:creationId xmlns:a16="http://schemas.microsoft.com/office/drawing/2014/main" id="{8E40DEFF-BDF1-8740-CEDE-EED6FE2C4824}"/>
+            </a:ext>
+          </a:extLst>
+        </p:cNvPr>
+        <p:cNvGrpSpPr/>
+        <p:nvPr/>
+      </p:nvGrpSpPr>
+      <p:grpSpPr>
+        <a:xfrm>
+          <a:off x="0" y="0"/>
+          <a:ext cx="0" cy="0"/>
+          <a:chOff x="0" y="0"/>
+          <a:chExt cx="0" cy="0"/>
+        </a:xfrm>
+      </p:grpSpPr>
+      <p:sp>
+        <p:nvSpPr>
+          <p:cNvPr id="2" name="Title 1">
+            <a:extLst>
+              <a:ext uri="{FF2B5EF4-FFF2-40B4-BE49-F238E27FC236}">
+                <a16:creationId xmlns:a16="http://schemas.microsoft.com/office/drawing/2014/main" id="{A40385B8-F8D9-9C4C-0466-068F772027B2}"/>
+              </a:ext>
+            </a:extLst>
+          </p:cNvPr>
+          <p:cNvSpPr>
+            <a:spLocks noGrp="1"/>
+          </p:cNvSpPr>
+          <p:nvPr>
+            <p:ph type="title"/>
+          </p:nvPr>
+        </p:nvSpPr>
+        <p:spPr/>
+        <p:txBody>
+          <a:bodyPr/>
+          <a:lstStyle/>
+          <a:p>
+            <a:r>
+              <a:rPr lang="en-US" dirty="0"/>
+              <a:t>Art of merging</a:t>
+            </a:r>
+            <a:endParaRPr lang="en-ID" dirty="0"/>
+          </a:p>
+        </p:txBody>
+      </p:sp>
+      <p:sp>
+        <p:nvSpPr>
+          <p:cNvPr id="3" name="Content Placeholder 2">
+            <a:extLst>
+              <a:ext uri="{FF2B5EF4-FFF2-40B4-BE49-F238E27FC236}">
+                <a16:creationId xmlns:a16="http://schemas.microsoft.com/office/drawing/2014/main" id="{057B6673-8E1D-5E45-91FF-9384D24AC1BA}"/>
+              </a:ext>
+            </a:extLst>
+          </p:cNvPr>
+          <p:cNvSpPr>
+            <a:spLocks noGrp="1"/>
+          </p:cNvSpPr>
+          <p:nvPr>
+            <p:ph idx="1"/>
+          </p:nvPr>
+        </p:nvSpPr>
+        <p:spPr>
+          <a:xfrm>
+            <a:off x="838200" y="1825625"/>
+            <a:ext cx="11147323" cy="2008956"/>
+          </a:xfrm>
+        </p:spPr>
+        <p:txBody>
+          <a:bodyPr>
+            <a:normAutofit/>
+          </a:bodyPr>
+          <a:lstStyle/>
+          <a:p>
+            <a:r>
+              <a:rPr lang="en-US" dirty="0"/>
+              <a:t>Merge -&gt; paling basic</a:t>
+            </a:r>
+          </a:p>
+          <a:p>
+            <a:r>
+              <a:rPr lang="en-US" dirty="0"/>
+              <a:t>Squash -&gt; </a:t>
+            </a:r>
+            <a:r>
+              <a:rPr lang="en-US" dirty="0" err="1"/>
+              <a:t>semua</a:t>
+            </a:r>
+            <a:r>
+              <a:rPr lang="en-US" dirty="0"/>
+              <a:t> commit </a:t>
+            </a:r>
+            <a:r>
+              <a:rPr lang="en-US" dirty="0" err="1"/>
+              <a:t>jadi</a:t>
+            </a:r>
+            <a:r>
+              <a:rPr lang="en-US" dirty="0"/>
+              <a:t> </a:t>
+            </a:r>
+            <a:r>
+              <a:rPr lang="en-US" dirty="0" err="1"/>
+              <a:t>satu</a:t>
+            </a:r>
+            <a:r>
+              <a:rPr lang="en-US" dirty="0"/>
+              <a:t> “merge commit”</a:t>
+            </a:r>
+          </a:p>
+          <a:p>
+            <a:r>
+              <a:rPr lang="en-US" dirty="0"/>
+              <a:t>Rebase -&gt; </a:t>
+            </a:r>
+            <a:r>
+              <a:rPr lang="en-US" dirty="0" err="1"/>
+              <a:t>semua</a:t>
+            </a:r>
+            <a:r>
+              <a:rPr lang="en-US" dirty="0"/>
+              <a:t> </a:t>
+            </a:r>
+            <a:r>
+              <a:rPr lang="en-US" dirty="0" err="1"/>
+              <a:t>histori</a:t>
+            </a:r>
+            <a:r>
+              <a:rPr lang="en-US" dirty="0"/>
+              <a:t> di </a:t>
+            </a:r>
+            <a:r>
+              <a:rPr lang="en-US" dirty="0" err="1"/>
+              <a:t>pindah</a:t>
+            </a:r>
+            <a:r>
+              <a:rPr lang="en-US" dirty="0"/>
+              <a:t> </a:t>
+            </a:r>
+            <a:r>
+              <a:rPr lang="en-US" dirty="0" err="1"/>
+              <a:t>tanpa</a:t>
+            </a:r>
+            <a:r>
+              <a:rPr lang="en-US" dirty="0"/>
+              <a:t> “merge commit”</a:t>
+            </a:r>
+          </a:p>
+          <a:p>
+            <a:endParaRPr lang="en-ID" dirty="0"/>
+          </a:p>
+        </p:txBody>
+      </p:sp>
+      <p:sp>
+        <p:nvSpPr>
+          <p:cNvPr id="4" name="Date Placeholder 3">
+            <a:extLst>
+              <a:ext uri="{FF2B5EF4-FFF2-40B4-BE49-F238E27FC236}">
+                <a16:creationId xmlns:a16="http://schemas.microsoft.com/office/drawing/2014/main" id="{2A86C30A-E1AD-E3BC-B569-FA8D87132427}"/>
+              </a:ext>
+            </a:extLst>
+          </p:cNvPr>
+          <p:cNvSpPr>
+            <a:spLocks noGrp="1"/>
+          </p:cNvSpPr>
+          <p:nvPr>
+            <p:ph type="dt" sz="half" idx="10"/>
+          </p:nvPr>
+        </p:nvSpPr>
+        <p:spPr/>
+        <p:txBody>
+          <a:bodyPr/>
+          <a:lstStyle/>
+          <a:p>
+            <a:r>
+              <a:rPr lang="en-ID"/>
+              <a:t>27/02/2026</a:t>
+            </a:r>
+            <a:endParaRPr lang="en-ID" dirty="0"/>
+          </a:p>
+        </p:txBody>
+      </p:sp>
+      <p:sp>
+        <p:nvSpPr>
+          <p:cNvPr id="5" name="Footer Placeholder 4">
+            <a:extLst>
+              <a:ext uri="{FF2B5EF4-FFF2-40B4-BE49-F238E27FC236}">
+                <a16:creationId xmlns:a16="http://schemas.microsoft.com/office/drawing/2014/main" id="{DA57868F-4B11-DD39-921B-90099DCA9D05}"/>
+              </a:ext>
+            </a:extLst>
+          </p:cNvPr>
+          <p:cNvSpPr>
+            <a:spLocks noGrp="1"/>
+          </p:cNvSpPr>
+          <p:nvPr>
+            <p:ph type="ftr" sz="quarter" idx="11"/>
+          </p:nvPr>
+        </p:nvSpPr>
+        <p:spPr/>
+        <p:txBody>
+          <a:bodyPr/>
+          <a:lstStyle/>
+          <a:p>
+            <a:r>
+              <a:rPr lang="en-ID"/>
+              <a:t>Git</a:t>
+            </a:r>
+            <a:endParaRPr lang="en-ID" dirty="0"/>
+          </a:p>
+        </p:txBody>
+      </p:sp>
+      <p:pic>
+        <p:nvPicPr>
+          <p:cNvPr id="12290" name="Picture 2" descr="git - What is the difference between merge --squash and rebase? - Stack  Overflow">
+            <a:extLst>
+              <a:ext uri="{FF2B5EF4-FFF2-40B4-BE49-F238E27FC236}">
+                <a16:creationId xmlns:a16="http://schemas.microsoft.com/office/drawing/2014/main" id="{C6564F48-51FD-F280-5C7F-A93010FCEC13}"/>
+              </a:ext>
+            </a:extLst>
+          </p:cNvPr>
+          <p:cNvPicPr>
+            <a:picLocks noChangeAspect="1" noChangeArrowheads="1"/>
+          </p:cNvPicPr>
+          <p:nvPr/>
+        </p:nvPicPr>
+        <p:blipFill>
+          <a:blip r:embed="rId2">
+            <a:extLst>
+              <a:ext uri="{28A0092B-C50C-407E-A947-70E740481C1C}">
+                <a14:useLocalDpi xmlns:a14="http://schemas.microsoft.com/office/drawing/2010/main" val="0"/>
+              </a:ext>
+            </a:extLst>
+          </a:blip>
+          <a:srcRect/>
+          <a:stretch>
+            <a:fillRect/>
+          </a:stretch>
+        </p:blipFill>
+        <p:spPr bwMode="auto">
+          <a:xfrm>
+            <a:off x="3249254" y="3811372"/>
+            <a:ext cx="4904146" cy="2568188"/>
+          </a:xfrm>
+          <a:prstGeom prst="rect">
+            <a:avLst/>
+          </a:prstGeom>
+          <a:noFill/>
+          <a:extLst>
+            <a:ext uri="{909E8E84-426E-40DD-AFC4-6F175D3DCCD1}">
+              <a14:hiddenFill xmlns:a14="http://schemas.microsoft.com/office/drawing/2010/main">
+                <a:solidFill>
+                  <a:srgbClr val="FFFFFF"/>
+                </a:solidFill>
+              </a14:hiddenFill>
+            </a:ext>
+          </a:extLst>
+        </p:spPr>
+      </p:pic>
+    </p:spTree>
+    <p:extLst>
+      <p:ext uri="{BB962C8B-B14F-4D97-AF65-F5344CB8AC3E}">
+        <p14:creationId xmlns:p14="http://schemas.microsoft.com/office/powerpoint/2010/main" val="705922553"/>
+      </p:ext>
+    </p:extLst>
+  </p:cSld>
+  <p:clrMapOvr>
+    <a:masterClrMapping/>
+  </p:clrMapOvr>
+</p:sld>
+</file>
+
+<file path=ppt/slides/slide51.xml><?xml version="1.0" encoding="utf-8"?>
+<p:sld xmlns:a="http://schemas.openxmlformats.org/drawingml/2006/main" xmlns:r="http://schemas.openxmlformats.org/officeDocument/2006/relationships" xmlns:p="http://schemas.openxmlformats.org/presentationml/2006/main">
+  <p:cSld>
+    <p:spTree>
+      <p:nvGrpSpPr>
+        <p:cNvPr id="1" name=""/>
+        <p:cNvGrpSpPr/>
+        <p:nvPr/>
+      </p:nvGrpSpPr>
+      <p:grpSpPr>
+        <a:xfrm>
+          <a:off x="0" y="0"/>
+          <a:ext cx="0" cy="0"/>
+          <a:chOff x="0" y="0"/>
+          <a:chExt cx="0" cy="0"/>
+        </a:xfrm>
+      </p:grpSpPr>
+      <p:sp>
+        <p:nvSpPr>
+          <p:cNvPr id="2" name="Title 1">
+            <a:extLst>
+              <a:ext uri="{FF2B5EF4-FFF2-40B4-BE49-F238E27FC236}">
+                <a16:creationId xmlns:a16="http://schemas.microsoft.com/office/drawing/2014/main" id="{D41B6C42-726B-0A35-560F-F582DFEAC0E4}"/>
+              </a:ext>
+            </a:extLst>
+          </p:cNvPr>
+          <p:cNvSpPr>
+            <a:spLocks noGrp="1"/>
+          </p:cNvSpPr>
+          <p:nvPr>
+            <p:ph type="title"/>
+          </p:nvPr>
+        </p:nvSpPr>
+        <p:spPr/>
+        <p:txBody>
+          <a:bodyPr/>
+          <a:lstStyle/>
+          <a:p>
+            <a:r>
+              <a:rPr lang="en-US" dirty="0"/>
+              <a:t>Hosting: make your web visible</a:t>
+            </a:r>
+            <a:endParaRPr lang="en-ID" dirty="0"/>
+          </a:p>
+        </p:txBody>
+      </p:sp>
+      <p:sp>
+        <p:nvSpPr>
+          <p:cNvPr id="3" name="Text Placeholder 2">
+            <a:extLst>
+              <a:ext uri="{FF2B5EF4-FFF2-40B4-BE49-F238E27FC236}">
+                <a16:creationId xmlns:a16="http://schemas.microsoft.com/office/drawing/2014/main" id="{54EF19C2-D491-6787-9A17-F61C0BA85E14}"/>
+              </a:ext>
+            </a:extLst>
+          </p:cNvPr>
+          <p:cNvSpPr>
+            <a:spLocks noGrp="1"/>
+          </p:cNvSpPr>
+          <p:nvPr>
+            <p:ph type="body" idx="1"/>
+          </p:nvPr>
+        </p:nvSpPr>
+        <p:spPr/>
+        <p:txBody>
+          <a:bodyPr/>
+          <a:lstStyle/>
+          <a:p>
+            <a:endParaRPr lang="en-ID"/>
+          </a:p>
+        </p:txBody>
+      </p:sp>
+      <p:sp>
+        <p:nvSpPr>
+          <p:cNvPr id="4" name="Date Placeholder 3">
+            <a:extLst>
+              <a:ext uri="{FF2B5EF4-FFF2-40B4-BE49-F238E27FC236}">
+                <a16:creationId xmlns:a16="http://schemas.microsoft.com/office/drawing/2014/main" id="{50E78D67-24E6-B4DF-A042-C47A2E4E9B76}"/>
+              </a:ext>
+            </a:extLst>
+          </p:cNvPr>
+          <p:cNvSpPr>
+            <a:spLocks noGrp="1"/>
+          </p:cNvSpPr>
+          <p:nvPr>
+            <p:ph type="dt" sz="half" idx="10"/>
+          </p:nvPr>
+        </p:nvSpPr>
+        <p:spPr/>
+        <p:txBody>
+          <a:bodyPr/>
+          <a:lstStyle/>
+          <a:p>
+            <a:r>
+              <a:rPr lang="en-ID"/>
+              <a:t>27/02/2026</a:t>
+            </a:r>
+          </a:p>
+        </p:txBody>
+      </p:sp>
+      <p:sp>
+        <p:nvSpPr>
+          <p:cNvPr id="5" name="Footer Placeholder 4">
+            <a:extLst>
+              <a:ext uri="{FF2B5EF4-FFF2-40B4-BE49-F238E27FC236}">
+                <a16:creationId xmlns:a16="http://schemas.microsoft.com/office/drawing/2014/main" id="{0B1A4D02-7008-65CF-606D-583710BBF2A4}"/>
+              </a:ext>
+            </a:extLst>
+          </p:cNvPr>
+          <p:cNvSpPr>
+            <a:spLocks noGrp="1"/>
+          </p:cNvSpPr>
+          <p:nvPr>
+            <p:ph type="ftr" sz="quarter" idx="11"/>
+          </p:nvPr>
+        </p:nvSpPr>
+        <p:spPr/>
+        <p:txBody>
+          <a:bodyPr/>
+          <a:lstStyle/>
+          <a:p>
+            <a:r>
+              <a:rPr lang="en-ID"/>
+              <a:t>Git</a:t>
+            </a:r>
+          </a:p>
+        </p:txBody>
+      </p:sp>
+    </p:spTree>
+    <p:extLst>
+      <p:ext uri="{BB962C8B-B14F-4D97-AF65-F5344CB8AC3E}">
+        <p14:creationId xmlns:p14="http://schemas.microsoft.com/office/powerpoint/2010/main" val="521112592"/>
       </p:ext>
     </p:extLst>
   </p:cSld>

</xml_diff>

<commit_message>
add part 2 hosting
</commit_message>
<xml_diff>
--- a/Part 1 Git/Git-art of source control.pptx
+++ b/Part 1 Git/Git-art of source control.pptx
@@ -5,7 +5,7 @@
     <p:sldMasterId id="2147483660" r:id="rId1"/>
   </p:sldMasterIdLst>
   <p:notesMasterIdLst>
-    <p:notesMasterId r:id="rId53"/>
+    <p:notesMasterId r:id="rId61"/>
   </p:notesMasterIdLst>
   <p:sldIdLst>
     <p:sldId id="256" r:id="rId2"/>
@@ -59,6 +59,14 @@
     <p:sldId id="303" r:id="rId50"/>
     <p:sldId id="304" r:id="rId51"/>
     <p:sldId id="306" r:id="rId52"/>
+    <p:sldId id="308" r:id="rId53"/>
+    <p:sldId id="307" r:id="rId54"/>
+    <p:sldId id="309" r:id="rId55"/>
+    <p:sldId id="310" r:id="rId56"/>
+    <p:sldId id="311" r:id="rId57"/>
+    <p:sldId id="312" r:id="rId58"/>
+    <p:sldId id="314" r:id="rId59"/>
+    <p:sldId id="313" r:id="rId60"/>
   </p:sldIdLst>
   <p:sldSz cx="12192000" cy="6858000"/>
   <p:notesSz cx="6858000" cy="9144000"/>
@@ -229,6 +237,14 @@
         <p14:section name="Hosting" id="{1C028AB8-67AB-4DA3-B6ED-EB3F2B4BAB6A}">
           <p14:sldIdLst>
             <p14:sldId id="306"/>
+            <p14:sldId id="308"/>
+            <p14:sldId id="307"/>
+            <p14:sldId id="309"/>
+            <p14:sldId id="310"/>
+            <p14:sldId id="311"/>
+            <p14:sldId id="312"/>
+            <p14:sldId id="314"/>
+            <p14:sldId id="313"/>
           </p14:sldIdLst>
         </p14:section>
       </p14:sectionLst>
@@ -322,7 +338,7 @@
           <a:p>
             <a:fld id="{3004ABFC-3074-413D-B7F9-A3C08E187088}" type="datetimeFigureOut">
               <a:rPr lang="en-ID" smtClean="0"/>
-              <a:t>26/02/2026</a:t>
+              <a:t>27/02/2026</a:t>
             </a:fld>
             <a:endParaRPr lang="en-ID"/>
           </a:p>
@@ -17734,6 +17750,2258 @@
     <p:extLst>
       <p:ext uri="{BB962C8B-B14F-4D97-AF65-F5344CB8AC3E}">
         <p14:creationId xmlns:p14="http://schemas.microsoft.com/office/powerpoint/2010/main" val="521112592"/>
+      </p:ext>
+    </p:extLst>
+  </p:cSld>
+  <p:clrMapOvr>
+    <a:masterClrMapping/>
+  </p:clrMapOvr>
+</p:sld>
+</file>
+
+<file path=ppt/slides/slide52.xml><?xml version="1.0" encoding="utf-8"?>
+<p:sld xmlns:a="http://schemas.openxmlformats.org/drawingml/2006/main" xmlns:r="http://schemas.openxmlformats.org/officeDocument/2006/relationships" xmlns:p="http://schemas.openxmlformats.org/presentationml/2006/main">
+  <p:cSld>
+    <p:spTree>
+      <p:nvGrpSpPr>
+        <p:cNvPr id="1" name=""/>
+        <p:cNvGrpSpPr/>
+        <p:nvPr/>
+      </p:nvGrpSpPr>
+      <p:grpSpPr>
+        <a:xfrm>
+          <a:off x="0" y="0"/>
+          <a:ext cx="0" cy="0"/>
+          <a:chOff x="0" y="0"/>
+          <a:chExt cx="0" cy="0"/>
+        </a:xfrm>
+      </p:grpSpPr>
+      <p:sp>
+        <p:nvSpPr>
+          <p:cNvPr id="6" name="Title 5">
+            <a:extLst>
+              <a:ext uri="{FF2B5EF4-FFF2-40B4-BE49-F238E27FC236}">
+                <a16:creationId xmlns:a16="http://schemas.microsoft.com/office/drawing/2014/main" id="{615B18DF-E2FD-C94F-2A78-DA79DBD27816}"/>
+              </a:ext>
+            </a:extLst>
+          </p:cNvPr>
+          <p:cNvSpPr>
+            <a:spLocks noGrp="1"/>
+          </p:cNvSpPr>
+          <p:nvPr>
+            <p:ph type="title"/>
+          </p:nvPr>
+        </p:nvSpPr>
+        <p:spPr/>
+        <p:txBody>
+          <a:bodyPr/>
+          <a:lstStyle/>
+          <a:p>
+            <a:r>
+              <a:rPr lang="en-US" dirty="0"/>
+              <a:t>Apa </a:t>
+            </a:r>
+            <a:r>
+              <a:rPr lang="en-US" dirty="0" err="1"/>
+              <a:t>itu</a:t>
+            </a:r>
+            <a:r>
+              <a:rPr lang="en-US" dirty="0"/>
+              <a:t> hosting?</a:t>
+            </a:r>
+            <a:endParaRPr lang="en-ID" dirty="0"/>
+          </a:p>
+        </p:txBody>
+      </p:sp>
+      <p:sp>
+        <p:nvSpPr>
+          <p:cNvPr id="7" name="Content Placeholder 6">
+            <a:extLst>
+              <a:ext uri="{FF2B5EF4-FFF2-40B4-BE49-F238E27FC236}">
+                <a16:creationId xmlns:a16="http://schemas.microsoft.com/office/drawing/2014/main" id="{E806ED42-77F8-E925-DB2C-58FFD630B588}"/>
+              </a:ext>
+            </a:extLst>
+          </p:cNvPr>
+          <p:cNvSpPr>
+            <a:spLocks noGrp="1"/>
+          </p:cNvSpPr>
+          <p:nvPr>
+            <p:ph idx="1"/>
+          </p:nvPr>
+        </p:nvSpPr>
+        <p:spPr/>
+        <p:txBody>
+          <a:bodyPr/>
+          <a:lstStyle/>
+          <a:p>
+            <a:r>
+              <a:rPr lang="en-US" dirty="0" err="1"/>
+              <a:t>Layanan</a:t>
+            </a:r>
+            <a:r>
+              <a:rPr lang="en-US" dirty="0"/>
+              <a:t> </a:t>
+            </a:r>
+            <a:r>
+              <a:rPr lang="en-US" dirty="0" err="1"/>
+              <a:t>untuk</a:t>
+            </a:r>
+            <a:r>
+              <a:rPr lang="en-US" dirty="0"/>
+              <a:t> </a:t>
+            </a:r>
+            <a:r>
+              <a:rPr lang="en-US" dirty="0" err="1"/>
+              <a:t>menempatkan</a:t>
+            </a:r>
+            <a:r>
+              <a:rPr lang="en-US" dirty="0"/>
+              <a:t> </a:t>
+            </a:r>
+            <a:r>
+              <a:rPr lang="en-US" dirty="0" err="1"/>
+              <a:t>aplikasi</a:t>
+            </a:r>
+            <a:r>
+              <a:rPr lang="en-US" dirty="0"/>
+              <a:t>/website agar </a:t>
+            </a:r>
+            <a:r>
+              <a:rPr lang="en-US" dirty="0" err="1"/>
+              <a:t>bisa</a:t>
+            </a:r>
+            <a:r>
+              <a:rPr lang="en-US" dirty="0"/>
+              <a:t> </a:t>
+            </a:r>
+            <a:r>
+              <a:rPr lang="en-US" dirty="0" err="1"/>
+              <a:t>diakses</a:t>
+            </a:r>
+            <a:r>
+              <a:rPr lang="en-US" dirty="0"/>
+              <a:t> </a:t>
+            </a:r>
+            <a:r>
+              <a:rPr lang="en-US" dirty="0" err="1"/>
+              <a:t>melalui</a:t>
+            </a:r>
+            <a:r>
+              <a:rPr lang="en-US" dirty="0"/>
+              <a:t> public/internet</a:t>
+            </a:r>
+            <a:endParaRPr lang="en-ID" dirty="0"/>
+          </a:p>
+        </p:txBody>
+      </p:sp>
+      <p:sp>
+        <p:nvSpPr>
+          <p:cNvPr id="4" name="Date Placeholder 3">
+            <a:extLst>
+              <a:ext uri="{FF2B5EF4-FFF2-40B4-BE49-F238E27FC236}">
+                <a16:creationId xmlns:a16="http://schemas.microsoft.com/office/drawing/2014/main" id="{7C407CA4-D151-EFDD-34C0-43CF8938B8E1}"/>
+              </a:ext>
+            </a:extLst>
+          </p:cNvPr>
+          <p:cNvSpPr>
+            <a:spLocks noGrp="1"/>
+          </p:cNvSpPr>
+          <p:nvPr>
+            <p:ph type="dt" sz="half" idx="10"/>
+          </p:nvPr>
+        </p:nvSpPr>
+        <p:spPr/>
+        <p:txBody>
+          <a:bodyPr/>
+          <a:lstStyle/>
+          <a:p>
+            <a:r>
+              <a:rPr lang="en-ID"/>
+              <a:t>27/02/2026</a:t>
+            </a:r>
+          </a:p>
+        </p:txBody>
+      </p:sp>
+      <p:sp>
+        <p:nvSpPr>
+          <p:cNvPr id="5" name="Footer Placeholder 4">
+            <a:extLst>
+              <a:ext uri="{FF2B5EF4-FFF2-40B4-BE49-F238E27FC236}">
+                <a16:creationId xmlns:a16="http://schemas.microsoft.com/office/drawing/2014/main" id="{3DE01E70-DC70-3455-5C18-D07A242A4CDF}"/>
+              </a:ext>
+            </a:extLst>
+          </p:cNvPr>
+          <p:cNvSpPr>
+            <a:spLocks noGrp="1"/>
+          </p:cNvSpPr>
+          <p:nvPr>
+            <p:ph type="ftr" sz="quarter" idx="11"/>
+          </p:nvPr>
+        </p:nvSpPr>
+        <p:spPr/>
+        <p:txBody>
+          <a:bodyPr/>
+          <a:lstStyle/>
+          <a:p>
+            <a:r>
+              <a:rPr lang="en-ID"/>
+              <a:t>Git</a:t>
+            </a:r>
+          </a:p>
+        </p:txBody>
+      </p:sp>
+    </p:spTree>
+    <p:extLst>
+      <p:ext uri="{BB962C8B-B14F-4D97-AF65-F5344CB8AC3E}">
+        <p14:creationId xmlns:p14="http://schemas.microsoft.com/office/powerpoint/2010/main" val="3744871987"/>
+      </p:ext>
+    </p:extLst>
+  </p:cSld>
+  <p:clrMapOvr>
+    <a:masterClrMapping/>
+  </p:clrMapOvr>
+</p:sld>
+</file>
+
+<file path=ppt/slides/slide53.xml><?xml version="1.0" encoding="utf-8"?>
+<p:sld xmlns:a="http://schemas.openxmlformats.org/drawingml/2006/main" xmlns:r="http://schemas.openxmlformats.org/officeDocument/2006/relationships" xmlns:p="http://schemas.openxmlformats.org/presentationml/2006/main">
+  <p:cSld>
+    <p:spTree>
+      <p:nvGrpSpPr>
+        <p:cNvPr id="1" name=""/>
+        <p:cNvGrpSpPr/>
+        <p:nvPr/>
+      </p:nvGrpSpPr>
+      <p:grpSpPr>
+        <a:xfrm>
+          <a:off x="0" y="0"/>
+          <a:ext cx="0" cy="0"/>
+          <a:chOff x="0" y="0"/>
+          <a:chExt cx="0" cy="0"/>
+        </a:xfrm>
+      </p:grpSpPr>
+      <p:sp>
+        <p:nvSpPr>
+          <p:cNvPr id="6" name="Title 5">
+            <a:extLst>
+              <a:ext uri="{FF2B5EF4-FFF2-40B4-BE49-F238E27FC236}">
+                <a16:creationId xmlns:a16="http://schemas.microsoft.com/office/drawing/2014/main" id="{335ECCA8-0E11-FE6D-85CB-9CE2A2C6DF95}"/>
+              </a:ext>
+            </a:extLst>
+          </p:cNvPr>
+          <p:cNvSpPr>
+            <a:spLocks noGrp="1"/>
+          </p:cNvSpPr>
+          <p:nvPr>
+            <p:ph type="title"/>
+          </p:nvPr>
+        </p:nvSpPr>
+        <p:spPr/>
+        <p:txBody>
+          <a:bodyPr/>
+          <a:lstStyle/>
+          <a:p>
+            <a:r>
+              <a:rPr lang="en-US" dirty="0" err="1"/>
+              <a:t>Kenapa</a:t>
+            </a:r>
+            <a:r>
+              <a:rPr lang="en-US" dirty="0"/>
+              <a:t> </a:t>
+            </a:r>
+            <a:r>
+              <a:rPr lang="en-US" dirty="0" err="1"/>
+              <a:t>butuh</a:t>
+            </a:r>
+            <a:r>
+              <a:rPr lang="en-US" dirty="0"/>
+              <a:t> hosting?</a:t>
+            </a:r>
+            <a:endParaRPr lang="en-ID" dirty="0"/>
+          </a:p>
+        </p:txBody>
+      </p:sp>
+      <p:sp>
+        <p:nvSpPr>
+          <p:cNvPr id="7" name="Content Placeholder 6">
+            <a:extLst>
+              <a:ext uri="{FF2B5EF4-FFF2-40B4-BE49-F238E27FC236}">
+                <a16:creationId xmlns:a16="http://schemas.microsoft.com/office/drawing/2014/main" id="{9B4D7B6E-CCE1-0112-0F49-5D09F4AB1D3E}"/>
+              </a:ext>
+            </a:extLst>
+          </p:cNvPr>
+          <p:cNvSpPr>
+            <a:spLocks noGrp="1"/>
+          </p:cNvSpPr>
+          <p:nvPr>
+            <p:ph sz="half" idx="1"/>
+          </p:nvPr>
+        </p:nvSpPr>
+        <p:spPr/>
+        <p:txBody>
+          <a:bodyPr/>
+          <a:lstStyle/>
+          <a:p>
+            <a:r>
+              <a:rPr lang="en-US" dirty="0"/>
+              <a:t>Lokal:</a:t>
+            </a:r>
+          </a:p>
+          <a:p>
+            <a:pPr lvl="1"/>
+            <a:r>
+              <a:rPr lang="en-US" dirty="0" err="1"/>
+              <a:t>Untuk</a:t>
+            </a:r>
+            <a:r>
+              <a:rPr lang="en-US" dirty="0"/>
+              <a:t> </a:t>
+            </a:r>
+            <a:r>
+              <a:rPr lang="en-US" dirty="0" err="1"/>
+              <a:t>diri</a:t>
+            </a:r>
+            <a:r>
+              <a:rPr lang="en-US" dirty="0"/>
+              <a:t> </a:t>
+            </a:r>
+            <a:r>
+              <a:rPr lang="en-US" dirty="0" err="1"/>
+              <a:t>sendiri</a:t>
+            </a:r>
+            <a:endParaRPr lang="en-US" dirty="0"/>
+          </a:p>
+          <a:p>
+            <a:pPr lvl="1"/>
+            <a:r>
+              <a:rPr lang="en-US" dirty="0"/>
+              <a:t>Bisa </a:t>
+            </a:r>
+            <a:r>
+              <a:rPr lang="en-US" dirty="0" err="1"/>
+              <a:t>aja</a:t>
+            </a:r>
+            <a:r>
+              <a:rPr lang="en-US" dirty="0"/>
+              <a:t> </a:t>
+            </a:r>
+            <a:r>
+              <a:rPr lang="en-US" dirty="0" err="1"/>
+              <a:t>pakai</a:t>
+            </a:r>
+            <a:r>
+              <a:rPr lang="en-US" dirty="0"/>
+              <a:t> “tunnel”</a:t>
+            </a:r>
+          </a:p>
+          <a:p>
+            <a:pPr lvl="1"/>
+            <a:r>
+              <a:rPr lang="en-US" dirty="0"/>
+              <a:t>Ga nyala 24 jam </a:t>
+            </a:r>
+            <a:r>
+              <a:rPr lang="en-US" dirty="0" err="1"/>
+              <a:t>terus</a:t>
+            </a:r>
+            <a:r>
+              <a:rPr lang="en-US" dirty="0"/>
+              <a:t> (</a:t>
+            </a:r>
+            <a:r>
+              <a:rPr lang="en-US" dirty="0" err="1"/>
+              <a:t>kecuali</a:t>
+            </a:r>
+            <a:r>
+              <a:rPr lang="en-US" dirty="0"/>
+              <a:t> </a:t>
+            </a:r>
+            <a:r>
+              <a:rPr lang="en-US" dirty="0" err="1"/>
+              <a:t>anda</a:t>
+            </a:r>
+            <a:r>
+              <a:rPr lang="en-US" dirty="0"/>
+              <a:t> </a:t>
+            </a:r>
+            <a:r>
+              <a:rPr lang="en-US" dirty="0" err="1"/>
+              <a:t>menyiksa</a:t>
+            </a:r>
+            <a:r>
+              <a:rPr lang="en-US" dirty="0"/>
+              <a:t> PC </a:t>
+            </a:r>
+            <a:r>
+              <a:rPr lang="en-US" dirty="0" err="1"/>
+              <a:t>anda</a:t>
+            </a:r>
+            <a:r>
+              <a:rPr lang="en-US" dirty="0"/>
+              <a:t> </a:t>
+            </a:r>
+            <a:r>
+              <a:rPr lang="en-US" dirty="0" err="1"/>
+              <a:t>sendiri</a:t>
+            </a:r>
+            <a:r>
+              <a:rPr lang="en-US" dirty="0"/>
+              <a:t>)</a:t>
+            </a:r>
+          </a:p>
+          <a:p>
+            <a:r>
+              <a:rPr lang="en-US" dirty="0"/>
+              <a:t>Server hosting</a:t>
+            </a:r>
+          </a:p>
+          <a:p>
+            <a:pPr lvl="1"/>
+            <a:r>
+              <a:rPr lang="en-US" dirty="0"/>
+              <a:t>Bisa </a:t>
+            </a:r>
+            <a:r>
+              <a:rPr lang="en-US" dirty="0" err="1"/>
+              <a:t>dipublik</a:t>
+            </a:r>
+            <a:r>
+              <a:rPr lang="en-US" dirty="0"/>
+              <a:t> (</a:t>
+            </a:r>
+            <a:r>
+              <a:rPr lang="en-US" dirty="0" err="1"/>
+              <a:t>bisa</a:t>
+            </a:r>
+            <a:r>
+              <a:rPr lang="en-US" dirty="0"/>
+              <a:t> private juga)</a:t>
+            </a:r>
+          </a:p>
+          <a:p>
+            <a:pPr lvl="1"/>
+            <a:r>
+              <a:rPr lang="en-US" dirty="0"/>
+              <a:t>Nyala 24 jam (</a:t>
+            </a:r>
+            <a:r>
+              <a:rPr lang="en-US" dirty="0" err="1"/>
+              <a:t>memang</a:t>
+            </a:r>
+            <a:r>
+              <a:rPr lang="en-US" dirty="0"/>
+              <a:t> </a:t>
+            </a:r>
+            <a:r>
+              <a:rPr lang="en-US" dirty="0" err="1"/>
+              <a:t>tugasnya</a:t>
+            </a:r>
+            <a:r>
+              <a:rPr lang="en-ID" dirty="0"/>
+              <a:t>)</a:t>
+            </a:r>
+            <a:endParaRPr lang="en-US" dirty="0"/>
+          </a:p>
+          <a:p>
+            <a:pPr marL="457200" lvl="1" indent="0">
+              <a:buNone/>
+            </a:pPr>
+            <a:endParaRPr lang="en-ID" dirty="0"/>
+          </a:p>
+        </p:txBody>
+      </p:sp>
+      <p:sp>
+        <p:nvSpPr>
+          <p:cNvPr id="4" name="Date Placeholder 3">
+            <a:extLst>
+              <a:ext uri="{FF2B5EF4-FFF2-40B4-BE49-F238E27FC236}">
+                <a16:creationId xmlns:a16="http://schemas.microsoft.com/office/drawing/2014/main" id="{E71C346C-5BBB-7490-C96A-88207517DED2}"/>
+              </a:ext>
+            </a:extLst>
+          </p:cNvPr>
+          <p:cNvSpPr>
+            <a:spLocks noGrp="1"/>
+          </p:cNvSpPr>
+          <p:nvPr>
+            <p:ph type="dt" sz="half" idx="10"/>
+          </p:nvPr>
+        </p:nvSpPr>
+        <p:spPr/>
+        <p:txBody>
+          <a:bodyPr/>
+          <a:lstStyle/>
+          <a:p>
+            <a:r>
+              <a:rPr lang="en-ID"/>
+              <a:t>27/02/2026</a:t>
+            </a:r>
+          </a:p>
+        </p:txBody>
+      </p:sp>
+      <p:sp>
+        <p:nvSpPr>
+          <p:cNvPr id="5" name="Footer Placeholder 4">
+            <a:extLst>
+              <a:ext uri="{FF2B5EF4-FFF2-40B4-BE49-F238E27FC236}">
+                <a16:creationId xmlns:a16="http://schemas.microsoft.com/office/drawing/2014/main" id="{7693EBFD-64C9-6F73-0A7C-9B76918D4E50}"/>
+              </a:ext>
+            </a:extLst>
+          </p:cNvPr>
+          <p:cNvSpPr>
+            <a:spLocks noGrp="1"/>
+          </p:cNvSpPr>
+          <p:nvPr>
+            <p:ph type="ftr" sz="quarter" idx="11"/>
+          </p:nvPr>
+        </p:nvSpPr>
+        <p:spPr/>
+        <p:txBody>
+          <a:bodyPr/>
+          <a:lstStyle/>
+          <a:p>
+            <a:r>
+              <a:rPr lang="en-ID"/>
+              <a:t>Git</a:t>
+            </a:r>
+          </a:p>
+        </p:txBody>
+      </p:sp>
+      <p:pic>
+        <p:nvPicPr>
+          <p:cNvPr id="1026" name="Picture 2" descr="Poor kid : r/ProgrammerHumor">
+            <a:extLst>
+              <a:ext uri="{FF2B5EF4-FFF2-40B4-BE49-F238E27FC236}">
+                <a16:creationId xmlns:a16="http://schemas.microsoft.com/office/drawing/2014/main" id="{0A90F0D3-88FC-1083-694E-50DA28EAE451}"/>
+              </a:ext>
+            </a:extLst>
+          </p:cNvPr>
+          <p:cNvPicPr>
+            <a:picLocks noChangeAspect="1" noChangeArrowheads="1"/>
+          </p:cNvPicPr>
+          <p:nvPr/>
+        </p:nvPicPr>
+        <p:blipFill>
+          <a:blip r:embed="rId2">
+            <a:extLst>
+              <a:ext uri="{28A0092B-C50C-407E-A947-70E740481C1C}">
+                <a14:useLocalDpi xmlns:a14="http://schemas.microsoft.com/office/drawing/2010/main" val="0"/>
+              </a:ext>
+            </a:extLst>
+          </a:blip>
+          <a:srcRect/>
+          <a:stretch>
+            <a:fillRect/>
+          </a:stretch>
+        </p:blipFill>
+        <p:spPr bwMode="auto">
+          <a:xfrm>
+            <a:off x="6872747" y="1690688"/>
+            <a:ext cx="3824749" cy="3824749"/>
+          </a:xfrm>
+          <a:prstGeom prst="rect">
+            <a:avLst/>
+          </a:prstGeom>
+          <a:noFill/>
+          <a:extLst>
+            <a:ext uri="{909E8E84-426E-40DD-AFC4-6F175D3DCCD1}">
+              <a14:hiddenFill xmlns:a14="http://schemas.microsoft.com/office/drawing/2010/main">
+                <a:solidFill>
+                  <a:srgbClr val="FFFFFF"/>
+                </a:solidFill>
+              </a14:hiddenFill>
+            </a:ext>
+          </a:extLst>
+        </p:spPr>
+      </p:pic>
+    </p:spTree>
+    <p:extLst>
+      <p:ext uri="{BB962C8B-B14F-4D97-AF65-F5344CB8AC3E}">
+        <p14:creationId xmlns:p14="http://schemas.microsoft.com/office/powerpoint/2010/main" val="3025277323"/>
+      </p:ext>
+    </p:extLst>
+  </p:cSld>
+  <p:clrMapOvr>
+    <a:masterClrMapping/>
+  </p:clrMapOvr>
+</p:sld>
+</file>
+
+<file path=ppt/slides/slide54.xml><?xml version="1.0" encoding="utf-8"?>
+<p:sld xmlns:a="http://schemas.openxmlformats.org/drawingml/2006/main" xmlns:r="http://schemas.openxmlformats.org/officeDocument/2006/relationships" xmlns:p="http://schemas.openxmlformats.org/presentationml/2006/main">
+  <p:cSld>
+    <p:spTree>
+      <p:nvGrpSpPr>
+        <p:cNvPr id="1" name=""/>
+        <p:cNvGrpSpPr/>
+        <p:nvPr/>
+      </p:nvGrpSpPr>
+      <p:grpSpPr>
+        <a:xfrm>
+          <a:off x="0" y="0"/>
+          <a:ext cx="0" cy="0"/>
+          <a:chOff x="0" y="0"/>
+          <a:chExt cx="0" cy="0"/>
+        </a:xfrm>
+      </p:grpSpPr>
+      <p:sp>
+        <p:nvSpPr>
+          <p:cNvPr id="12" name="Title 11">
+            <a:extLst>
+              <a:ext uri="{FF2B5EF4-FFF2-40B4-BE49-F238E27FC236}">
+                <a16:creationId xmlns:a16="http://schemas.microsoft.com/office/drawing/2014/main" id="{40B335A9-1C32-3457-5AF9-93F29617DEBF}"/>
+              </a:ext>
+            </a:extLst>
+          </p:cNvPr>
+          <p:cNvSpPr>
+            <a:spLocks noGrp="1"/>
+          </p:cNvSpPr>
+          <p:nvPr>
+            <p:ph type="title"/>
+          </p:nvPr>
+        </p:nvSpPr>
+        <p:spPr/>
+        <p:txBody>
+          <a:bodyPr/>
+          <a:lstStyle/>
+          <a:p>
+            <a:r>
+              <a:rPr lang="en-US" dirty="0" err="1"/>
+              <a:t>Terminologi</a:t>
+            </a:r>
+            <a:r>
+              <a:rPr lang="en-US" dirty="0"/>
+              <a:t> hosting</a:t>
+            </a:r>
+            <a:endParaRPr lang="en-ID" dirty="0"/>
+          </a:p>
+        </p:txBody>
+      </p:sp>
+      <p:sp>
+        <p:nvSpPr>
+          <p:cNvPr id="13" name="Content Placeholder 12">
+            <a:extLst>
+              <a:ext uri="{FF2B5EF4-FFF2-40B4-BE49-F238E27FC236}">
+                <a16:creationId xmlns:a16="http://schemas.microsoft.com/office/drawing/2014/main" id="{E07DC552-4E66-F8D8-29EC-DCCB2294D1E4}"/>
+              </a:ext>
+            </a:extLst>
+          </p:cNvPr>
+          <p:cNvSpPr>
+            <a:spLocks noGrp="1"/>
+          </p:cNvSpPr>
+          <p:nvPr>
+            <p:ph idx="1"/>
+          </p:nvPr>
+        </p:nvSpPr>
+        <p:spPr/>
+        <p:txBody>
+          <a:bodyPr>
+            <a:normAutofit lnSpcReduction="10000"/>
+          </a:bodyPr>
+          <a:lstStyle/>
+          <a:p>
+            <a:r>
+              <a:rPr lang="en-US" dirty="0"/>
+              <a:t>Server: (computer yang </a:t>
+            </a:r>
+            <a:r>
+              <a:rPr lang="en-US" dirty="0" err="1"/>
+              <a:t>menjadi</a:t>
+            </a:r>
+            <a:r>
+              <a:rPr lang="en-US" dirty="0"/>
+              <a:t> host </a:t>
+            </a:r>
+            <a:r>
+              <a:rPr lang="en-US" dirty="0" err="1"/>
+              <a:t>websitenya</a:t>
+            </a:r>
+            <a:r>
+              <a:rPr lang="en-US" dirty="0"/>
+              <a:t>)</a:t>
+            </a:r>
+          </a:p>
+          <a:p>
+            <a:r>
+              <a:rPr lang="en-US" dirty="0"/>
+              <a:t>Domain: nama alias </a:t>
+            </a:r>
+            <a:r>
+              <a:rPr lang="en-US" dirty="0" err="1"/>
+              <a:t>untuk</a:t>
+            </a:r>
+            <a:r>
+              <a:rPr lang="en-US" dirty="0"/>
+              <a:t> IP server kalian (google.com, </a:t>
+            </a:r>
+            <a:r>
+              <a:rPr lang="en-US" dirty="0" err="1"/>
+              <a:t>etc</a:t>
+            </a:r>
+            <a:r>
+              <a:rPr lang="en-US" dirty="0"/>
+              <a:t>)</a:t>
+            </a:r>
+          </a:p>
+          <a:p>
+            <a:r>
+              <a:rPr lang="en-US" dirty="0"/>
+              <a:t>DNS: domain name server (translating IP to domain name)</a:t>
+            </a:r>
+          </a:p>
+          <a:p>
+            <a:r>
+              <a:rPr lang="en-US" dirty="0"/>
+              <a:t>IP: dah tau </a:t>
+            </a:r>
+            <a:r>
+              <a:rPr lang="en-US" dirty="0" err="1"/>
+              <a:t>lah</a:t>
+            </a:r>
+            <a:r>
+              <a:rPr lang="en-US" dirty="0"/>
+              <a:t> </a:t>
+            </a:r>
+            <a:r>
+              <a:rPr lang="en-US" dirty="0" err="1"/>
+              <a:t>ya</a:t>
+            </a:r>
+            <a:endParaRPr lang="en-US" dirty="0"/>
+          </a:p>
+          <a:p>
+            <a:r>
+              <a:rPr lang="en-US" dirty="0"/>
+              <a:t>SSL/TLS: secure connection</a:t>
+            </a:r>
+          </a:p>
+          <a:p>
+            <a:r>
+              <a:rPr lang="en-US" dirty="0"/>
+              <a:t>Latency: </a:t>
+            </a:r>
+            <a:r>
+              <a:rPr lang="en-US" dirty="0" err="1"/>
+              <a:t>waktu</a:t>
+            </a:r>
+            <a:r>
+              <a:rPr lang="en-US" dirty="0"/>
+              <a:t> loading website</a:t>
+            </a:r>
+          </a:p>
+          <a:p>
+            <a:r>
+              <a:rPr lang="en-US" dirty="0"/>
+              <a:t>Uptime: </a:t>
+            </a:r>
+            <a:r>
+              <a:rPr lang="en-US" dirty="0" err="1"/>
+              <a:t>persensate</a:t>
+            </a:r>
+            <a:r>
+              <a:rPr lang="en-US" dirty="0"/>
+              <a:t> </a:t>
+            </a:r>
+            <a:r>
+              <a:rPr lang="en-US" dirty="0" err="1"/>
+              <a:t>waktu</a:t>
+            </a:r>
+            <a:r>
+              <a:rPr lang="en-US" dirty="0"/>
+              <a:t> server </a:t>
+            </a:r>
+            <a:r>
+              <a:rPr lang="en-US" dirty="0" err="1"/>
+              <a:t>aktif</a:t>
+            </a:r>
+            <a:endParaRPr lang="en-US" dirty="0"/>
+          </a:p>
+          <a:p>
+            <a:r>
+              <a:rPr lang="en-US" dirty="0"/>
+              <a:t>Outbound/Inbound: data </a:t>
+            </a:r>
+            <a:r>
+              <a:rPr lang="en-US" dirty="0" err="1"/>
+              <a:t>keluar</a:t>
+            </a:r>
+            <a:r>
+              <a:rPr lang="en-US" dirty="0"/>
+              <a:t> data </a:t>
+            </a:r>
+            <a:r>
+              <a:rPr lang="en-US" dirty="0" err="1"/>
+              <a:t>masuk</a:t>
+            </a:r>
+            <a:r>
+              <a:rPr lang="en-US" dirty="0"/>
+              <a:t> (</a:t>
+            </a:r>
+            <a:r>
+              <a:rPr lang="en-US" dirty="0" err="1"/>
+              <a:t>penting</a:t>
+            </a:r>
+            <a:r>
+              <a:rPr lang="en-US" dirty="0"/>
+              <a:t> Ketika </a:t>
+            </a:r>
+            <a:r>
+              <a:rPr lang="en-US" dirty="0" err="1"/>
+              <a:t>pakai</a:t>
+            </a:r>
+            <a:r>
+              <a:rPr lang="en-US" dirty="0"/>
+              <a:t> cloud)</a:t>
+            </a:r>
+            <a:endParaRPr lang="en-ID" dirty="0"/>
+          </a:p>
+        </p:txBody>
+      </p:sp>
+      <p:sp>
+        <p:nvSpPr>
+          <p:cNvPr id="5" name="Date Placeholder 4">
+            <a:extLst>
+              <a:ext uri="{FF2B5EF4-FFF2-40B4-BE49-F238E27FC236}">
+                <a16:creationId xmlns:a16="http://schemas.microsoft.com/office/drawing/2014/main" id="{CF986091-EA68-80F0-6CFE-70026638BBB8}"/>
+              </a:ext>
+            </a:extLst>
+          </p:cNvPr>
+          <p:cNvSpPr>
+            <a:spLocks noGrp="1"/>
+          </p:cNvSpPr>
+          <p:nvPr>
+            <p:ph type="dt" sz="half" idx="10"/>
+          </p:nvPr>
+        </p:nvSpPr>
+        <p:spPr/>
+        <p:txBody>
+          <a:bodyPr/>
+          <a:lstStyle/>
+          <a:p>
+            <a:r>
+              <a:rPr lang="en-ID"/>
+              <a:t>27/02/2026</a:t>
+            </a:r>
+          </a:p>
+        </p:txBody>
+      </p:sp>
+      <p:sp>
+        <p:nvSpPr>
+          <p:cNvPr id="6" name="Footer Placeholder 5">
+            <a:extLst>
+              <a:ext uri="{FF2B5EF4-FFF2-40B4-BE49-F238E27FC236}">
+                <a16:creationId xmlns:a16="http://schemas.microsoft.com/office/drawing/2014/main" id="{C2438A10-E6A2-617D-7C41-2563F2EEAE93}"/>
+              </a:ext>
+            </a:extLst>
+          </p:cNvPr>
+          <p:cNvSpPr>
+            <a:spLocks noGrp="1"/>
+          </p:cNvSpPr>
+          <p:nvPr>
+            <p:ph type="ftr" sz="quarter" idx="11"/>
+          </p:nvPr>
+        </p:nvSpPr>
+        <p:spPr/>
+        <p:txBody>
+          <a:bodyPr/>
+          <a:lstStyle/>
+          <a:p>
+            <a:r>
+              <a:rPr lang="en-ID"/>
+              <a:t>Git</a:t>
+            </a:r>
+          </a:p>
+        </p:txBody>
+      </p:sp>
+    </p:spTree>
+    <p:extLst>
+      <p:ext uri="{BB962C8B-B14F-4D97-AF65-F5344CB8AC3E}">
+        <p14:creationId xmlns:p14="http://schemas.microsoft.com/office/powerpoint/2010/main" val="4174687711"/>
+      </p:ext>
+    </p:extLst>
+  </p:cSld>
+  <p:clrMapOvr>
+    <a:masterClrMapping/>
+  </p:clrMapOvr>
+</p:sld>
+</file>
+
+<file path=ppt/slides/slide55.xml><?xml version="1.0" encoding="utf-8"?>
+<p:sld xmlns:a="http://schemas.openxmlformats.org/drawingml/2006/main" xmlns:r="http://schemas.openxmlformats.org/officeDocument/2006/relationships" xmlns:p="http://schemas.openxmlformats.org/presentationml/2006/main">
+  <p:cSld>
+    <p:spTree>
+      <p:nvGrpSpPr>
+        <p:cNvPr id="1" name=""/>
+        <p:cNvGrpSpPr/>
+        <p:nvPr/>
+      </p:nvGrpSpPr>
+      <p:grpSpPr>
+        <a:xfrm>
+          <a:off x="0" y="0"/>
+          <a:ext cx="0" cy="0"/>
+          <a:chOff x="0" y="0"/>
+          <a:chExt cx="0" cy="0"/>
+        </a:xfrm>
+      </p:grpSpPr>
+      <p:sp>
+        <p:nvSpPr>
+          <p:cNvPr id="2" name="Title 1">
+            <a:extLst>
+              <a:ext uri="{FF2B5EF4-FFF2-40B4-BE49-F238E27FC236}">
+                <a16:creationId xmlns:a16="http://schemas.microsoft.com/office/drawing/2014/main" id="{C427E588-C8F6-3B34-CF40-CFA53F27CA80}"/>
+              </a:ext>
+            </a:extLst>
+          </p:cNvPr>
+          <p:cNvSpPr>
+            <a:spLocks noGrp="1"/>
+          </p:cNvSpPr>
+          <p:nvPr>
+            <p:ph type="title"/>
+          </p:nvPr>
+        </p:nvSpPr>
+        <p:spPr/>
+        <p:txBody>
+          <a:bodyPr/>
+          <a:lstStyle/>
+          <a:p>
+            <a:r>
+              <a:rPr lang="en-US" dirty="0"/>
+              <a:t>Type of hosting</a:t>
+            </a:r>
+            <a:endParaRPr lang="en-ID" dirty="0"/>
+          </a:p>
+        </p:txBody>
+      </p:sp>
+      <p:sp>
+        <p:nvSpPr>
+          <p:cNvPr id="4" name="Date Placeholder 3">
+            <a:extLst>
+              <a:ext uri="{FF2B5EF4-FFF2-40B4-BE49-F238E27FC236}">
+                <a16:creationId xmlns:a16="http://schemas.microsoft.com/office/drawing/2014/main" id="{1BFD4A2E-A4D5-3BA6-3B98-993D46FF9378}"/>
+              </a:ext>
+            </a:extLst>
+          </p:cNvPr>
+          <p:cNvSpPr>
+            <a:spLocks noGrp="1"/>
+          </p:cNvSpPr>
+          <p:nvPr>
+            <p:ph type="dt" sz="half" idx="10"/>
+          </p:nvPr>
+        </p:nvSpPr>
+        <p:spPr/>
+        <p:txBody>
+          <a:bodyPr/>
+          <a:lstStyle/>
+          <a:p>
+            <a:r>
+              <a:rPr lang="en-ID"/>
+              <a:t>27/02/2026</a:t>
+            </a:r>
+            <a:endParaRPr lang="en-ID" dirty="0"/>
+          </a:p>
+        </p:txBody>
+      </p:sp>
+      <p:sp>
+        <p:nvSpPr>
+          <p:cNvPr id="5" name="Footer Placeholder 4">
+            <a:extLst>
+              <a:ext uri="{FF2B5EF4-FFF2-40B4-BE49-F238E27FC236}">
+                <a16:creationId xmlns:a16="http://schemas.microsoft.com/office/drawing/2014/main" id="{958542E3-792C-945C-D01F-6755F1DB8093}"/>
+              </a:ext>
+            </a:extLst>
+          </p:cNvPr>
+          <p:cNvSpPr>
+            <a:spLocks noGrp="1"/>
+          </p:cNvSpPr>
+          <p:nvPr>
+            <p:ph type="ftr" sz="quarter" idx="11"/>
+          </p:nvPr>
+        </p:nvSpPr>
+        <p:spPr/>
+        <p:txBody>
+          <a:bodyPr/>
+          <a:lstStyle/>
+          <a:p>
+            <a:r>
+              <a:rPr lang="en-ID"/>
+              <a:t>Git</a:t>
+            </a:r>
+            <a:endParaRPr lang="en-ID" dirty="0"/>
+          </a:p>
+        </p:txBody>
+      </p:sp>
+      <p:pic>
+        <p:nvPicPr>
+          <p:cNvPr id="2050" name="Picture 2">
+            <a:extLst>
+              <a:ext uri="{FF2B5EF4-FFF2-40B4-BE49-F238E27FC236}">
+                <a16:creationId xmlns:a16="http://schemas.microsoft.com/office/drawing/2014/main" id="{83AF29B1-86A5-4340-B50D-C7542B1EADB7}"/>
+              </a:ext>
+            </a:extLst>
+          </p:cNvPr>
+          <p:cNvPicPr>
+            <a:picLocks noChangeAspect="1" noChangeArrowheads="1"/>
+          </p:cNvPicPr>
+          <p:nvPr/>
+        </p:nvPicPr>
+        <p:blipFill>
+          <a:blip r:embed="rId2">
+            <a:extLst>
+              <a:ext uri="{28A0092B-C50C-407E-A947-70E740481C1C}">
+                <a14:useLocalDpi xmlns:a14="http://schemas.microsoft.com/office/drawing/2010/main" val="0"/>
+              </a:ext>
+            </a:extLst>
+          </a:blip>
+          <a:srcRect/>
+          <a:stretch>
+            <a:fillRect/>
+          </a:stretch>
+        </p:blipFill>
+        <p:spPr bwMode="auto">
+          <a:xfrm>
+            <a:off x="3143250" y="1690688"/>
+            <a:ext cx="5905500" cy="4010025"/>
+          </a:xfrm>
+          <a:prstGeom prst="rect">
+            <a:avLst/>
+          </a:prstGeom>
+          <a:noFill/>
+          <a:extLst>
+            <a:ext uri="{909E8E84-426E-40DD-AFC4-6F175D3DCCD1}">
+              <a14:hiddenFill xmlns:a14="http://schemas.microsoft.com/office/drawing/2010/main">
+                <a:solidFill>
+                  <a:srgbClr val="FFFFFF"/>
+                </a:solidFill>
+              </a14:hiddenFill>
+            </a:ext>
+          </a:extLst>
+        </p:spPr>
+      </p:pic>
+    </p:spTree>
+    <p:extLst>
+      <p:ext uri="{BB962C8B-B14F-4D97-AF65-F5344CB8AC3E}">
+        <p14:creationId xmlns:p14="http://schemas.microsoft.com/office/powerpoint/2010/main" val="3585033864"/>
+      </p:ext>
+    </p:extLst>
+  </p:cSld>
+  <p:clrMapOvr>
+    <a:masterClrMapping/>
+  </p:clrMapOvr>
+</p:sld>
+</file>
+
+<file path=ppt/slides/slide56.xml><?xml version="1.0" encoding="utf-8"?>
+<p:sld xmlns:a="http://schemas.openxmlformats.org/drawingml/2006/main" xmlns:r="http://schemas.openxmlformats.org/officeDocument/2006/relationships" xmlns:p="http://schemas.openxmlformats.org/presentationml/2006/main">
+  <p:cSld>
+    <p:spTree>
+      <p:nvGrpSpPr>
+        <p:cNvPr id="1" name="">
+          <a:extLst>
+            <a:ext uri="{FF2B5EF4-FFF2-40B4-BE49-F238E27FC236}">
+              <a16:creationId xmlns:a16="http://schemas.microsoft.com/office/drawing/2014/main" id="{62E624AD-4B21-9C19-DEB1-D149C9F3B002}"/>
+            </a:ext>
+          </a:extLst>
+        </p:cNvPr>
+        <p:cNvGrpSpPr/>
+        <p:nvPr/>
+      </p:nvGrpSpPr>
+      <p:grpSpPr>
+        <a:xfrm>
+          <a:off x="0" y="0"/>
+          <a:ext cx="0" cy="0"/>
+          <a:chOff x="0" y="0"/>
+          <a:chExt cx="0" cy="0"/>
+        </a:xfrm>
+      </p:grpSpPr>
+      <p:sp>
+        <p:nvSpPr>
+          <p:cNvPr id="2" name="Title 1">
+            <a:extLst>
+              <a:ext uri="{FF2B5EF4-FFF2-40B4-BE49-F238E27FC236}">
+                <a16:creationId xmlns:a16="http://schemas.microsoft.com/office/drawing/2014/main" id="{0D43669E-2503-54E2-F6B0-E06D0E0931D7}"/>
+              </a:ext>
+            </a:extLst>
+          </p:cNvPr>
+          <p:cNvSpPr>
+            <a:spLocks noGrp="1"/>
+          </p:cNvSpPr>
+          <p:nvPr>
+            <p:ph type="title"/>
+          </p:nvPr>
+        </p:nvSpPr>
+        <p:spPr/>
+        <p:txBody>
+          <a:bodyPr/>
+          <a:lstStyle/>
+          <a:p>
+            <a:r>
+              <a:rPr lang="en-US" dirty="0"/>
+              <a:t>Type of hosting</a:t>
+            </a:r>
+            <a:endParaRPr lang="en-ID" dirty="0"/>
+          </a:p>
+        </p:txBody>
+      </p:sp>
+      <p:sp>
+        <p:nvSpPr>
+          <p:cNvPr id="3" name="Content Placeholder 2">
+            <a:extLst>
+              <a:ext uri="{FF2B5EF4-FFF2-40B4-BE49-F238E27FC236}">
+                <a16:creationId xmlns:a16="http://schemas.microsoft.com/office/drawing/2014/main" id="{14C71459-FDE8-DE8C-53B3-C5EE52196C94}"/>
+              </a:ext>
+            </a:extLst>
+          </p:cNvPr>
+          <p:cNvSpPr>
+            <a:spLocks noGrp="1"/>
+          </p:cNvSpPr>
+          <p:nvPr>
+            <p:ph idx="1"/>
+          </p:nvPr>
+        </p:nvSpPr>
+        <p:spPr/>
+        <p:txBody>
+          <a:bodyPr/>
+          <a:lstStyle/>
+          <a:p>
+            <a:r>
+              <a:rPr lang="en-US" dirty="0" err="1"/>
+              <a:t>Secara</a:t>
+            </a:r>
+            <a:r>
+              <a:rPr lang="en-US" dirty="0"/>
+              <a:t> </a:t>
+            </a:r>
+            <a:r>
+              <a:rPr lang="en-US" dirty="0" err="1"/>
+              <a:t>kewajiban</a:t>
+            </a:r>
+            <a:r>
+              <a:rPr lang="en-US" dirty="0"/>
+              <a:t>:</a:t>
+            </a:r>
+          </a:p>
+          <a:p>
+            <a:pPr lvl="1"/>
+            <a:r>
+              <a:rPr lang="en-US" dirty="0"/>
+              <a:t>PaaS (platform as a service)</a:t>
+            </a:r>
+          </a:p>
+          <a:p>
+            <a:pPr lvl="2"/>
+            <a:r>
+              <a:rPr lang="en-US" dirty="0" err="1"/>
+              <a:t>Contoh</a:t>
+            </a:r>
+            <a:r>
+              <a:rPr lang="en-US" dirty="0"/>
+              <a:t>: Azure webapp, AWS </a:t>
+            </a:r>
+            <a:r>
+              <a:rPr lang="en-US" dirty="0" err="1"/>
+              <a:t>Lightsail</a:t>
+            </a:r>
+            <a:r>
+              <a:rPr lang="en-US" dirty="0"/>
+              <a:t>, GCP App Engine, Heroku, </a:t>
+            </a:r>
+            <a:r>
+              <a:rPr lang="en-US" dirty="0" err="1"/>
+              <a:t>Vercel</a:t>
+            </a:r>
+            <a:endParaRPr lang="en-US" dirty="0"/>
+          </a:p>
+          <a:p>
+            <a:pPr lvl="2"/>
+            <a:r>
+              <a:rPr lang="en-US" dirty="0"/>
+              <a:t>Kalian </a:t>
+            </a:r>
+            <a:r>
+              <a:rPr lang="en-US" dirty="0" err="1"/>
+              <a:t>fokus</a:t>
+            </a:r>
+            <a:r>
+              <a:rPr lang="en-US" dirty="0"/>
+              <a:t> pada app </a:t>
+            </a:r>
+            <a:r>
+              <a:rPr lang="en-US" dirty="0" err="1"/>
+              <a:t>saja</a:t>
+            </a:r>
+            <a:r>
+              <a:rPr lang="en-US" dirty="0"/>
+              <a:t>, </a:t>
+            </a:r>
+            <a:r>
+              <a:rPr lang="en-US" dirty="0" err="1"/>
+              <a:t>langsung</a:t>
+            </a:r>
+            <a:r>
+              <a:rPr lang="en-US" dirty="0"/>
+              <a:t> deploy, </a:t>
+            </a:r>
+            <a:r>
+              <a:rPr lang="en-US" dirty="0" err="1"/>
+              <a:t>tanpa</a:t>
+            </a:r>
+            <a:r>
+              <a:rPr lang="en-US" dirty="0"/>
+              <a:t> </a:t>
+            </a:r>
+            <a:r>
+              <a:rPr lang="en-US" dirty="0" err="1"/>
+              <a:t>mikirin</a:t>
+            </a:r>
+            <a:r>
+              <a:rPr lang="en-US" dirty="0"/>
+              <a:t> security </a:t>
+            </a:r>
+            <a:r>
+              <a:rPr lang="en-US" dirty="0" err="1"/>
+              <a:t>servernya</a:t>
+            </a:r>
+            <a:r>
+              <a:rPr lang="en-US" dirty="0"/>
+              <a:t> (</a:t>
+            </a:r>
+            <a:r>
+              <a:rPr lang="en-US" dirty="0" err="1"/>
+              <a:t>bukan</a:t>
+            </a:r>
+            <a:r>
+              <a:rPr lang="en-US" dirty="0"/>
+              <a:t> app </a:t>
+            </a:r>
+            <a:r>
+              <a:rPr lang="en-US" dirty="0" err="1"/>
+              <a:t>ya</a:t>
+            </a:r>
+            <a:r>
+              <a:rPr lang="en-US" dirty="0"/>
+              <a:t>)</a:t>
+            </a:r>
+          </a:p>
+          <a:p>
+            <a:pPr lvl="1"/>
+            <a:r>
+              <a:rPr lang="en-US" dirty="0"/>
+              <a:t>IaaS (infrastructure as a service)</a:t>
+            </a:r>
+          </a:p>
+          <a:p>
+            <a:pPr lvl="2"/>
+            <a:r>
+              <a:rPr lang="en-US" dirty="0" err="1"/>
+              <a:t>Contoh</a:t>
+            </a:r>
+            <a:r>
+              <a:rPr lang="en-US" dirty="0"/>
+              <a:t>: shared hosting, VPS hosting</a:t>
+            </a:r>
+          </a:p>
+          <a:p>
+            <a:pPr lvl="2"/>
+            <a:r>
+              <a:rPr lang="en-US" dirty="0" err="1"/>
+              <a:t>Fokus</a:t>
+            </a:r>
+            <a:r>
+              <a:rPr lang="en-US" dirty="0"/>
+              <a:t> pada both app dan server, </a:t>
+            </a:r>
+            <a:r>
+              <a:rPr lang="en-US" dirty="0" err="1"/>
+              <a:t>harus</a:t>
+            </a:r>
+            <a:r>
+              <a:rPr lang="en-US" dirty="0"/>
+              <a:t> maintain security dan OS update</a:t>
+            </a:r>
+            <a:endParaRPr lang="en-ID" dirty="0"/>
+          </a:p>
+        </p:txBody>
+      </p:sp>
+      <p:sp>
+        <p:nvSpPr>
+          <p:cNvPr id="4" name="Date Placeholder 3">
+            <a:extLst>
+              <a:ext uri="{FF2B5EF4-FFF2-40B4-BE49-F238E27FC236}">
+                <a16:creationId xmlns:a16="http://schemas.microsoft.com/office/drawing/2014/main" id="{F4F82CF6-DDB9-A9DC-2E2C-25F61785279E}"/>
+              </a:ext>
+            </a:extLst>
+          </p:cNvPr>
+          <p:cNvSpPr>
+            <a:spLocks noGrp="1"/>
+          </p:cNvSpPr>
+          <p:nvPr>
+            <p:ph type="dt" sz="half" idx="10"/>
+          </p:nvPr>
+        </p:nvSpPr>
+        <p:spPr/>
+        <p:txBody>
+          <a:bodyPr/>
+          <a:lstStyle/>
+          <a:p>
+            <a:r>
+              <a:rPr lang="en-ID"/>
+              <a:t>27/02/2026</a:t>
+            </a:r>
+            <a:endParaRPr lang="en-ID" dirty="0"/>
+          </a:p>
+        </p:txBody>
+      </p:sp>
+      <p:sp>
+        <p:nvSpPr>
+          <p:cNvPr id="5" name="Footer Placeholder 4">
+            <a:extLst>
+              <a:ext uri="{FF2B5EF4-FFF2-40B4-BE49-F238E27FC236}">
+                <a16:creationId xmlns:a16="http://schemas.microsoft.com/office/drawing/2014/main" id="{5325A81D-8EDF-A1D7-51E3-327A3FC1BD34}"/>
+              </a:ext>
+            </a:extLst>
+          </p:cNvPr>
+          <p:cNvSpPr>
+            <a:spLocks noGrp="1"/>
+          </p:cNvSpPr>
+          <p:nvPr>
+            <p:ph type="ftr" sz="quarter" idx="11"/>
+          </p:nvPr>
+        </p:nvSpPr>
+        <p:spPr/>
+        <p:txBody>
+          <a:bodyPr/>
+          <a:lstStyle/>
+          <a:p>
+            <a:r>
+              <a:rPr lang="en-ID"/>
+              <a:t>Git</a:t>
+            </a:r>
+            <a:endParaRPr lang="en-ID" dirty="0"/>
+          </a:p>
+        </p:txBody>
+      </p:sp>
+    </p:spTree>
+    <p:extLst>
+      <p:ext uri="{BB962C8B-B14F-4D97-AF65-F5344CB8AC3E}">
+        <p14:creationId xmlns:p14="http://schemas.microsoft.com/office/powerpoint/2010/main" val="4051088487"/>
+      </p:ext>
+    </p:extLst>
+  </p:cSld>
+  <p:clrMapOvr>
+    <a:masterClrMapping/>
+  </p:clrMapOvr>
+</p:sld>
+</file>
+
+<file path=ppt/slides/slide57.xml><?xml version="1.0" encoding="utf-8"?>
+<p:sld xmlns:a="http://schemas.openxmlformats.org/drawingml/2006/main" xmlns:r="http://schemas.openxmlformats.org/officeDocument/2006/relationships" xmlns:p="http://schemas.openxmlformats.org/presentationml/2006/main">
+  <p:cSld>
+    <p:spTree>
+      <p:nvGrpSpPr>
+        <p:cNvPr id="1" name="">
+          <a:extLst>
+            <a:ext uri="{FF2B5EF4-FFF2-40B4-BE49-F238E27FC236}">
+              <a16:creationId xmlns:a16="http://schemas.microsoft.com/office/drawing/2014/main" id="{C3F5B6D4-A566-358E-C59D-F3DF16E980CD}"/>
+            </a:ext>
+          </a:extLst>
+        </p:cNvPr>
+        <p:cNvGrpSpPr/>
+        <p:nvPr/>
+      </p:nvGrpSpPr>
+      <p:grpSpPr>
+        <a:xfrm>
+          <a:off x="0" y="0"/>
+          <a:ext cx="0" cy="0"/>
+          <a:chOff x="0" y="0"/>
+          <a:chExt cx="0" cy="0"/>
+        </a:xfrm>
+      </p:grpSpPr>
+      <p:sp>
+        <p:nvSpPr>
+          <p:cNvPr id="2" name="Title 1">
+            <a:extLst>
+              <a:ext uri="{FF2B5EF4-FFF2-40B4-BE49-F238E27FC236}">
+                <a16:creationId xmlns:a16="http://schemas.microsoft.com/office/drawing/2014/main" id="{12AE97CF-2261-1A87-4A92-0B18B4DEAC7D}"/>
+              </a:ext>
+            </a:extLst>
+          </p:cNvPr>
+          <p:cNvSpPr>
+            <a:spLocks noGrp="1"/>
+          </p:cNvSpPr>
+          <p:nvPr>
+            <p:ph type="title"/>
+          </p:nvPr>
+        </p:nvSpPr>
+        <p:spPr/>
+        <p:txBody>
+          <a:bodyPr/>
+          <a:lstStyle/>
+          <a:p>
+            <a:r>
+              <a:rPr lang="en-US" dirty="0"/>
+              <a:t>Type of hosting</a:t>
+            </a:r>
+            <a:endParaRPr lang="en-ID" dirty="0"/>
+          </a:p>
+        </p:txBody>
+      </p:sp>
+      <p:sp>
+        <p:nvSpPr>
+          <p:cNvPr id="3" name="Content Placeholder 2">
+            <a:extLst>
+              <a:ext uri="{FF2B5EF4-FFF2-40B4-BE49-F238E27FC236}">
+                <a16:creationId xmlns:a16="http://schemas.microsoft.com/office/drawing/2014/main" id="{2556E678-A9D7-A684-3B37-D2744CB9E7A8}"/>
+              </a:ext>
+            </a:extLst>
+          </p:cNvPr>
+          <p:cNvSpPr>
+            <a:spLocks noGrp="1"/>
+          </p:cNvSpPr>
+          <p:nvPr>
+            <p:ph idx="1"/>
+          </p:nvPr>
+        </p:nvSpPr>
+        <p:spPr/>
+        <p:txBody>
+          <a:bodyPr/>
+          <a:lstStyle/>
+          <a:p>
+            <a:r>
+              <a:rPr lang="en-US" dirty="0" err="1"/>
+              <a:t>Secara</a:t>
+            </a:r>
+            <a:r>
+              <a:rPr lang="en-US" dirty="0"/>
+              <a:t> </a:t>
+            </a:r>
+            <a:r>
+              <a:rPr lang="en-US" dirty="0" err="1"/>
+              <a:t>kepemilikan</a:t>
+            </a:r>
+            <a:r>
+              <a:rPr lang="en-US" dirty="0"/>
+              <a:t> </a:t>
+            </a:r>
+            <a:r>
+              <a:rPr lang="en-US" dirty="0" err="1"/>
+              <a:t>dibagi</a:t>
+            </a:r>
+            <a:r>
+              <a:rPr lang="en-US" dirty="0"/>
+              <a:t> </a:t>
+            </a:r>
+            <a:r>
+              <a:rPr lang="en-US" dirty="0" err="1"/>
+              <a:t>menjadi</a:t>
+            </a:r>
+            <a:endParaRPr lang="en-US" dirty="0"/>
+          </a:p>
+          <a:p>
+            <a:pPr lvl="1"/>
+            <a:r>
+              <a:rPr lang="en-US" dirty="0"/>
+              <a:t>Shared Hosting</a:t>
+            </a:r>
+          </a:p>
+          <a:p>
+            <a:pPr lvl="2"/>
+            <a:r>
+              <a:rPr lang="en-US" dirty="0"/>
+              <a:t>Less resource, sharing </a:t>
+            </a:r>
+            <a:r>
+              <a:rPr lang="en-US" dirty="0" err="1"/>
+              <a:t>dengan</a:t>
+            </a:r>
+            <a:r>
+              <a:rPr lang="en-US" dirty="0"/>
+              <a:t> orang lain, </a:t>
+            </a:r>
+            <a:r>
+              <a:rPr lang="en-US" dirty="0" err="1"/>
+              <a:t>biasanya</a:t>
+            </a:r>
+            <a:r>
+              <a:rPr lang="en-US" dirty="0"/>
+              <a:t> </a:t>
+            </a:r>
+            <a:r>
+              <a:rPr lang="en-US" dirty="0" err="1"/>
+              <a:t>terbatas</a:t>
+            </a:r>
+            <a:r>
+              <a:rPr lang="en-US" dirty="0"/>
+              <a:t> </a:t>
+            </a:r>
+            <a:r>
+              <a:rPr lang="en-US" dirty="0" err="1"/>
+              <a:t>kontrolnya</a:t>
+            </a:r>
+            <a:endParaRPr lang="en-US" dirty="0"/>
+          </a:p>
+          <a:p>
+            <a:pPr lvl="2"/>
+            <a:r>
+              <a:rPr lang="en-US" dirty="0"/>
+              <a:t>Ciri </a:t>
+            </a:r>
+            <a:r>
+              <a:rPr lang="en-US" dirty="0" err="1"/>
+              <a:t>unik</a:t>
+            </a:r>
+            <a:r>
+              <a:rPr lang="en-US" dirty="0"/>
+              <a:t>: </a:t>
+            </a:r>
+            <a:r>
+              <a:rPr lang="en-US" dirty="0" err="1"/>
+              <a:t>sering</a:t>
+            </a:r>
+            <a:r>
+              <a:rPr lang="en-US" dirty="0"/>
+              <a:t> </a:t>
+            </a:r>
+            <a:r>
+              <a:rPr lang="en-US" dirty="0" err="1"/>
+              <a:t>pake</a:t>
+            </a:r>
+            <a:r>
+              <a:rPr lang="en-US" dirty="0"/>
+              <a:t> </a:t>
+            </a:r>
+            <a:r>
+              <a:rPr lang="en-US" dirty="0" err="1"/>
+              <a:t>Cpanel</a:t>
+            </a:r>
+            <a:r>
+              <a:rPr lang="en-US" dirty="0"/>
+              <a:t> </a:t>
+            </a:r>
+            <a:r>
+              <a:rPr lang="en-US" dirty="0" err="1"/>
+              <a:t>atau</a:t>
+            </a:r>
+            <a:r>
+              <a:rPr lang="en-US" dirty="0"/>
+              <a:t> </a:t>
+            </a:r>
+            <a:r>
+              <a:rPr lang="en-US" dirty="0" err="1"/>
+              <a:t>sejenisnya</a:t>
+            </a:r>
+            <a:endParaRPr lang="en-US" dirty="0"/>
+          </a:p>
+          <a:p>
+            <a:pPr lvl="1"/>
+            <a:r>
+              <a:rPr lang="en-US" dirty="0"/>
+              <a:t>VPS (Private server)</a:t>
+            </a:r>
+          </a:p>
+          <a:p>
+            <a:pPr lvl="2"/>
+            <a:r>
+              <a:rPr lang="en-US" dirty="0"/>
+              <a:t>Dunia </a:t>
+            </a:r>
+            <a:r>
+              <a:rPr lang="en-US" dirty="0" err="1"/>
+              <a:t>milik</a:t>
+            </a:r>
+            <a:r>
+              <a:rPr lang="en-US" dirty="0"/>
+              <a:t> </a:t>
+            </a:r>
+            <a:r>
+              <a:rPr lang="en-US" dirty="0" err="1"/>
+              <a:t>sendiri</a:t>
+            </a:r>
+            <a:r>
+              <a:rPr lang="en-US" dirty="0"/>
+              <a:t>, full </a:t>
+            </a:r>
+            <a:r>
+              <a:rPr lang="en-US" dirty="0" err="1"/>
+              <a:t>utak</a:t>
+            </a:r>
+            <a:r>
+              <a:rPr lang="en-US" dirty="0"/>
+              <a:t> </a:t>
+            </a:r>
+            <a:r>
+              <a:rPr lang="en-US" dirty="0" err="1"/>
+              <a:t>atik</a:t>
+            </a:r>
+            <a:r>
+              <a:rPr lang="en-US" dirty="0"/>
+              <a:t> </a:t>
+            </a:r>
+            <a:r>
+              <a:rPr lang="en-US" dirty="0" err="1"/>
+              <a:t>sendiri</a:t>
+            </a:r>
+            <a:endParaRPr lang="en-ID" dirty="0"/>
+          </a:p>
+        </p:txBody>
+      </p:sp>
+      <p:sp>
+        <p:nvSpPr>
+          <p:cNvPr id="4" name="Date Placeholder 3">
+            <a:extLst>
+              <a:ext uri="{FF2B5EF4-FFF2-40B4-BE49-F238E27FC236}">
+                <a16:creationId xmlns:a16="http://schemas.microsoft.com/office/drawing/2014/main" id="{E4924F0F-0CE6-E0AC-FD24-4BF953271239}"/>
+              </a:ext>
+            </a:extLst>
+          </p:cNvPr>
+          <p:cNvSpPr>
+            <a:spLocks noGrp="1"/>
+          </p:cNvSpPr>
+          <p:nvPr>
+            <p:ph type="dt" sz="half" idx="10"/>
+          </p:nvPr>
+        </p:nvSpPr>
+        <p:spPr/>
+        <p:txBody>
+          <a:bodyPr/>
+          <a:lstStyle/>
+          <a:p>
+            <a:r>
+              <a:rPr lang="en-ID"/>
+              <a:t>27/02/2026</a:t>
+            </a:r>
+            <a:endParaRPr lang="en-ID" dirty="0"/>
+          </a:p>
+        </p:txBody>
+      </p:sp>
+      <p:sp>
+        <p:nvSpPr>
+          <p:cNvPr id="5" name="Footer Placeholder 4">
+            <a:extLst>
+              <a:ext uri="{FF2B5EF4-FFF2-40B4-BE49-F238E27FC236}">
+                <a16:creationId xmlns:a16="http://schemas.microsoft.com/office/drawing/2014/main" id="{ED4BAB03-C185-5BE2-F1F7-DC356E57A68E}"/>
+              </a:ext>
+            </a:extLst>
+          </p:cNvPr>
+          <p:cNvSpPr>
+            <a:spLocks noGrp="1"/>
+          </p:cNvSpPr>
+          <p:nvPr>
+            <p:ph type="ftr" sz="quarter" idx="11"/>
+          </p:nvPr>
+        </p:nvSpPr>
+        <p:spPr/>
+        <p:txBody>
+          <a:bodyPr/>
+          <a:lstStyle/>
+          <a:p>
+            <a:r>
+              <a:rPr lang="en-ID"/>
+              <a:t>Git</a:t>
+            </a:r>
+            <a:endParaRPr lang="en-ID" dirty="0"/>
+          </a:p>
+        </p:txBody>
+      </p:sp>
+    </p:spTree>
+    <p:extLst>
+      <p:ext uri="{BB962C8B-B14F-4D97-AF65-F5344CB8AC3E}">
+        <p14:creationId xmlns:p14="http://schemas.microsoft.com/office/powerpoint/2010/main" val="4227658737"/>
+      </p:ext>
+    </p:extLst>
+  </p:cSld>
+  <p:clrMapOvr>
+    <a:masterClrMapping/>
+  </p:clrMapOvr>
+</p:sld>
+</file>
+
+<file path=ppt/slides/slide58.xml><?xml version="1.0" encoding="utf-8"?>
+<p:sld xmlns:a="http://schemas.openxmlformats.org/drawingml/2006/main" xmlns:r="http://schemas.openxmlformats.org/officeDocument/2006/relationships" xmlns:p="http://schemas.openxmlformats.org/presentationml/2006/main">
+  <p:cSld>
+    <p:spTree>
+      <p:nvGrpSpPr>
+        <p:cNvPr id="1" name="">
+          <a:extLst>
+            <a:ext uri="{FF2B5EF4-FFF2-40B4-BE49-F238E27FC236}">
+              <a16:creationId xmlns:a16="http://schemas.microsoft.com/office/drawing/2014/main" id="{4976589F-7EE8-DB0C-0A90-562089C70B02}"/>
+            </a:ext>
+          </a:extLst>
+        </p:cNvPr>
+        <p:cNvGrpSpPr/>
+        <p:nvPr/>
+      </p:nvGrpSpPr>
+      <p:grpSpPr>
+        <a:xfrm>
+          <a:off x="0" y="0"/>
+          <a:ext cx="0" cy="0"/>
+          <a:chOff x="0" y="0"/>
+          <a:chExt cx="0" cy="0"/>
+        </a:xfrm>
+      </p:grpSpPr>
+      <p:sp>
+        <p:nvSpPr>
+          <p:cNvPr id="2" name="Title 1">
+            <a:extLst>
+              <a:ext uri="{FF2B5EF4-FFF2-40B4-BE49-F238E27FC236}">
+                <a16:creationId xmlns:a16="http://schemas.microsoft.com/office/drawing/2014/main" id="{D8DBC906-36D7-782F-B2C6-D10EA90E7FE0}"/>
+              </a:ext>
+            </a:extLst>
+          </p:cNvPr>
+          <p:cNvSpPr>
+            <a:spLocks noGrp="1"/>
+          </p:cNvSpPr>
+          <p:nvPr>
+            <p:ph type="title"/>
+          </p:nvPr>
+        </p:nvSpPr>
+        <p:spPr/>
+        <p:txBody>
+          <a:bodyPr/>
+          <a:lstStyle/>
+          <a:p>
+            <a:r>
+              <a:rPr lang="en-US" dirty="0"/>
+              <a:t>Hosting biology (VPS)</a:t>
+            </a:r>
+            <a:endParaRPr lang="en-ID" dirty="0"/>
+          </a:p>
+        </p:txBody>
+      </p:sp>
+      <p:sp>
+        <p:nvSpPr>
+          <p:cNvPr id="10" name="Content Placeholder 9">
+            <a:extLst>
+              <a:ext uri="{FF2B5EF4-FFF2-40B4-BE49-F238E27FC236}">
+                <a16:creationId xmlns:a16="http://schemas.microsoft.com/office/drawing/2014/main" id="{9A344457-9763-FB6B-9857-2281E42BE049}"/>
+              </a:ext>
+            </a:extLst>
+          </p:cNvPr>
+          <p:cNvSpPr>
+            <a:spLocks noGrp="1"/>
+          </p:cNvSpPr>
+          <p:nvPr>
+            <p:ph idx="1"/>
+          </p:nvPr>
+        </p:nvSpPr>
+        <p:spPr>
+          <a:xfrm>
+            <a:off x="838199" y="1825625"/>
+            <a:ext cx="5138887" cy="4351338"/>
+          </a:xfrm>
+        </p:spPr>
+        <p:txBody>
+          <a:bodyPr/>
+          <a:lstStyle/>
+          <a:p>
+            <a:r>
+              <a:rPr lang="en-US" dirty="0"/>
+              <a:t>Simple’s there is</a:t>
+            </a:r>
+          </a:p>
+          <a:p>
+            <a:pPr lvl="1"/>
+            <a:r>
+              <a:rPr lang="en-US" dirty="0"/>
+              <a:t>Ada Server, </a:t>
+            </a:r>
+            <a:r>
+              <a:rPr lang="en-US" dirty="0" err="1"/>
+              <a:t>dalamnya</a:t>
+            </a:r>
+            <a:r>
+              <a:rPr lang="en-US" dirty="0"/>
+              <a:t> </a:t>
+            </a:r>
+            <a:r>
+              <a:rPr lang="en-US" dirty="0" err="1"/>
+              <a:t>ada</a:t>
+            </a:r>
+            <a:r>
+              <a:rPr lang="en-US" dirty="0"/>
+              <a:t>:</a:t>
+            </a:r>
+          </a:p>
+          <a:p>
+            <a:pPr lvl="2"/>
+            <a:r>
+              <a:rPr lang="en-US" dirty="0" err="1"/>
+              <a:t>Databasenya</a:t>
+            </a:r>
+            <a:endParaRPr lang="en-US" dirty="0"/>
+          </a:p>
+          <a:p>
+            <a:pPr lvl="2"/>
+            <a:r>
+              <a:rPr lang="en-US" dirty="0"/>
+              <a:t>App </a:t>
+            </a:r>
+            <a:r>
+              <a:rPr lang="en-US" dirty="0" err="1"/>
+              <a:t>nya</a:t>
+            </a:r>
+            <a:r>
+              <a:rPr lang="en-US" dirty="0"/>
+              <a:t> (Misal Laravel)</a:t>
+            </a:r>
+          </a:p>
+          <a:p>
+            <a:pPr lvl="2"/>
+            <a:r>
+              <a:rPr lang="en-US" dirty="0"/>
+              <a:t>Reverse Proxy</a:t>
+            </a:r>
+          </a:p>
+          <a:p>
+            <a:pPr lvl="2"/>
+            <a:endParaRPr lang="en-US" dirty="0"/>
+          </a:p>
+          <a:p>
+            <a:pPr lvl="1"/>
+            <a:r>
+              <a:rPr lang="en-US" dirty="0" err="1"/>
+              <a:t>Boleh</a:t>
+            </a:r>
+            <a:r>
+              <a:rPr lang="en-US" dirty="0"/>
+              <a:t> ga </a:t>
+            </a:r>
+            <a:r>
+              <a:rPr lang="en-US" dirty="0" err="1"/>
+              <a:t>kalau</a:t>
+            </a:r>
+            <a:r>
+              <a:rPr lang="en-US" dirty="0"/>
+              <a:t> DB </a:t>
+            </a:r>
+            <a:r>
+              <a:rPr lang="en-US" dirty="0" err="1"/>
+              <a:t>nya</a:t>
+            </a:r>
+            <a:r>
+              <a:rPr lang="en-US" dirty="0"/>
+              <a:t> di server lain? </a:t>
+            </a:r>
+            <a:r>
+              <a:rPr lang="en-US" dirty="0" err="1"/>
+              <a:t>Boleh</a:t>
+            </a:r>
+            <a:r>
+              <a:rPr lang="en-US" dirty="0"/>
+              <a:t>, </a:t>
+            </a:r>
+            <a:r>
+              <a:rPr lang="en-US" dirty="0" err="1"/>
+              <a:t>sah</a:t>
+            </a:r>
+            <a:r>
+              <a:rPr lang="en-US" dirty="0"/>
+              <a:t> </a:t>
+            </a:r>
+            <a:r>
+              <a:rPr lang="en-US" dirty="0" err="1"/>
+              <a:t>sah</a:t>
+            </a:r>
+            <a:r>
+              <a:rPr lang="en-US" dirty="0"/>
+              <a:t> </a:t>
+            </a:r>
+            <a:r>
+              <a:rPr lang="en-US" dirty="0" err="1"/>
+              <a:t>aja</a:t>
+            </a:r>
+            <a:endParaRPr lang="en-US" dirty="0"/>
+          </a:p>
+        </p:txBody>
+      </p:sp>
+      <p:sp>
+        <p:nvSpPr>
+          <p:cNvPr id="4" name="Date Placeholder 3">
+            <a:extLst>
+              <a:ext uri="{FF2B5EF4-FFF2-40B4-BE49-F238E27FC236}">
+                <a16:creationId xmlns:a16="http://schemas.microsoft.com/office/drawing/2014/main" id="{334DCF48-AFBA-3ECD-C988-A9C2F6490333}"/>
+              </a:ext>
+            </a:extLst>
+          </p:cNvPr>
+          <p:cNvSpPr>
+            <a:spLocks noGrp="1"/>
+          </p:cNvSpPr>
+          <p:nvPr>
+            <p:ph type="dt" sz="half" idx="10"/>
+          </p:nvPr>
+        </p:nvSpPr>
+        <p:spPr/>
+        <p:txBody>
+          <a:bodyPr/>
+          <a:lstStyle/>
+          <a:p>
+            <a:r>
+              <a:rPr lang="en-ID"/>
+              <a:t>27/02/2026</a:t>
+            </a:r>
+            <a:endParaRPr lang="en-ID" dirty="0"/>
+          </a:p>
+        </p:txBody>
+      </p:sp>
+      <p:sp>
+        <p:nvSpPr>
+          <p:cNvPr id="5" name="Footer Placeholder 4">
+            <a:extLst>
+              <a:ext uri="{FF2B5EF4-FFF2-40B4-BE49-F238E27FC236}">
+                <a16:creationId xmlns:a16="http://schemas.microsoft.com/office/drawing/2014/main" id="{F0C1A720-8C22-8B47-3B44-75084CC7E9BC}"/>
+              </a:ext>
+            </a:extLst>
+          </p:cNvPr>
+          <p:cNvSpPr>
+            <a:spLocks noGrp="1"/>
+          </p:cNvSpPr>
+          <p:nvPr>
+            <p:ph type="ftr" sz="quarter" idx="11"/>
+          </p:nvPr>
+        </p:nvSpPr>
+        <p:spPr/>
+        <p:txBody>
+          <a:bodyPr/>
+          <a:lstStyle/>
+          <a:p>
+            <a:r>
+              <a:rPr lang="en-ID"/>
+              <a:t>Git</a:t>
+            </a:r>
+            <a:endParaRPr lang="en-ID" dirty="0"/>
+          </a:p>
+        </p:txBody>
+      </p:sp>
+      <p:pic>
+        <p:nvPicPr>
+          <p:cNvPr id="12" name="Picture 11">
+            <a:extLst>
+              <a:ext uri="{FF2B5EF4-FFF2-40B4-BE49-F238E27FC236}">
+                <a16:creationId xmlns:a16="http://schemas.microsoft.com/office/drawing/2014/main" id="{B1179584-8EE5-4BA7-A3D8-80FDDA595634}"/>
+              </a:ext>
+            </a:extLst>
+          </p:cNvPr>
+          <p:cNvPicPr>
+            <a:picLocks noChangeAspect="1"/>
+          </p:cNvPicPr>
+          <p:nvPr/>
+        </p:nvPicPr>
+        <p:blipFill>
+          <a:blip r:embed="rId2"/>
+          <a:stretch>
+            <a:fillRect/>
+          </a:stretch>
+        </p:blipFill>
+        <p:spPr>
+          <a:xfrm>
+            <a:off x="6455344" y="1829468"/>
+            <a:ext cx="5294204" cy="3015242"/>
+          </a:xfrm>
+          <a:prstGeom prst="rect">
+            <a:avLst/>
+          </a:prstGeom>
+        </p:spPr>
+      </p:pic>
+    </p:spTree>
+    <p:extLst>
+      <p:ext uri="{BB962C8B-B14F-4D97-AF65-F5344CB8AC3E}">
+        <p14:creationId xmlns:p14="http://schemas.microsoft.com/office/powerpoint/2010/main" val="1527273090"/>
+      </p:ext>
+    </p:extLst>
+  </p:cSld>
+  <p:clrMapOvr>
+    <a:masterClrMapping/>
+  </p:clrMapOvr>
+</p:sld>
+</file>
+
+<file path=ppt/slides/slide59.xml><?xml version="1.0" encoding="utf-8"?>
+<p:sld xmlns:a="http://schemas.openxmlformats.org/drawingml/2006/main" xmlns:r="http://schemas.openxmlformats.org/officeDocument/2006/relationships" xmlns:p="http://schemas.openxmlformats.org/presentationml/2006/main">
+  <p:cSld>
+    <p:spTree>
+      <p:nvGrpSpPr>
+        <p:cNvPr id="1" name="">
+          <a:extLst>
+            <a:ext uri="{FF2B5EF4-FFF2-40B4-BE49-F238E27FC236}">
+              <a16:creationId xmlns:a16="http://schemas.microsoft.com/office/drawing/2014/main" id="{2F2A4215-C10E-9549-2BD8-75F95345D2CB}"/>
+            </a:ext>
+          </a:extLst>
+        </p:cNvPr>
+        <p:cNvGrpSpPr/>
+        <p:nvPr/>
+      </p:nvGrpSpPr>
+      <p:grpSpPr>
+        <a:xfrm>
+          <a:off x="0" y="0"/>
+          <a:ext cx="0" cy="0"/>
+          <a:chOff x="0" y="0"/>
+          <a:chExt cx="0" cy="0"/>
+        </a:xfrm>
+      </p:grpSpPr>
+      <p:sp>
+        <p:nvSpPr>
+          <p:cNvPr id="2" name="Title 1">
+            <a:extLst>
+              <a:ext uri="{FF2B5EF4-FFF2-40B4-BE49-F238E27FC236}">
+                <a16:creationId xmlns:a16="http://schemas.microsoft.com/office/drawing/2014/main" id="{93EE4198-C98D-6BFD-4BED-70C7FD1AD111}"/>
+              </a:ext>
+            </a:extLst>
+          </p:cNvPr>
+          <p:cNvSpPr>
+            <a:spLocks noGrp="1"/>
+          </p:cNvSpPr>
+          <p:nvPr>
+            <p:ph type="title"/>
+          </p:nvPr>
+        </p:nvSpPr>
+        <p:spPr/>
+        <p:txBody>
+          <a:bodyPr/>
+          <a:lstStyle/>
+          <a:p>
+            <a:r>
+              <a:rPr lang="en-US"/>
+              <a:t>Hosting biology (shared hosting)</a:t>
+            </a:r>
+            <a:endParaRPr lang="en-ID" dirty="0"/>
+          </a:p>
+        </p:txBody>
+      </p:sp>
+      <p:sp>
+        <p:nvSpPr>
+          <p:cNvPr id="10" name="Content Placeholder 9">
+            <a:extLst>
+              <a:ext uri="{FF2B5EF4-FFF2-40B4-BE49-F238E27FC236}">
+                <a16:creationId xmlns:a16="http://schemas.microsoft.com/office/drawing/2014/main" id="{CB4CB80C-23D3-B55C-F918-47822A007E51}"/>
+              </a:ext>
+            </a:extLst>
+          </p:cNvPr>
+          <p:cNvSpPr>
+            <a:spLocks noGrp="1"/>
+          </p:cNvSpPr>
+          <p:nvPr>
+            <p:ph idx="1"/>
+          </p:nvPr>
+        </p:nvSpPr>
+        <p:spPr>
+          <a:xfrm>
+            <a:off x="838199" y="1825625"/>
+            <a:ext cx="5138887" cy="4351338"/>
+          </a:xfrm>
+        </p:spPr>
+        <p:txBody>
+          <a:bodyPr/>
+          <a:lstStyle/>
+          <a:p>
+            <a:r>
+              <a:rPr lang="en-US" dirty="0"/>
+              <a:t>Simple’s there is</a:t>
+            </a:r>
+          </a:p>
+          <a:p>
+            <a:pPr lvl="1"/>
+            <a:r>
+              <a:rPr lang="en-US" dirty="0"/>
+              <a:t>Ada Server, </a:t>
+            </a:r>
+            <a:r>
+              <a:rPr lang="en-US" dirty="0" err="1"/>
+              <a:t>dalamnya</a:t>
+            </a:r>
+            <a:r>
+              <a:rPr lang="en-US" dirty="0"/>
+              <a:t> </a:t>
+            </a:r>
+            <a:r>
+              <a:rPr lang="en-US" dirty="0" err="1"/>
+              <a:t>ada</a:t>
+            </a:r>
+            <a:r>
+              <a:rPr lang="en-US" dirty="0"/>
+              <a:t>:</a:t>
+            </a:r>
+          </a:p>
+          <a:p>
+            <a:pPr lvl="2"/>
+            <a:r>
+              <a:rPr lang="en-US" dirty="0" err="1"/>
+              <a:t>Databasenya</a:t>
+            </a:r>
+            <a:endParaRPr lang="en-US" dirty="0"/>
+          </a:p>
+          <a:p>
+            <a:pPr lvl="2"/>
+            <a:r>
+              <a:rPr lang="en-US" dirty="0"/>
+              <a:t>App </a:t>
+            </a:r>
+            <a:r>
+              <a:rPr lang="en-US" dirty="0" err="1"/>
+              <a:t>nya</a:t>
+            </a:r>
+            <a:r>
+              <a:rPr lang="en-US" dirty="0"/>
+              <a:t> (Misal Laravel)</a:t>
+            </a:r>
+          </a:p>
+          <a:p>
+            <a:pPr lvl="2"/>
+            <a:r>
+              <a:rPr lang="en-US" dirty="0"/>
+              <a:t>Reverse Proxy</a:t>
+            </a:r>
+          </a:p>
+          <a:p>
+            <a:pPr lvl="2"/>
+            <a:endParaRPr lang="en-US" dirty="0"/>
+          </a:p>
+          <a:p>
+            <a:pPr lvl="1"/>
+            <a:r>
+              <a:rPr lang="en-US" dirty="0" err="1"/>
+              <a:t>Boleh</a:t>
+            </a:r>
+            <a:r>
+              <a:rPr lang="en-US" dirty="0"/>
+              <a:t> ga </a:t>
+            </a:r>
+            <a:r>
+              <a:rPr lang="en-US" dirty="0" err="1"/>
+              <a:t>kalau</a:t>
+            </a:r>
+            <a:r>
+              <a:rPr lang="en-US" dirty="0"/>
+              <a:t> DB </a:t>
+            </a:r>
+            <a:r>
+              <a:rPr lang="en-US" dirty="0" err="1"/>
+              <a:t>nya</a:t>
+            </a:r>
+            <a:r>
+              <a:rPr lang="en-US" dirty="0"/>
+              <a:t> di server lain? </a:t>
+            </a:r>
+            <a:r>
+              <a:rPr lang="en-US" dirty="0" err="1"/>
+              <a:t>Boleh</a:t>
+            </a:r>
+            <a:r>
+              <a:rPr lang="en-US" dirty="0"/>
+              <a:t>, </a:t>
+            </a:r>
+            <a:r>
+              <a:rPr lang="en-US" dirty="0" err="1"/>
+              <a:t>sah</a:t>
+            </a:r>
+            <a:r>
+              <a:rPr lang="en-US" dirty="0"/>
+              <a:t> </a:t>
+            </a:r>
+            <a:r>
+              <a:rPr lang="en-US" dirty="0" err="1"/>
+              <a:t>sah</a:t>
+            </a:r>
+            <a:r>
+              <a:rPr lang="en-US" dirty="0"/>
+              <a:t> </a:t>
+            </a:r>
+            <a:r>
+              <a:rPr lang="en-US" dirty="0" err="1"/>
+              <a:t>aja</a:t>
+            </a:r>
+            <a:endParaRPr lang="en-US" dirty="0"/>
+          </a:p>
+        </p:txBody>
+      </p:sp>
+      <p:sp>
+        <p:nvSpPr>
+          <p:cNvPr id="4" name="Date Placeholder 3">
+            <a:extLst>
+              <a:ext uri="{FF2B5EF4-FFF2-40B4-BE49-F238E27FC236}">
+                <a16:creationId xmlns:a16="http://schemas.microsoft.com/office/drawing/2014/main" id="{B5783106-2148-DB14-7E64-19FF058DB6D3}"/>
+              </a:ext>
+            </a:extLst>
+          </p:cNvPr>
+          <p:cNvSpPr>
+            <a:spLocks noGrp="1"/>
+          </p:cNvSpPr>
+          <p:nvPr>
+            <p:ph type="dt" sz="half" idx="10"/>
+          </p:nvPr>
+        </p:nvSpPr>
+        <p:spPr/>
+        <p:txBody>
+          <a:bodyPr/>
+          <a:lstStyle/>
+          <a:p>
+            <a:r>
+              <a:rPr lang="en-ID"/>
+              <a:t>27/02/2026</a:t>
+            </a:r>
+            <a:endParaRPr lang="en-ID" dirty="0"/>
+          </a:p>
+        </p:txBody>
+      </p:sp>
+      <p:sp>
+        <p:nvSpPr>
+          <p:cNvPr id="5" name="Footer Placeholder 4">
+            <a:extLst>
+              <a:ext uri="{FF2B5EF4-FFF2-40B4-BE49-F238E27FC236}">
+                <a16:creationId xmlns:a16="http://schemas.microsoft.com/office/drawing/2014/main" id="{685BFC2A-917F-FA99-61F2-8728AAB74931}"/>
+              </a:ext>
+            </a:extLst>
+          </p:cNvPr>
+          <p:cNvSpPr>
+            <a:spLocks noGrp="1"/>
+          </p:cNvSpPr>
+          <p:nvPr>
+            <p:ph type="ftr" sz="quarter" idx="11"/>
+          </p:nvPr>
+        </p:nvSpPr>
+        <p:spPr/>
+        <p:txBody>
+          <a:bodyPr/>
+          <a:lstStyle/>
+          <a:p>
+            <a:r>
+              <a:rPr lang="en-ID"/>
+              <a:t>Git</a:t>
+            </a:r>
+            <a:endParaRPr lang="en-ID" dirty="0"/>
+          </a:p>
+        </p:txBody>
+      </p:sp>
+      <p:pic>
+        <p:nvPicPr>
+          <p:cNvPr id="12" name="Picture 11">
+            <a:extLst>
+              <a:ext uri="{FF2B5EF4-FFF2-40B4-BE49-F238E27FC236}">
+                <a16:creationId xmlns:a16="http://schemas.microsoft.com/office/drawing/2014/main" id="{37903A89-41C0-0BDB-9524-D775E6F0CD9F}"/>
+              </a:ext>
+            </a:extLst>
+          </p:cNvPr>
+          <p:cNvPicPr>
+            <a:picLocks noChangeAspect="1"/>
+          </p:cNvPicPr>
+          <p:nvPr/>
+        </p:nvPicPr>
+        <p:blipFill>
+          <a:blip r:embed="rId2"/>
+          <a:stretch>
+            <a:fillRect/>
+          </a:stretch>
+        </p:blipFill>
+        <p:spPr>
+          <a:xfrm>
+            <a:off x="6455344" y="1829468"/>
+            <a:ext cx="5294204" cy="3015242"/>
+          </a:xfrm>
+          <a:prstGeom prst="rect">
+            <a:avLst/>
+          </a:prstGeom>
+        </p:spPr>
+      </p:pic>
+    </p:spTree>
+    <p:extLst>
+      <p:ext uri="{BB962C8B-B14F-4D97-AF65-F5344CB8AC3E}">
+        <p14:creationId xmlns:p14="http://schemas.microsoft.com/office/powerpoint/2010/main" val="3695549552"/>
       </p:ext>
     </p:extLst>
   </p:cSld>

</xml_diff>